<commit_message>
Unify AgroVector business plan and pitch standards
</commit_message>
<xml_diff>
--- a/presentations/AGROVECTOR_22_SLIDES.pptx
+++ b/presentations/AGROVECTOR_22_SLIDES.pptx
@@ -129,473 +129,6 @@
 </file>
 
 <file path=ppt/charts/chart1.xml><?xml version="1.0" encoding="utf-8"?>
-<c:chartSpace xmlns:c="http://schemas.openxmlformats.org/drawingml/2006/chart" xmlns:a="http://schemas.openxmlformats.org/drawingml/2006/main" xmlns:r="http://schemas.openxmlformats.org/officeDocument/2006/relationships">
-  <c:date1904 val="0"/>
-  <c:style val="10"/>
-  <c:chart>
-    <c:autoTitleDeleted val="0"/>
-    <c:plotArea>
-      <c:lineChart>
-        <c:grouping val="standard"/>
-        <c:varyColors val="0"/>
-        <c:ser>
-          <c:idx val="0"/>
-          <c:order val="0"/>
-          <c:tx>
-            <c:strRef>
-              <c:f>Sheet1!$B$1</c:f>
-              <c:strCache>
-                <c:ptCount val="1"/>
-                <c:pt idx="0">
-                  <c:v>АгроВектор</c:v>
-                </c:pt>
-              </c:strCache>
-            </c:strRef>
-          </c:tx>
-          <c:spPr>
-            <a:solidFill>
-              <a:srgbClr val="164C38"/>
-            </a:solidFill>
-            <a:ln w="25400">
-              <a:solidFill>
-                <a:srgbClr val="164C38"/>
-              </a:solidFill>
-            </a:ln>
-          </c:spPr>
-          <c:marker>
-            <c:symbol val="none"/>
-          </c:marker>
-          <c:cat>
-            <c:strRef>
-              <c:f>Sheet1!$A$2:$A$8</c:f>
-              <c:strCache>
-                <c:ptCount val="7"/>
-                <c:pt idx="0">
-                  <c:v>Локальный
-объем</c:v>
-                </c:pt>
-                <c:pt idx="1">
-                  <c:v>Геометрия</c:v>
-                </c:pt>
-                <c:pt idx="2">
-                  <c:v>Связка
-с картой</c:v>
-                </c:pt>
-                <c:pt idx="3">
-                  <c:v>Отчет</c:v>
-                </c:pt>
-                <c:pt idx="4">
-                  <c:v>Без CAPEX
-клиента</c:v>
-                </c:pt>
-                <c:pt idx="5">
-                  <c:v>Доступность</c:v>
-                </c:pt>
-                <c:pt idx="6">
-                  <c:v>Широта
-технологий</c:v>
-                </c:pt>
-              </c:strCache>
-            </c:strRef>
-          </c:cat>
-          <c:val>
-            <c:numRef>
-              <c:f>Sheet1!$B$2:$B$8</c:f>
-              <c:numCache>
-                <c:formatCode>General</c:formatCode>
-                <c:ptCount val="7"/>
-                <c:pt idx="0">
-                  <c:v>5</c:v>
-                </c:pt>
-                <c:pt idx="1">
-                  <c:v>5</c:v>
-                </c:pt>
-                <c:pt idx="2">
-                  <c:v>5</c:v>
-                </c:pt>
-                <c:pt idx="3">
-                  <c:v>5</c:v>
-                </c:pt>
-                <c:pt idx="4">
-                  <c:v>5</c:v>
-                </c:pt>
-                <c:pt idx="5">
-                  <c:v>3</c:v>
-                </c:pt>
-                <c:pt idx="6">
-                  <c:v>3</c:v>
-                </c:pt>
-              </c:numCache>
-            </c:numRef>
-          </c:val>
-          <c:smooth val="0"/>
-        </c:ser>
-        <c:ser>
-          <c:idx val="1"/>
-          <c:order val="1"/>
-          <c:tx>
-            <c:strRef>
-              <c:f>Sheet1!$C$1</c:f>
-              <c:strCache>
-                <c:ptCount val="1"/>
-                <c:pt idx="0">
-                  <c:v>Наземный подрядчик</c:v>
-                </c:pt>
-              </c:strCache>
-            </c:strRef>
-          </c:tx>
-          <c:spPr>
-            <a:solidFill>
-              <a:srgbClr val="7EB94A"/>
-            </a:solidFill>
-            <a:ln w="25400">
-              <a:solidFill>
-                <a:srgbClr val="7EB94A"/>
-              </a:solidFill>
-            </a:ln>
-          </c:spPr>
-          <c:marker>
-            <c:symbol val="none"/>
-          </c:marker>
-          <c:cat>
-            <c:strRef>
-              <c:f>Sheet1!$A$2:$A$8</c:f>
-              <c:strCache>
-                <c:ptCount val="7"/>
-                <c:pt idx="0">
-                  <c:v>Локальный
-объем</c:v>
-                </c:pt>
-                <c:pt idx="1">
-                  <c:v>Геометрия</c:v>
-                </c:pt>
-                <c:pt idx="2">
-                  <c:v>Связка
-с картой</c:v>
-                </c:pt>
-                <c:pt idx="3">
-                  <c:v>Отчет</c:v>
-                </c:pt>
-                <c:pt idx="4">
-                  <c:v>Без CAPEX
-клиента</c:v>
-                </c:pt>
-                <c:pt idx="5">
-                  <c:v>Доступность</c:v>
-                </c:pt>
-                <c:pt idx="6">
-                  <c:v>Широта
-технологий</c:v>
-                </c:pt>
-              </c:strCache>
-            </c:strRef>
-          </c:cat>
-          <c:val>
-            <c:numRef>
-              <c:f>Sheet1!$C$2:$C$8</c:f>
-              <c:numCache>
-                <c:formatCode>General</c:formatCode>
-                <c:ptCount val="7"/>
-                <c:pt idx="0">
-                  <c:v>2</c:v>
-                </c:pt>
-                <c:pt idx="1">
-                  <c:v>2</c:v>
-                </c:pt>
-                <c:pt idx="2">
-                  <c:v>2</c:v>
-                </c:pt>
-                <c:pt idx="3">
-                  <c:v>3</c:v>
-                </c:pt>
-                <c:pt idx="4">
-                  <c:v>5</c:v>
-                </c:pt>
-                <c:pt idx="5">
-                  <c:v>3</c:v>
-                </c:pt>
-                <c:pt idx="6">
-                  <c:v>4</c:v>
-                </c:pt>
-              </c:numCache>
-            </c:numRef>
-          </c:val>
-          <c:smooth val="0"/>
-        </c:ser>
-        <c:ser>
-          <c:idx val="2"/>
-          <c:order val="2"/>
-          <c:tx>
-            <c:strRef>
-              <c:f>Sheet1!$D$1</c:f>
-              <c:strCache>
-                <c:ptCount val="1"/>
-                <c:pt idx="0">
-                  <c:v>Своя техника</c:v>
-                </c:pt>
-              </c:strCache>
-            </c:strRef>
-          </c:tx>
-          <c:spPr>
-            <a:solidFill>
-              <a:srgbClr val="739DAB"/>
-            </a:solidFill>
-            <a:ln w="25400">
-              <a:solidFill>
-                <a:srgbClr val="739DAB"/>
-              </a:solidFill>
-            </a:ln>
-          </c:spPr>
-          <c:marker>
-            <c:symbol val="none"/>
-          </c:marker>
-          <c:cat>
-            <c:strRef>
-              <c:f>Sheet1!$A$2:$A$8</c:f>
-              <c:strCache>
-                <c:ptCount val="7"/>
-                <c:pt idx="0">
-                  <c:v>Локальный
-объем</c:v>
-                </c:pt>
-                <c:pt idx="1">
-                  <c:v>Геометрия</c:v>
-                </c:pt>
-                <c:pt idx="2">
-                  <c:v>Связка
-с картой</c:v>
-                </c:pt>
-                <c:pt idx="3">
-                  <c:v>Отчет</c:v>
-                </c:pt>
-                <c:pt idx="4">
-                  <c:v>Без CAPEX
-клиента</c:v>
-                </c:pt>
-                <c:pt idx="5">
-                  <c:v>Доступность</c:v>
-                </c:pt>
-                <c:pt idx="6">
-                  <c:v>Широта
-технологий</c:v>
-                </c:pt>
-              </c:strCache>
-            </c:strRef>
-          </c:cat>
-          <c:val>
-            <c:numRef>
-              <c:f>Sheet1!$D$2:$D$8</c:f>
-              <c:numCache>
-                <c:formatCode>General</c:formatCode>
-                <c:ptCount val="7"/>
-                <c:pt idx="0">
-                  <c:v>3</c:v>
-                </c:pt>
-                <c:pt idx="1">
-                  <c:v>3</c:v>
-                </c:pt>
-                <c:pt idx="2">
-                  <c:v>3</c:v>
-                </c:pt>
-                <c:pt idx="3">
-                  <c:v>3</c:v>
-                </c:pt>
-                <c:pt idx="4">
-                  <c:v>1</c:v>
-                </c:pt>
-                <c:pt idx="5">
-                  <c:v>5</c:v>
-                </c:pt>
-                <c:pt idx="6">
-                  <c:v>4</c:v>
-                </c:pt>
-              </c:numCache>
-            </c:numRef>
-          </c:val>
-          <c:smooth val="0"/>
-        </c:ser>
-        <c:ser>
-          <c:idx val="3"/>
-          <c:order val="3"/>
-          <c:tx>
-            <c:strRef>
-              <c:f>Sheet1!$E$1</c:f>
-              <c:strCache>
-                <c:ptCount val="1"/>
-                <c:pt idx="0">
-                  <c:v>Узкий БПЛА-подрядчик</c:v>
-                </c:pt>
-              </c:strCache>
-            </c:strRef>
-          </c:tx>
-          <c:spPr>
-            <a:solidFill>
-              <a:srgbClr val="BC9255"/>
-            </a:solidFill>
-            <a:ln w="25400">
-              <a:solidFill>
-                <a:srgbClr val="BC9255"/>
-              </a:solidFill>
-            </a:ln>
-          </c:spPr>
-          <c:marker>
-            <c:symbol val="none"/>
-          </c:marker>
-          <c:cat>
-            <c:strRef>
-              <c:f>Sheet1!$A$2:$A$8</c:f>
-              <c:strCache>
-                <c:ptCount val="7"/>
-                <c:pt idx="0">
-                  <c:v>Локальный
-объем</c:v>
-                </c:pt>
-                <c:pt idx="1">
-                  <c:v>Геометрия</c:v>
-                </c:pt>
-                <c:pt idx="2">
-                  <c:v>Связка
-с картой</c:v>
-                </c:pt>
-                <c:pt idx="3">
-                  <c:v>Отчет</c:v>
-                </c:pt>
-                <c:pt idx="4">
-                  <c:v>Без CAPEX
-клиента</c:v>
-                </c:pt>
-                <c:pt idx="5">
-                  <c:v>Доступность</c:v>
-                </c:pt>
-                <c:pt idx="6">
-                  <c:v>Широта
-технологий</c:v>
-                </c:pt>
-              </c:strCache>
-            </c:strRef>
-          </c:cat>
-          <c:val>
-            <c:numRef>
-              <c:f>Sheet1!$E$2:$E$8</c:f>
-              <c:numCache>
-                <c:formatCode>General</c:formatCode>
-                <c:ptCount val="7"/>
-                <c:pt idx="0">
-                  <c:v>4</c:v>
-                </c:pt>
-                <c:pt idx="1">
-                  <c:v>4</c:v>
-                </c:pt>
-                <c:pt idx="2">
-                  <c:v>3</c:v>
-                </c:pt>
-                <c:pt idx="3">
-                  <c:v>3</c:v>
-                </c:pt>
-                <c:pt idx="4">
-                  <c:v>5</c:v>
-                </c:pt>
-                <c:pt idx="5">
-                  <c:v>3</c:v>
-                </c:pt>
-                <c:pt idx="6">
-                  <c:v>3</c:v>
-                </c:pt>
-              </c:numCache>
-            </c:numRef>
-          </c:val>
-          <c:smooth val="0"/>
-        </c:ser>
-        <c:marker val="1"/>
-        <c:smooth val="0"/>
-        <c:axId val="2118791784"/>
-        <c:axId val="2140495176"/>
-      </c:lineChart>
-      <c:catAx>
-        <c:axId val="2118791784"/>
-        <c:scaling>
-          <c:orientation val="minMax"/>
-        </c:scaling>
-        <c:delete val="0"/>
-        <c:axPos val="b"/>
-        <c:majorTickMark val="out"/>
-        <c:minorTickMark val="none"/>
-        <c:tickLblPos val="nextTo"/>
-        <c:txPr>
-          <a:bodyPr/>
-          <a:lstStyle/>
-          <a:p>
-            <a:pPr>
-              <a:defRPr sz="1500"/>
-            </a:pPr>
-          </a:p>
-        </c:txPr>
-        <c:crossAx val="2140495176"/>
-        <c:crosses val="autoZero"/>
-        <c:auto val="1"/>
-        <c:lblAlgn val="ctr"/>
-        <c:lblOffset val="100"/>
-        <c:noMultiLvlLbl val="0"/>
-      </c:catAx>
-      <c:valAx>
-        <c:axId val="2140495176"/>
-        <c:scaling/>
-        <c:delete val="0"/>
-        <c:axPos val="l"/>
-        <c:majorGridlines/>
-        <c:majorTickMark val="out"/>
-        <c:minorTickMark val="none"/>
-        <c:tickLblPos val="nextTo"/>
-        <c:txPr>
-          <a:bodyPr/>
-          <a:lstStyle/>
-          <a:p>
-            <a:pPr>
-              <a:defRPr sz="1500"/>
-            </a:pPr>
-          </a:p>
-        </c:txPr>
-        <c:crossAx val="2118791784"/>
-        <c:crosses val="autoZero"/>
-      </c:valAx>
-    </c:plotArea>
-    <c:legend>
-      <c:legendPos val="b"/>
-      <c:layout/>
-      <c:overlay val="0"/>
-      <c:txPr>
-        <a:bodyPr/>
-        <a:lstStyle/>
-        <a:p>
-          <a:pPr>
-            <a:defRPr sz="1500"/>
-          </a:pPr>
-        </a:p>
-      </c:txPr>
-    </c:legend>
-    <c:plotVisOnly val="1"/>
-    <c:dispBlanksAs val="gap"/>
-    <c:showDLblsOverMax val="0"/>
-  </c:chart>
-  <c:txPr>
-    <a:bodyPr/>
-    <a:lstStyle/>
-    <a:p>
-      <a:pPr>
-        <a:defRPr sz="1500">
-          <a:latin typeface="Arial"/>
-        </a:defRPr>
-      </a:pPr>
-      <a:endParaRPr lang="en-US"/>
-    </a:p>
-  </c:txPr>
-  <c:externalData r:id="rId1">
-    <c:autoUpdate val="0"/>
-  </c:externalData>
-</c:chartSpace>
-</file>
-
-<file path=ppt/charts/chart2.xml><?xml version="1.0" encoding="utf-8"?>
 <c:chartSpace xmlns:c="http://schemas.openxmlformats.org/drawingml/2006/chart" xmlns:a="http://schemas.openxmlformats.org/drawingml/2006/main" xmlns:r="http://schemas.openxmlformats.org/officeDocument/2006/relationships">
   <c:date1904 val="0"/>
   <c:style val="10"/>
@@ -905,7 +438,7 @@
 </c:chartSpace>
 </file>
 
-<file path=ppt/charts/chart3.xml><?xml version="1.0" encoding="utf-8"?>
+<file path=ppt/charts/chart2.xml><?xml version="1.0" encoding="utf-8"?>
 <c:chartSpace xmlns:c="http://schemas.openxmlformats.org/drawingml/2006/chart" xmlns:a="http://schemas.openxmlformats.org/drawingml/2006/main" xmlns:r="http://schemas.openxmlformats.org/officeDocument/2006/relationships">
   <c:date1904 val="0"/>
   <c:style val="10"/>
@@ -1503,7 +1036,7 @@
           </a:p>
           <a:p>
             <a:r>
-              <a:t>| Выручка 2027 / EBITDA2027 | 8 800 000 / 1 960 000 руб. |</a:t>
+              <a:t>| Выручка 2027 / EBITDA 2027 | 8 800 000 / 1 960 000 руб. |</a:t>
             </a:r>
           </a:p>
           <a:p>
@@ -1809,7 +1342,13 @@
           <a:p/>
           <a:p>
             <a:r>
-              <a:t>[РАСЧЕТ] Проверка совместной мощности:22×7=154 календарных дня; внесение 13000/130=100 дней, мониторинг 10000/500=20 дней, резерв 34 дня. [ДОПУЩЕНИЕ] Производительность мониторинга 500 га/день и 120 полевых дней — напряженный потолок, а не гарантия; работы выполняются последовательно, выходные и нормы отдыха соблюдаются. Полевой пилот 100 га в апреле включен в 6000 га-проходов первого сезона. При невозможности подтвердить такой календарь объемыY4–Y5 снижаются.</a:t>
+              <a:t>[РАСЧЕТ] Проверка совместной мощности:22×7=154 календарных дня; внесение 13000/130=100 дней, мониторинг 10000/500=20 дней, резерв 34 дня. [ДОПУЩЕНИЕ] Производительность мониторинга 500 га/день и 120 полевых дней — напряженный потолок, а не гарантия; работы выполняются последовательно, выходные и нормы отдыха соблюдаются. Полевой пилот 100 га в апреле включен в 6000 га-проходов первого сезона. При невозможности подтвердить такой календарь объемыY 4–Y 5 снижаются.</a:t>
+            </a:r>
+          </a:p>
+          <a:p/>
+          <a:p>
+            <a:r>
+              <a:t>[ДОПУЩЕНИЕ] Базовые 4 млн руб. на основной и резервный аппараты внесения не подтверждены КП. Ориентир пары XAG P 100 Pro — 5,98 млн руб.; закупочный стресс требует 11,48 млн руб. финансирования. Проверка комплектации и производительности обязательна; подробности в разделе 17.</a:t>
             </a:r>
           </a:p>
           <a:p/>
@@ -2296,67 +1835,67 @@
           </a:p>
           <a:p>
             <a:r>
-              <a:t>    A Проверка региона, полетов и схемы АХР :crit, A, 2026-09-07, 28d</a:t>
-            </a:r>
-          </a:p>
-          <a:p>
-            <a:r>
-              <a:t>    B Интервью и предварительные заявки хозяйств :B, 2026-09-07, 35d</a:t>
-            </a:r>
-          </a:p>
-          <a:p>
-            <a:r>
-              <a:t>    C ООО, договоры, учет и страховой проект :crit, C, 2026-10-05, 21d</a:t>
-            </a:r>
-          </a:p>
-          <a:p>
-            <a:r>
-              <a:t>    D Инвестиционное решение и финансирование :crit, D, 2026-10-26, 7d</a:t>
-            </a:r>
-          </a:p>
-          <a:p>
-            <a:r>
-              <a:t>    E Закупка и приемка оборудования :crit, E, 2026-11-02, 35d</a:t>
-            </a:r>
-          </a:p>
-          <a:p>
-            <a:r>
-              <a:t>    F Подбор и гражданская переподготовка :F, 2026-11-02, 42d</a:t>
-            </a:r>
-          </a:p>
-          <a:p>
-            <a:r>
-              <a:t>    G Разрешительная готовность и учет БВС :crit, G, 2026-12-07, 42d</a:t>
-            </a:r>
-          </a:p>
-          <a:p>
-            <a:r>
-              <a:t>    H SOP, CRM, карты и контроль качества :H, 2026-12-14, 21d</a:t>
-            </a:r>
-          </a:p>
-          <a:p>
-            <a:r>
-              <a:t>    I Стендовые и контролируемые приемочные испытания :crit, I, 2027-01-18, 14d</a:t>
-            </a:r>
-          </a:p>
-          <a:p>
-            <a:r>
-              <a:t>    J Сезонные договоры и маршрутизация :crit, J, 2027-02-01, 14d</a:t>
-            </a:r>
-          </a:p>
-          <a:p>
-            <a:r>
-              <a:t>    M Предсезонная готовность и ожидание погодного окна :crit, M, 2027-02-15, 56d</a:t>
-            </a:r>
-          </a:p>
-          <a:p>
-            <a:r>
-              <a:t>    K Первый коммерческий сезон :crit, K, 2027-04-12, 154d</a:t>
-            </a:r>
-          </a:p>
-          <a:p>
-            <a:r>
-              <a:t>    L Аудит сезона и решение о продолжении :crit, L, 2027-09-13, 14d</a:t>
+              <a:t>    A Проверка региона, полетов и схемы АХР :crit, A, 2026-09-07, 28 d</a:t>
+            </a:r>
+          </a:p>
+          <a:p>
+            <a:r>
+              <a:t>    B Интервью и предварительные заявки хозяйств :B, 2026-09-07, 35 d</a:t>
+            </a:r>
+          </a:p>
+          <a:p>
+            <a:r>
+              <a:t>    C ООО, договоры, учет и страховой проект :crit, C, 2026-10-05, 21 d</a:t>
+            </a:r>
+          </a:p>
+          <a:p>
+            <a:r>
+              <a:t>    D Инвестиционное решение и финансирование :crit, D, 2026-10-26, 7 d</a:t>
+            </a:r>
+          </a:p>
+          <a:p>
+            <a:r>
+              <a:t>    E Закупка и приемка оборудования :crit, E, 2026-11-02, 35 d</a:t>
+            </a:r>
+          </a:p>
+          <a:p>
+            <a:r>
+              <a:t>    F Подбор и гражданская переподготовка :F, 2026-11-02, 42 d</a:t>
+            </a:r>
+          </a:p>
+          <a:p>
+            <a:r>
+              <a:t>    G Разрешительная готовность и учет БВС :crit, G, 2026-12-07, 42 d</a:t>
+            </a:r>
+          </a:p>
+          <a:p>
+            <a:r>
+              <a:t>    H SOP, CRM, карты и контроль качества :H, 2026-12-14, 21 d</a:t>
+            </a:r>
+          </a:p>
+          <a:p>
+            <a:r>
+              <a:t>    I Стендовые и контролируемые приемочные испытания :crit, I, 2027-01-18, 14 d</a:t>
+            </a:r>
+          </a:p>
+          <a:p>
+            <a:r>
+              <a:t>    J Сезонные договоры и маршрутизация :crit, J, 2027-02-01, 14 d</a:t>
+            </a:r>
+          </a:p>
+          <a:p>
+            <a:r>
+              <a:t>    M Предсезонная готовность и ожидание погодного окна :crit, M, 2027-02-15, 56 d</a:t>
+            </a:r>
+          </a:p>
+          <a:p>
+            <a:r>
+              <a:t>    K Первый коммерческий сезон :crit, K, 2027-04-12, 154 d</a:t>
+            </a:r>
+          </a:p>
+          <a:p>
+            <a:r>
+              <a:t>    L Аудит сезона и решение о продолжении :crit, L, 2027-09-13, 14 d</a:t>
             </a:r>
           </a:p>
           <a:p>
@@ -3067,7 +2606,7 @@
           <a:p/>
           <a:p>
             <a:r>
-              <a:t>[ДОПУЩЕНИЕ] CAPEX7 млн: два аппарата внесения с АКБ/зарядкой 4 млн; авто и прицеп 1,4 млн; мониторинговый аппарат 0,6 млн; смешивание и безопасность 0,4 млн; IT0,2 млн; капитальный запас заменяемых узлов 0,4 млн. Последний не является запасом расходных химикатов. Конкретные модели выбираются после проверки максимальной взлетной массы и законной эксплуатации; бюджет не равен подтвержденному предложению поставщика.</a:t>
+              <a:t>[ДОПУЩЕНИЕ] CAPEX 7 млн: два аппарата внесения с АКБ/зарядкой 4 млн; авто и прицеп 1,4 млн; мониторинговый аппарат 0,6 млн; смешивание и безопасность 0,4 млн; IT 0,2 млн; капитальный запас заменяемых узлов 0,4 млн. Последний не является запасом расходных химикатов. Конкретные модели выбираются после проверки максимальной взлетной массы и законной эксплуатации; бюджет не равен подтвержденному предложению поставщика.</a:t>
             </a:r>
           </a:p>
           <a:p/>
@@ -3079,7 +2618,7 @@
           <a:p/>
           <a:p>
             <a:r>
-              <a:t>[ДОПУЩЕНИЕ] Постоянный OPEX2027 — 4,2 млнруб.: штат с начислениями 3 млн; аренда 360 тыс.; страхование/комплаенс 300 тыс. (страхование 120, юрист 60, внешний агроном 120); маркетинг 240 тыс.; IT120 тыс.; администрирование 180 тыс. (бухгалтер 120, банк/прочее 60). Бюджеты внешних специалистов и труда экономные; подтверждение их достаточности является инвестиционным gate. Стартовые 500 тыс. распределены на первоначальное обучение 200, подготовку правового/операционного досье 200 и организационные расходы 100; ежегодное сопровождение не дублирует эти разовые работы.</a:t>
+              <a:t>[ДОПУЩЕНИЕ] Постоянный OPEX 2027 — 4,2 млнруб.: штат с начислениями 3 млн; аренда 360 тыс.; страхование/комплаенс 300 тыс. (страхование 120, юрист 60, внешний агроном 120); маркетинг 240 тыс.; IT 120 тыс.; администрирование 180 тыс. (бухгалтер 120, банк/прочее 60). Бюджеты внешних специалистов и труда экономные; подтверждение их достаточности является инвестиционным gate. Стартовые 500 тыс. распределены на первоначальное обучение 200, подготовку правового/операционного досье 200 и организационные расходы 100; ежегодное сопровождение не дублирует эти разовые работы.</a:t>
             </a:r>
           </a:p>
           <a:p/>
@@ -3202,7 +2741,7 @@
           <a:p/>
           <a:p>
             <a:r>
-              <a:t>[ДОПУЩЕНИЕ] Поступления и выполнение распределены апрель–сентябрь 10/20/25/20/15/10%. Услуги оплачиваются в месяц выполнения; плановый договорный аванс 30% не используется для улучшения модели. Фиксированные расходы 350000 руб./месяц. Подготовительные расходы 2026 свернуты в t0; годовая модель оценивается на условную дату 31.12.2026, не заменяет календарь траншей осени 2026.</a:t>
+              <a:t>[ДОПУЩЕНИЕ] Поступления и выполнение распределены апрель–сентябрь 10/20/25/20/15/10%. Услуги оплачиваются в месяц выполнения; плановый договорный аванс 30% не используется для улучшения модели. Фиксированные расходы 350000 руб./месяц. Подготовительные расходы 2026 свернуты в t 0; годовая модель оценивается на условную дату 31.12.2026, не заменяет календарь траншей осени 2026.</a:t>
             </a:r>
           </a:p>
           <a:p/>
@@ -3214,7 +2753,37 @@
           <a:p/>
           <a:p>
             <a:r>
-              <a:t>[ДОПУЩЕНИЕ] Резерв 2 млн учитывается только в t0 и возвращается в конце 2031 при завершении оценочного проекта. Рост дебиторской задолженности не смоделирован; резерв не индексируется. Для продолжающегося бизнеса его возврат исключается. Инвестиционный NPV не является суммой дивидендов инвестору.</a:t>
+              <a:t>[ДОПУЩЕНИЕ] Резерв 2 млн учитывается только в t 0 и возвращается в конце 2031 при завершении оценочного проекта. Рост дебиторской задолженности не смоделирован; резерв не индексируется. Для продолжающегося бизнеса его возврат исключается. Инвестиционный NPV не является суммой дивидендов инвестору.</a:t>
+            </a:r>
+          </a:p>
+          <a:p/>
+          <a:p>
+            <a:r>
+              <a:t>### Проверка закупочного бюджета</a:t>
+            </a:r>
+          </a:p>
+          <a:p/>
+          <a:p>
+            <a:r>
+              <a:t>[ДОПУЩЕНИЕ] Базовые 4 млн руб. на два аппарата внесения — закупочный лимит без выбранной модели, не подтвержденная цена. Производительность 130 га/день подтверждается приемочным испытанием выбранного комплекта, а не характеристиками другой модели.</a:t>
+            </a:r>
+          </a:p>
+          <a:p/>
+          <a:p>
+            <a:r>
+              <a:t>[ФАКТ] На 06.10.2026 Агропрофи публикует XAG P 100 Pro за 2 990 000 руб. за комплект: https://xag-ap.ru/ . Состав, налоги, доставка и условия требуют письменного КП. Это ориентир, не договор или решение о выборе модели.</a:t>
+            </a:r>
+          </a:p>
+          <a:p/>
+          <a:p>
+            <a:r>
+              <a:t>[РАСЧЕТ] Два комплекта стоят 5 980 000 руб., превышение базового лимита — 1 980 000 руб. При прочих равных CAPEX — 8 980 000 руб., финансирование — 11 480 000 руб., NPV — 1 966 443 руб. Это изолированный тест удорожания закупки, не новая полноценная база. Обучение и сопровождение в комплекте нужно исключить из повторного счета после получения КП.</a:t>
+            </a:r>
+          </a:p>
+          <a:p/>
+          <a:p>
+            <a:r>
+              <a:t>[ДОПУЩЕНИЕ] До инвестирования нужны два сопоставимых КП с АКБ, зарядкой, доставкой, обучением, сервисом и налогами. Необходимо либо подтвердить комплект в лимите 4 млн руб. с нужной выработкой, либо пересчитать модель, финансирование и сроки целиком. Без этого закупочный этап не утверждается.</a:t>
             </a:r>
           </a:p>
           <a:p/>
@@ -3295,7 +2864,7 @@
           <a:lstStyle/>
           <a:p>
             <a:r>
-              <a:t>[ДОПУЩЕНИЕ] Ставка дисконтирования 24% — требуемая доходность проектного капитала, не рыночная котировка WACC; финансирование долевое. Потоки номинальные, конец каждого года, t0=-9500000 руб. Ликвидационная стоимость оборудования 0; возврат оборотного резерва 2 млн только в концеY5.</a:t>
+              <a:t>[ДОПУЩЕНИЕ] Ставка дисконтирования 24% — требуемая доходность проектного капитала, не рыночная котировка WACC; финансирование долевое. Потоки номинальные, конец каждого года, t 0=-9500000 руб. Ликвидационная стоимость оборудования 0; возврат оборотного резерва 2 млн только в концеY 5.</a:t>
             </a:r>
           </a:p>
           <a:p/>
@@ -3407,7 +2976,7 @@
           <a:p/>
           <a:p>
             <a:r>
-              <a:t>[РАСЧЕТ] Снижение тарифа на 10% почти обнуляет NPV; дисконтированная окупаемость этого стресса наступает только в концеY5 с возвратом резерва. При недозагрузке 25% либо годовой задержке дисконтированная окупаемость за 5 лет не достигается. Основное условие вложения капитала — проверка готовности клиентов оплачивать именно плановый тариф.</a:t>
+              <a:t>[РАСЧЕТ] Снижение тарифа на 10% почти обнуляет NPV; дисконтированная окупаемость этого стресса наступает только в концеY 5 с возвратом резерва. При недозагрузке 25% либо годовой задержке дисконтированная окупаемость за 5 лет не достигается. Основное условие вложения капитала — проверка готовности клиентов оплачивать именно плановый тариф.</a:t>
             </a:r>
           </a:p>
           <a:p/>
@@ -3531,6 +3100,12 @@
           <a:p/>
           <a:p>
             <a:r>
+              <a:t>[ДОПУЩЕНИЕ] Базовые 4 млн руб. на основной и резервный аппараты внесения не подтверждены КП. Ориентир пары XAG P 100 Pro — 5,98 млн руб.; закупочный стресс требует 11,48 млн руб. финансирования. Проверка комплектации и производительности обязательна; подробности в разделе 17.</a:t>
+            </a:r>
+          </a:p>
+          <a:p/>
+          <a:p>
+            <a:r>
               <a:t>Комментарий к слайду:</a:t>
             </a:r>
           </a:p>
@@ -3606,54 +3181,54 @@
           <a:lstStyle/>
           <a:p>
             <a:r>
-              <a:t>[ДОПУЩЕНИЕ] Цель «АгроВектора» — подготовить к весне 2027 года юридически допустимый сервис агромониторинга и точечного внесения, проверить платежеспособный спрос и провести первый сезон без расширения команды сверх подтвержденной загрузки. Татарстан и радиус обслуживания до 150 км рассматриваются условно: окончательная территория определяется после юридической проверки конкретных работ и маршрутов.</a:t>
+              <a:t>[ДОПУЩЕНИЕ] SMART-цели первого сезона. Даты являются контрольным планом, а не подтверждением выполненных работ. При пропуске правовой или закупочной контрольной точки календарь пересматривается до финансирования.</a:t>
             </a:r>
           </a:p>
           <a:p/>
           <a:p>
             <a:r>
-              <a:t>| SMART-цель | Измеримый результат | Срок и подтверждение |</a:t>
-            </a:r>
-          </a:p>
-          <a:p>
-            <a:r>
-              <a:t>|---|---|---|</a:t>
-            </a:r>
-          </a:p>
-          <a:p>
-            <a:r>
-              <a:t>| Проверить применимость модели | Письменная карта разрешений, ограничений и оснований отказа | До go/no-go в 2026 году; заключение юриста |</a:t>
-            </a:r>
-          </a:p>
-          <a:p>
-            <a:r>
-              <a:t>| Подтвердить спрос | 20 интервью; предварительные заявки на 6000 га-проходов | До финансирования; реестр контактов и заявок |</a:t>
-            </a:r>
-          </a:p>
-          <a:p>
-            <a:r>
-              <a:t>| Сформировать портфель | 10 клиентов со средним объемом 600 га-проходов | До старта сезона; договоры и согласованные окна |</a:t>
-            </a:r>
-          </a:p>
-          <a:p>
-            <a:r>
-              <a:t>| Обеспечить готовность | Техника принята, два оператора обучены, регламенты проверены | До 12 апреля 2027 года; акты, проверка компетенций, разрешительная готовность |</a:t>
-            </a:r>
-          </a:p>
-          <a:p>
-            <a:r>
-              <a:t>| Выполнить первый сезон | 6000 га-проходов внесения и 4000 га-обследований | Сезон 2027 года; подписанные акты и журналы |</a:t>
-            </a:r>
-          </a:p>
-          <a:p>
-            <a:r>
-              <a:t>| Проверить социальную модель | Открытый добровольный отбор, индивидуальное обучение и наставничество | К началу работ; документированная оценка каждого кандидата |</a:t>
+              <a:t>| Цель | Измеримый результат | Срок | Ответственный и доказательство |</a:t>
+            </a:r>
+          </a:p>
+          <a:p>
+            <a:r>
+              <a:t>| --- | --- | --- | --- |</a:t>
+            </a:r>
+          </a:p>
+          <a:p>
+            <a:r>
+              <a:t>| Правовая применимость | Карта требований по всем выбранным полям; решение GO/NO-GO | 31.10.2026 | Директор; письменное заключение юриста |</a:t>
+            </a:r>
+          </a:p>
+          <a:p>
+            <a:r>
+              <a:t>| Подтверждение спроса | 20 интервью; заявки на 6 000 га-проходов и 4 000 га-обследований | 30.11.2026 | Директор; реестр полей и заявок, без объявления их продажами |</a:t>
+            </a:r>
+          </a:p>
+          <a:p>
+            <a:r>
+              <a:t>| Коммерческий портфель | 10 клиентов; суммарно 6 000 га-проходов и 4 000 га-обследований | 11.04.2027 | Директор; подписанные договоры и календарь |</a:t>
+            </a:r>
+          </a:p>
+          <a:p>
+            <a:r>
+              <a:t>| Техническая готовность | Приняты 3 аппарата; 2 оператора прошли оценку; пилот 100 га внутри сезонного объема | 30.04.2027 | Операционный руководитель; до 11.04 — приемка и допуски, в апреле — акт пилота |</a:t>
+            </a:r>
+          </a:p>
+          <a:p>
+            <a:r>
+              <a:t>| Первый сезон | 6 000 га-проходов, 4 000 га-обследований; выручка 8,8 млн руб. без НДС | 12.09.2027 | Директор; акты, журнал операций, бухгалтерский учет |</a:t>
+            </a:r>
+          </a:p>
+          <a:p>
+            <a:r>
+              <a:t>| Гражданская подготовка | 2 оператора: индивидуальный план, наставник и оценка; контроль занятости через 3 месяца | 11.04.2027; контроль 12.07.2027 | Операционный руководитель; протоколы обучения и кадровый учет |</a:t>
             </a:r>
           </a:p>
           <a:p/>
           <a:p>
             <a:r>
-              <a:t>[ДОПУЩЕНИЕ] Показатель безопасности — отсутствие работ без необходимой готовности и обязательная регистрация опасных событий, включая предотвращенные. Для социальной программы не устанавливается квота, способная подменить профессиональный отбор. Успешность оценивается по освоению гражданских компетенций и устойчивости занятости, а не по биографическому статусу. Коммерческие цели не отменяют право остановить небезопасную работу.</a:t>
+              <a:t>Обучение добровольное; квоты по биографическому статусу нет. Самостоятельные работы допускаются только после оценки компетенций. Безопасность: 100% заданий проходят проверку готовности; все опасные события регистрируются. Цель — ноль работ без необходимых допусков, а не обещание отсутствия любого инцидента.</a:t>
             </a:r>
           </a:p>
           <a:p/>
@@ -3664,7 +3239,7 @@
           </a:p>
           <a:p>
             <a:r>
-              <a:t>Редактируемые объекты. Финансовые показатели — расчет модели, входные данные — допущения; проект не является действующим подтвержденным бизнесом.</a:t>
+              <a:t>Объемы на слайде: внесение / мониторинг. Полные цели и критерии — в разделе 2. Готовность до 11.04; пилот в апреле входит в сезонный объем.</a:t>
             </a:r>
           </a:p>
         </p:txBody>
@@ -3878,7 +3453,7 @@
           </a:p>
           <a:p>
             <a:r>
-              <a:t>| Бригады / штат | 1 /3FTE | 1 /3FTE |</a:t>
+              <a:t>| Бригады / штат | 1 /3 FTE | 1 /3 FTE |</a:t>
             </a:r>
           </a:p>
           <a:p>
@@ -4282,59 +3857,108 @@
           <a:p/>
           <a:p>
             <a:r>
-              <a:t>[ДОПУЩЕНИЕ] Стратегическая канва ниже — гипотеза позиционирования, не исследование конкретных конкурентов. Шкала 1–5 означает предполагаемую выраженность полезного клиенту свойства; оценки требуют проверки интервью и коммерческими предложениями. Сравниваются четыре альтернативы решения одной задачи.</a:t>
+              <a:t>### Сравнение с конкретными конкурентами</a:t>
             </a:r>
           </a:p>
           <a:p/>
           <a:p>
             <a:r>
-              <a:t>| Критерий | АгроВектор | Наземный подрядчик | Собственная техника хозяйства | Узкий подрядчик БПЛА |</a:t>
-            </a:r>
-          </a:p>
-          <a:p>
-            <a:r>
-              <a:t>|---|---:|---:|---:|---:|</a:t>
-            </a:r>
-          </a:p>
-          <a:p>
-            <a:r>
-              <a:t>| Удобство заказа небольшого локального объема | 5 | 2 | 3 | 4 |</a:t>
-            </a:r>
-          </a:p>
-          <a:p>
-            <a:r>
-              <a:t>| Работа со сложной геометрией участка | 5 | 2 | 3 | 4 |</a:t>
-            </a:r>
-          </a:p>
-          <a:p>
-            <a:r>
-              <a:t>| Связка обследования и задания | 5 | 2 | 3 | 3 |</a:t>
-            </a:r>
-          </a:p>
-          <a:p>
-            <a:r>
-              <a:t>| Прослеживаемый отчет | 5 | 3 | 3 | 3 |</a:t>
-            </a:r>
-          </a:p>
-          <a:p>
-            <a:r>
-              <a:t>| Отсутствие капитальных вложений клиента | 5 | 5 | 1 | 5 |</a:t>
-            </a:r>
-          </a:p>
-          <a:p>
-            <a:r>
-              <a:t>| Управляемость сезонной доступности | 3 | 3 | 5 | 3 |</a:t>
-            </a:r>
-          </a:p>
-          <a:p>
-            <a:r>
-              <a:t>| Широта применимых технологий | 3 | 4 | 4 | 3 |</a:t>
+              <a:t>Дата проверки открытых предложений: 06.10.2026. АгроВектор находится до запуска. Сравнение отражает наличие предложения, а не доказанное превосходство по качеству. Агропрофи — региональный конкурент; Агродроны ЮФО и Гермес — межрегиональные ориентиры, работа в Татарстане ими здесь не подтверждается.</a:t>
             </a:r>
           </a:p>
           <a:p/>
           <a:p>
             <a:r>
-              <a:t>[ДОПУЩЕНИЕ] Канва не подтверждает абсолютного превосходства: у проектного сервиса ограничены сезонная доступность и технологическая универсальность. Поэтому обещание клиенту строится вокруг подходящего задания и проверяемого результата, а не вокруг замены всех наземных операций.</a:t>
+              <a:t>| Фактор ценности | АгроВектор | ГК Агропрофи / XAG | Агродроны ЮФО | Гермес |</a:t>
+            </a:r>
+          </a:p>
+          <a:p>
+            <a:r>
+              <a:t>|---|---|---|---|---|</a:t>
+            </a:r>
+          </a:p>
+          <a:p>
+            <a:r>
+              <a:t>| Услуга внесения | Запланирована | Предлагается [3][4] | Предлагается [7] | Предлагается [6] |</a:t>
+            </a:r>
+          </a:p>
+          <a:p>
+            <a:r>
+              <a:t>| Мониторинг и картирование | Запланированы | Средства мониторинга заявлены; состав услуги уточняется [3] | Отдельная услуга не подтверждена | Мониторинг и карты заявлены [6] |</a:t>
+            </a:r>
+          </a:p>
+          <a:p>
+            <a:r>
+              <a:t>| Обслуживание Татарстана | План после проверки участков | Татарстан заявлен [3] | Заявлен ЮФО [7] | Краснодарский край и Адыгея [6] |</a:t>
+            </a:r>
+          </a:p>
+          <a:p>
+            <a:r>
+              <a:t>| Публичный тариф внесения | 1300 руб./га-проход, план | По запросу | В среднем 900 руб./га [7] | По запросу |</a:t>
+            </a:r>
+          </a:p>
+          <a:p>
+            <a:r>
+              <a:t>| Отчетность заказчику | Отчет за 48 часов, цель | Состав отчета уточняется | Акты и закрывающие документы заявлены [7] | Состав отчета уточняется |</a:t>
+            </a:r>
+          </a:p>
+          <a:p>
+            <a:r>
+              <a:t>| Опыт исполнения | Коммерческий сезон еще не проведен | Более 50 тыс. га суммарно, заявление без периода [3] | Собственный парк заявлен [7] | Полевые кейсы опубликованы [6] |</a:t>
+            </a:r>
+          </a:p>
+          <a:p/>
+          <a:p>
+            <a:r>
+              <a:t>### Стратегическая канва по факторам выбора клиента</a:t>
+            </a:r>
+          </a:p>
+          <a:p/>
+          <a:p>
+            <a:r>
+              <a:t>Качественная канва сопоставляет цену, состав пакета, территорию, минимальный объем и срок отчета. Для несопоставимых и нераскрытых параметров числовые баллы не назначаются. Целевой профиль проекта не является достигнутым результатом.</a:t>
+            </a:r>
+          </a:p>
+          <a:p/>
+          <a:p>
+            <a:r>
+              <a:t>| Фактор выбора клиента | АгроВектор: цель | Агропрофи / XAG | Агродроны ЮФО | Гермес |</a:t>
+            </a:r>
+          </a:p>
+          <a:p>
+            <a:r>
+              <a:t>| --- | --- | --- | --- | --- |</a:t>
+            </a:r>
+          </a:p>
+          <a:p>
+            <a:r>
+              <a:t>| Цена внесения, руб./га | 1 300 без НДС | По запросу | 900, средняя; состав уточняется | По запросу |</a:t>
+            </a:r>
+          </a:p>
+          <a:p>
+            <a:r>
+              <a:t>| Мониторинг + внесение | Один договор, план | Состав пакета уточняется | Мониторинг не подтвержден | Оба направления заявлены |</a:t>
+            </a:r>
+          </a:p>
+          <a:p>
+            <a:r>
+              <a:t>| Локальная доступность | Татарстан, до 150 км; условно | Татарстан заявлен | ЮФО | Краснодар / Адыгея |</a:t>
+            </a:r>
+          </a:p>
+          <a:p>
+            <a:r>
+              <a:t>| Минимальный маршрут | 100 га-проходов, план | Не раскрыт | Не раскрыт | Не раскрыт |</a:t>
+            </a:r>
+          </a:p>
+          <a:p>
+            <a:r>
+              <a:t>| Срок отчета | Не более 48 часов, цель | Не раскрыт | Акты заявлены; срок не раскрыт | Не раскрыт |</a:t>
+            </a:r>
+          </a:p>
+          <a:p/>
+          <a:p>
+            <a:r>
+              <a:t>[ДОПУЩЕНИЕ] Позиционирование: локальный маршрут от 100 га-проходов, один договор на мониторинг и внесение, отчет за 48 часов. Это проверяемая гипотеза, не доказанное превосходство. У конкурентов уже есть сходные услуги. Премия к ориентиру 900 руб./га требует сопоставимых коммерческих предложений и платного пилота. Неизвестные характеристики конкурентов не считаются их недостатками. Источники: [3][4][6][7]; проверка 06.10.2026.</a:t>
             </a:r>
           </a:p>
           <a:p/>
@@ -4564,62 +4188,144 @@
           <a:p/>
           <a:p>
             <a:r>
-              <a:t>### Размер рынка: сценарный расчет снизу вверх</a:t>
+              <a:t>### TAM SAM SOM и проверка расчета</a:t>
             </a:r>
           </a:p>
           <a:p/>
           <a:p>
             <a:r>
-              <a:t>[ДОПУЩЕНИЕ] Открытого реестра оплаченных гектаров услуг агродронов и проверенной базы потенциальных клиентов в выбранном радиусе нет. Поэтому приведен проверяемый сценарий адресуемого спроса, **не установленный размер российского рынка и не прогноз отраслевого агентства**. Перед инвестиционным решением каждое хозяйство SAM должно быть подтверждено в CRM.</a:t>
+              <a:t>Рынок проекта — платные услуги агродронов по внесению и мониторингу для КФХ и малых/средних хозяйств. Оценка — годовая, в ценах 2027 года, без НДС, препаратов клиента и продажи дронов. TAM — потенциальный спрос выбранного сегмента РФ; SAM — его доступная часть в кластере Татарстана до 150 км; SOM — объем, который одна бригада планирует продать и выполнить в первом сезоне. SAM вложен в TAM. Доступность требует проверки конкретного поля.</a:t>
             </a:r>
           </a:p>
           <a:p/>
           <a:p>
             <a:r>
-              <a:t>[ДОПУЩЕНИЕ] TAM — расчетная корзина из 2000 хозяйств РФ по 2000 га; лишь 15% площади допускается к рассматриваемым услугам с учетом агрономии, полетной доступности и готовности отдавать работу подрядчику. На пригодный гектар — 1,5 оплаченного прохода внесения и 0,5 обследования в год. SAM — подмножество 200 хозяйств по 2000 га в доступном кластере Татарстана и радиусе до 150 км при тех же фильтрах. Это гипотезы, не подсчитанные хозяйства; юридически недоступные участки исключаются. Цены постоянные, 2027 года, без НДС.</a:t>
+              <a:t>[ДОПУЩЕНИЕ] База 2000 хозяйств РФ и 200 хозяйств кластера, средняя площадь 2000 га, пригодность 15%, 1,5 прохода внесения и 0,5 обследования на пригодный гектар — параметры сценария. Список хозяйств и пригодность не подтверждены. Поэтому эти результаты называются сценарной емкостью выбранного сегмента, а не установленной емкостью всей России. До адресного реестра точность 1,245 млрд руб. арифметическая, а не статистическая.</a:t>
             </a:r>
           </a:p>
           <a:p/>
           <a:p>
             <a:r>
-              <a:t>[РАСЧЕТ]</a:t>
+              <a:t>[РАСЧЕТ] Пригодная площадь = число хозяйств × средняя площадь × доля пригодности. Внесение = пригодная площадь × 1,5; мониторинг = пригодная площадь × 0,5. Емкость = внесение × 1300 + мониторинг × 250.</a:t>
             </a:r>
           </a:p>
           <a:p/>
           <a:p>
             <a:r>
-              <a:t>| Уровень | Пригодная площадь, га | Га-проходы внесения | Га-обследования | Рубли в год |</a:t>
-            </a:r>
-          </a:p>
-          <a:p>
-            <a:r>
-              <a:t>|---|---:|---:|---:|---:|</a:t>
-            </a:r>
-          </a:p>
-          <a:p>
-            <a:r>
-              <a:t>| TAM сценарный | 600000 | 900000 | 300000 | 1245000000 |</a:t>
-            </a:r>
-          </a:p>
-          <a:p>
-            <a:r>
-              <a:t>| SAM сценарный | 60000 | 90000 | 30000 | 124500000 |</a:t>
-            </a:r>
-          </a:p>
-          <a:p>
-            <a:r>
-              <a:t>| SOM первого сезона | Не суммируется между услугами | 6000 | 4000 | 8800000 |</a:t>
+              <a:t>| Уровень | Хозяйства | Пригодная площадь, га | Внесение, га-проходы | Мониторинг, га-обследования | Емкость, руб./год |</a:t>
+            </a:r>
+          </a:p>
+          <a:p>
+            <a:r>
+              <a:t>|---|---:|---:|---:|---:|---:|</a:t>
+            </a:r>
+          </a:p>
+          <a:p>
+            <a:r>
+              <a:t>| TAM выбранного сегмента, сценарий | 2000 | 600000 | 900000 | 300000 | 1245000000 |</a:t>
+            </a:r>
+          </a:p>
+          <a:p>
+            <a:r>
+              <a:t>| SAM кластера, сценарий | 200 | 60000 | 90000 | 30000 | 124500000 |</a:t>
+            </a:r>
+          </a:p>
+          <a:p>
+            <a:r>
+              <a:t>| SOM сезона 2027, цель | 10 | Не суммируется по услугам | 6000 | 4000 | 8800000 |</a:t>
             </a:r>
           </a:p>
           <a:p/>
           <a:p>
             <a:r>
-              <a:t>[РАСЧЕТ] Формула TAM: 2000 × 2000 × 15% × (1,5 × 1300 + 0,5 × 250). SAM — та же формула для 200 хозяйств. SOM — 10 клиентов × 600 га-проходов × 1300 + 4000 га-обследований × 250. План занимает 6,67% сценарных га-проходов SAM и 7,07% его денежного объема. Это целевые доли будущей выручки, не текущая доля компании. Повторные проходы не считаются уникальными гектарами; мониторинг тех же полей — другая оплаченная операция, а не прирост земли.</a:t>
+              <a:t>[РАСЧЕТ] TAM = 2000 × 2000 × 0,15 × (1,5 × 1300 + 0,5 × 250). SAM использует ту же формулу для 200 хозяйств. SOM = 6000 × 1300 + 4000 × 250 = 7,8 млн + 1,0 млн = 8,8 млн руб. Средние 600 га-проходов на каждого из 10 клиентов относятся к внесению; 400 га-обследований на клиента — отдельная целевая услуга, если все 10 заказывают мониторинг.</a:t>
             </a:r>
           </a:p>
           <a:p/>
           <a:p>
             <a:r>
+              <a:t>| Доля SOM в SAM | Расчет | Результат |</a:t>
+            </a:r>
+          </a:p>
+          <a:p>
+            <a:r>
+              <a:t>|---|---|---:|</a:t>
+            </a:r>
+          </a:p>
+          <a:p>
+            <a:r>
+              <a:t>| По внесению | 6000 / 90000 × 100% | 6,67% |</a:t>
+            </a:r>
+          </a:p>
+          <a:p>
+            <a:r>
+              <a:t>| По мониторингу | 4000 / 30000 × 100% | 13,33% |</a:t>
+            </a:r>
+          </a:p>
+          <a:p>
+            <a:r>
+              <a:t>| По выручке двух услуг | 8800000 / 124500000 × 100% | 7,07% |</a:t>
+            </a:r>
+          </a:p>
+          <a:p/>
+          <a:p>
+            <a:r>
+              <a:t>Микс SOM отличается от среднего микса TAM/SAM: 0,667 обследования на проход против 0,333. Это возможно как отдельный спрос на мониторинг, но должно подтверждаться заявками. Если сохранить средний микс SAM, мониторинг при 6000 проходах составит 2000 обследований, SOM — 8,3 млн руб., доля — 6,67%. Финансовая база 8,8 млн сохранена как проверяемая цель, а не исправлена без подтверждения портфеля.</a:t>
+            </a:r>
+          </a:p>
+          <a:p/>
+          <a:p>
+            <a:r>
+              <a:t>[РАСЧЕТ] Ограничение мощности: 6000 / 130 + 4000 / 500 = 54,15 полевых дня при плановых производительностях проекта. Это ниже потолка 120 дней, однако пики агрономических окон, погода, транспорт и отдых могут ограничить загрузку. SOM проверяется одновременно по договорам, кадрам и календарю. Резервный борт не создает вторую бригаду.</a:t>
+            </a:r>
+          </a:p>
+          <a:p/>
+          <a:p>
+            <a:r>
+              <a:t>### Чувствительность сценарной емкости</a:t>
+            </a:r>
+          </a:p>
+          <a:p/>
+          <a:p>
+            <a:r>
+              <a:t>При прежних числе хозяйств, площади, частоте и тарифах меняется только пригодность. Диапазон не является доверительным интервалом.</a:t>
+            </a:r>
+          </a:p>
+          <a:p/>
+          <a:p>
+            <a:r>
+              <a:t>| Пригодность | TAM, руб./год | SAM, руб./год | Цель SOM / SAM |</a:t>
+            </a:r>
+          </a:p>
+          <a:p>
+            <a:r>
+              <a:t>|---|---:|---:|---:|</a:t>
+            </a:r>
+          </a:p>
+          <a:p>
+            <a:r>
+              <a:t>| 10% | 830000000 | 83000000 | 10,60% |</a:t>
+            </a:r>
+          </a:p>
+          <a:p>
+            <a:r>
+              <a:t>| 15%, база | 1245000000 | 124500000 | 7,07% |</a:t>
+            </a:r>
+          </a:p>
+          <a:p>
+            <a:r>
+              <a:t>| 20% | 1660000000 | 166000000 | 5,30% |</a:t>
+            </a:r>
+          </a:p>
+          <a:p/>
+          <a:p>
+            <a:r>
+              <a:t>Для подтверждения оценки нужны адресный список хозяйств, площадь и культуры по каждому клиенту, агрономически подходящие операции, доступность участков, частота заказов и готовность оплатить тариф. Национальная площадь обработок не подменяет выручку подрядчиков и не служит знаменателем региональных долей.</a:t>
+            </a:r>
+          </a:p>
+          <a:p/>
+          <a:p>
+            <a:r>
               <a:t>### Выход на рынок</a:t>
             </a:r>
           </a:p>
@@ -4668,7 +4374,7 @@
           <a:p/>
           <a:p>
             <a:r>
-              <a:t>[РАСЧЕТ] Внутри оценки РСХБ прогнозный рост 2026 к 2025 составляет 35,47% (1058/781−1), но этот темп не переносится на финансовую модель АгроВектора: ее выручку определяют собственные гектары, тариф и мощность. Плановый средний CAC24000 руб. и выручка 880000 руб. на клиента рассчитаны как 240000/10 и 8800000/10 соответственно.</a:t>
+              <a:t>[РАСЧЕТ] Внутри оценки РСХБ прогнозный рост 2026 к 2025 составляет 35,47% (1058/781−1), но этот темп не переносится на финансовую модель АгроВектора: ее выручку определяют собственные гектары, тариф и мощность. Плановый средний CAC 24000 руб. и выручка 880000 руб. на клиента рассчитаны как 240000/10 и 8800000/10 соответственно.</a:t>
             </a:r>
           </a:p>
           <a:p/>
@@ -4826,6 +4532,65 @@
           <a:p>
             <a:r>
               <a:t>[ДОПУЩЕНИЕ] Фактические выручки и знаменатель регионального рынка не раскрыты, поэтому именованные доли не присваиваются и круговая диаграмма выдуманных долей не строится. Целевая доля АгроВектора 7,07% относится исключительно к сценарному денежному SAM раздела 5. Для рыночного подтверждения нужны реестр доступных хозяйств, сопоставимые КП минимум трех подрядчиков и фактические гектары оплаченных работ.</a:t>
+            </a:r>
+          </a:p>
+          <a:p/>
+          <a:p>
+            <a:r>
+              <a:t>### Доли конкретных конкурентов</a:t>
+            </a:r>
+          </a:p>
+          <a:p/>
+          <a:p>
+            <a:r>
+              <a:t>Доля по выручке = выручка компании от сопоставимых услуг в территории и году / суммарная выручка всех исполнителей тех же услуг в той же территории и году × 100%. Альтернатива — доля по оплачиваемым га-проходам; смешивать эти показатели нельзя. Для сопоставления с AgroVector нужен рынок услуг кластера Татарстана за один сезон, а не продажи оборудования или мировая доля марки XAG/DJI.</a:t>
+            </a:r>
+          </a:p>
+          <a:p/>
+          <a:p>
+            <a:r>
+              <a:t>| Компания | Доля услуг кластера Татарстана, % | Доступное основание | Что требуется для расчета |</a:t>
+            </a:r>
+          </a:p>
+          <a:p>
+            <a:r>
+              <a:t>|---|---|---|---|</a:t>
+            </a:r>
+          </a:p>
+          <a:p>
+            <a:r>
+              <a:t>| ГК Агропрофи | Не установлена | 50 тыс.+ га суммарно; период и доля Татарстана не раскрыты | Годовой объем или выручка услуг в кластере и итог рынка |</a:t>
+            </a:r>
+          </a:p>
+          <a:p>
+            <a:r>
+              <a:t>| BeeAir / BeeUAV | Не установлена | В прежнем реестре заявлен Татарстан; сайт повторно недоступен 06.10.2026 | Подтверждение покрытия, годовые продажи и итог рынка |</a:t>
+            </a:r>
+          </a:p>
+          <a:p>
+            <a:r>
+              <a:t>| Агродроны ЮФО | Не установлена | Предложение относится к ЮФО; не подтверждено присутствие в кластере | Покрытие кластера и сопоставимая статистика |</a:t>
+            </a:r>
+          </a:p>
+          <a:p>
+            <a:r>
+              <a:t>| Гермес | Не установлена | Предложение относится к Краснодарскому краю и Адыгее | Покрытие кластера и сопоставимая статистика |</a:t>
+            </a:r>
+          </a:p>
+          <a:p>
+            <a:r>
+              <a:t>| Аграс | Не установлена | Межрегиональный ориентир из предыдущего реестра | Покрытие кластера и сопоставимая статистика |</a:t>
+            </a:r>
+          </a:p>
+          <a:p>
+            <a:r>
+              <a:t>| АгроВектор | Продажи проекта не подтверждены | 7,07% — цель от сценарного SAM, не фактическая доля | Фактические акты и подтвержденный знаменатель рынка |</a:t>
+            </a:r>
+          </a:p>
+          <a:p/>
+          <a:p>
+            <a:r>
+              <a:t>[ФАКТ] При проверке 06.10.2026 Агропрофи публикует более 50 тыс. обработанных гектаров без годового периода. Нельзя делить этот накопленный показатель на годовую площадь РФ, на сценарные 90000 га-проходов SAM или на 60000 га земли: полученные проценты не являются рыночной долей. Ни один сопоставимый процент по именованным конкурентам в проверенных источниках не подтвержден. Числовая доля требует данных исполнителей или исследования рынка с раскрытой методикой.</a:t>
             </a:r>
           </a:p>
           <a:p/>
@@ -23772,6 +23537,48 @@
           </a:p>
         </p:txBody>
       </p:sp>
+      <p:sp>
+        <p:nvSpPr>
+          <p:cNvPr id="19" name="TextBox 18"/>
+          <p:cNvSpPr txBox="1"/>
+          <p:nvPr/>
+        </p:nvSpPr>
+        <p:spPr>
+          <a:xfrm>
+            <a:off x="594360" y="5349240"/>
+            <a:ext cx="10972800" cy="347472"/>
+          </a:xfrm>
+          <a:prstGeom prst="rect">
+            <a:avLst/>
+          </a:prstGeom>
+          <a:noFill/>
+        </p:spPr>
+        <p:txBody>
+          <a:bodyPr wrap="square" lIns="13716" rIns="13716" tIns="0" bIns="0">
+            <a:spAutoFit/>
+          </a:bodyPr>
+          <a:lstStyle/>
+          <a:p>
+            <a:pPr>
+              <a:spcBef>
+                <a:spcPts val="0"/>
+              </a:spcBef>
+              <a:spcAft>
+                <a:spcPts val="500"/>
+              </a:spcAft>
+              <a:defRPr sz="1500" b="0">
+                <a:solidFill>
+                  <a:srgbClr val="FFFFFF"/>
+                </a:solidFill>
+                <a:latin typeface="Arial"/>
+              </a:defRPr>
+            </a:pPr>
+            <a:r>
+              <a:t>Пара XAG P100 Pro: ориентир 5,98 млн ₽ вместо лимита 4,0; финансирование 11,48 млн ₽.</a:t>
+            </a:r>
+          </a:p>
+        </p:txBody>
+      </p:sp>
     </p:spTree>
   </p:cSld>
   <p:clrMapOvr>
@@ -24029,10 +23836,10 @@
               </a:tblPr>
               <a:tblGrid>
                 <a:gridCol w="4709160"/>
-                <a:gridCol w="2560320"/>
-                <a:gridCol w="3913632"/>
+                <a:gridCol w="2103120"/>
+                <a:gridCol w="4370832"/>
               </a:tblGrid>
-              <a:tr h="586740">
+              <a:tr h="502920">
                 <a:tc>
                   <a:txBody>
                     <a:bodyPr/>
@@ -24042,7 +23849,7 @@
                         <a:spcAft>
                           <a:spcPts val="0"/>
                         </a:spcAft>
-                        <a:defRPr sz="1700" b="1">
+                        <a:defRPr sz="1500" b="1">
                           <a:solidFill>
                             <a:srgbClr val="FFFFFF"/>
                           </a:solidFill>
@@ -24050,7 +23857,7 @@
                         </a:defRPr>
                       </a:pPr>
                       <a:r>
-                        <a:t>SMART-результат</a:t>
+                        <a:t>Цель / результат</a:t>
                       </a:r>
                     </a:p>
                   </a:txBody>
@@ -24069,7 +23876,7 @@
                         <a:spcAft>
                           <a:spcPts val="0"/>
                         </a:spcAft>
-                        <a:defRPr sz="1700" b="1">
+                        <a:defRPr sz="1500" b="1">
                           <a:solidFill>
                             <a:srgbClr val="FFFFFF"/>
                           </a:solidFill>
@@ -24096,7 +23903,7 @@
                         <a:spcAft>
                           <a:spcPts val="0"/>
                         </a:spcAft>
-                        <a:defRPr sz="1700" b="1">
+                        <a:defRPr sz="1500" b="1">
                           <a:solidFill>
                             <a:srgbClr val="FFFFFF"/>
                           </a:solidFill>
@@ -24115,7 +23922,7 @@
                   </a:tcPr>
                 </a:tc>
               </a:tr>
-              <a:tr h="586740">
+              <a:tr h="502920">
                 <a:tc>
                   <a:txBody>
                     <a:bodyPr/>
@@ -24125,7 +23932,7 @@
                         <a:spcAft>
                           <a:spcPts val="0"/>
                         </a:spcAft>
-                        <a:defRPr sz="1700" b="0">
+                        <a:defRPr sz="1500" b="0">
                           <a:solidFill>
                             <a:srgbClr val="092A20"/>
                           </a:solidFill>
@@ -24133,7 +23940,7 @@
                         </a:defRPr>
                       </a:pPr>
                       <a:r>
-                        <a:t>Правовая применимость</a:t>
+                        <a:t>Правовая карта всех полей; GO/NO-GO</a:t>
                       </a:r>
                     </a:p>
                   </a:txBody>
@@ -24152,7 +23959,7 @@
                         <a:spcAft>
                           <a:spcPts val="0"/>
                         </a:spcAft>
-                        <a:defRPr sz="1700" b="0">
+                        <a:defRPr sz="1500" b="0">
                           <a:solidFill>
                             <a:srgbClr val="092A20"/>
                           </a:solidFill>
@@ -24160,7 +23967,7 @@
                         </a:defRPr>
                       </a:pPr>
                       <a:r>
-                        <a:t>До go/no-go 2026</a:t>
+                        <a:t>31.10.2026</a:t>
                       </a:r>
                     </a:p>
                   </a:txBody>
@@ -24179,7 +23986,7 @@
                         <a:spcAft>
                           <a:spcPts val="0"/>
                         </a:spcAft>
-                        <a:defRPr sz="1700" b="0">
+                        <a:defRPr sz="1500" b="0">
                           <a:solidFill>
                             <a:srgbClr val="092A20"/>
                           </a:solidFill>
@@ -24187,7 +23994,7 @@
                         </a:defRPr>
                       </a:pPr>
                       <a:r>
-                        <a:t>Письменная карта ограничений</a:t>
+                        <a:t>Директор; заключение юриста</a:t>
                       </a:r>
                     </a:p>
                   </a:txBody>
@@ -24198,7 +24005,7 @@
                   </a:tcPr>
                 </a:tc>
               </a:tr>
-              <a:tr h="586740">
+              <a:tr h="502920">
                 <a:tc>
                   <a:txBody>
                     <a:bodyPr/>
@@ -24208,7 +24015,7 @@
                         <a:spcAft>
                           <a:spcPts val="0"/>
                         </a:spcAft>
-                        <a:defRPr sz="1700" b="0">
+                        <a:defRPr sz="1500" b="0">
                           <a:solidFill>
                             <a:srgbClr val="092A20"/>
                           </a:solidFill>
@@ -24216,7 +24023,7 @@
                         </a:defRPr>
                       </a:pPr>
                       <a:r>
-                        <a:t>20 интервью; заявки на 6 000 га-проходов</a:t>
+                        <a:t>20 интервью; заявки: 6 000 / 4 000</a:t>
                       </a:r>
                     </a:p>
                   </a:txBody>
@@ -24235,7 +24042,7 @@
                         <a:spcAft>
                           <a:spcPts val="0"/>
                         </a:spcAft>
-                        <a:defRPr sz="1700" b="0">
+                        <a:defRPr sz="1500" b="0">
                           <a:solidFill>
                             <a:srgbClr val="092A20"/>
                           </a:solidFill>
@@ -24243,7 +24050,7 @@
                         </a:defRPr>
                       </a:pPr>
                       <a:r>
-                        <a:t>До финансирования</a:t>
+                        <a:t>30.11.2026</a:t>
                       </a:r>
                     </a:p>
                   </a:txBody>
@@ -24262,7 +24069,7 @@
                         <a:spcAft>
                           <a:spcPts val="0"/>
                         </a:spcAft>
-                        <a:defRPr sz="1700" b="0">
+                        <a:defRPr sz="1500" b="0">
                           <a:solidFill>
                             <a:srgbClr val="092A20"/>
                           </a:solidFill>
@@ -24270,7 +24077,7 @@
                         </a:defRPr>
                       </a:pPr>
                       <a:r>
-                        <a:t>Реестр клиентов и полей</a:t>
+                        <a:t>Директор; реестр заявок</a:t>
                       </a:r>
                     </a:p>
                   </a:txBody>
@@ -24281,7 +24088,7 @@
                   </a:tcPr>
                 </a:tc>
               </a:tr>
-              <a:tr h="586740">
+              <a:tr h="502920">
                 <a:tc>
                   <a:txBody>
                     <a:bodyPr/>
@@ -24291,7 +24098,7 @@
                         <a:spcAft>
                           <a:spcPts val="0"/>
                         </a:spcAft>
-                        <a:defRPr sz="1700" b="0">
+                        <a:defRPr sz="1500" b="0">
                           <a:solidFill>
                             <a:srgbClr val="092A20"/>
                           </a:solidFill>
@@ -24299,7 +24106,7 @@
                         </a:defRPr>
                       </a:pPr>
                       <a:r>
-                        <a:t>10 сезонных клиентов; 2 оператора</a:t>
+                        <a:t>10 клиентов; договоры: 6 000 / 4 000</a:t>
                       </a:r>
                     </a:p>
                   </a:txBody>
@@ -24318,7 +24125,7 @@
                         <a:spcAft>
                           <a:spcPts val="0"/>
                         </a:spcAft>
-                        <a:defRPr sz="1700" b="0">
+                        <a:defRPr sz="1500" b="0">
                           <a:solidFill>
                             <a:srgbClr val="092A20"/>
                           </a:solidFill>
@@ -24326,7 +24133,7 @@
                         </a:defRPr>
                       </a:pPr>
                       <a:r>
-                        <a:t>До 12.04.2027</a:t>
+                        <a:t>11.04.2027</a:t>
                       </a:r>
                     </a:p>
                   </a:txBody>
@@ -24345,7 +24152,7 @@
                         <a:spcAft>
                           <a:spcPts val="0"/>
                         </a:spcAft>
-                        <a:defRPr sz="1700" b="0">
+                        <a:defRPr sz="1500" b="0">
                           <a:solidFill>
                             <a:srgbClr val="092A20"/>
                           </a:solidFill>
@@ -24353,7 +24160,7 @@
                         </a:defRPr>
                       </a:pPr>
                       <a:r>
-                        <a:t>Договоры; оценка компетенций</a:t>
+                        <a:t>Директор; договоры и календарь</a:t>
                       </a:r>
                     </a:p>
                   </a:txBody>
@@ -24364,7 +24171,7 @@
                   </a:tcPr>
                 </a:tc>
               </a:tr>
-              <a:tr h="586740">
+              <a:tr h="502920">
                 <a:tc>
                   <a:txBody>
                     <a:bodyPr/>
@@ -24374,7 +24181,7 @@
                         <a:spcAft>
                           <a:spcPts val="0"/>
                         </a:spcAft>
-                        <a:defRPr sz="1700" b="0">
+                        <a:defRPr sz="1500" b="0">
                           <a:solidFill>
                             <a:srgbClr val="092A20"/>
                           </a:solidFill>
@@ -24382,7 +24189,7 @@
                         </a:defRPr>
                       </a:pPr>
                       <a:r>
-                        <a:t>6 000 га-проходов + 4 000 га-обследований</a:t>
+                        <a:t>3 аппарата; 2 оператора; пилот 100 га</a:t>
                       </a:r>
                     </a:p>
                   </a:txBody>
@@ -24401,7 +24208,7 @@
                         <a:spcAft>
                           <a:spcPts val="0"/>
                         </a:spcAft>
-                        <a:defRPr sz="1700" b="0">
+                        <a:defRPr sz="1500" b="0">
                           <a:solidFill>
                             <a:srgbClr val="092A20"/>
                           </a:solidFill>
@@ -24409,7 +24216,7 @@
                         </a:defRPr>
                       </a:pPr>
                       <a:r>
-                        <a:t>Сезон 2027</a:t>
+                        <a:t>30.04.2027</a:t>
                       </a:r>
                     </a:p>
                   </a:txBody>
@@ -24428,7 +24235,7 @@
                         <a:spcAft>
                           <a:spcPts val="0"/>
                         </a:spcAft>
-                        <a:defRPr sz="1700" b="0">
+                        <a:defRPr sz="1500" b="0">
                           <a:solidFill>
                             <a:srgbClr val="092A20"/>
                           </a:solidFill>
@@ -24436,7 +24243,7 @@
                         </a:defRPr>
                       </a:pPr>
                       <a:r>
-                        <a:t>Акты и журналы; пилот внутри объема</a:t>
+                        <a:t>Опер. руководитель; акты и допуски</a:t>
                       </a:r>
                     </a:p>
                   </a:txBody>
@@ -24447,7 +24254,7 @@
                   </a:tcPr>
                 </a:tc>
               </a:tr>
-              <a:tr h="586740">
+              <a:tr h="502920">
                 <a:tc>
                   <a:txBody>
                     <a:bodyPr/>
@@ -24457,7 +24264,7 @@
                         <a:spcAft>
                           <a:spcPts val="0"/>
                         </a:spcAft>
-                        <a:defRPr sz="1700" b="0">
+                        <a:defRPr sz="1500" b="0">
                           <a:solidFill>
                             <a:srgbClr val="092A20"/>
                           </a:solidFill>
@@ -24465,7 +24272,7 @@
                         </a:defRPr>
                       </a:pPr>
                       <a:r>
-                        <a:t>Добровольная гражданская переподготовка</a:t>
+                        <a:t>6 000 / 4 000; выручка 8,8 млн ₽</a:t>
                       </a:r>
                     </a:p>
                   </a:txBody>
@@ -24484,7 +24291,7 @@
                         <a:spcAft>
                           <a:spcPts val="0"/>
                         </a:spcAft>
-                        <a:defRPr sz="1700" b="0">
+                        <a:defRPr sz="1500" b="0">
                           <a:solidFill>
                             <a:srgbClr val="092A20"/>
                           </a:solidFill>
@@ -24492,7 +24299,7 @@
                         </a:defRPr>
                       </a:pPr>
                       <a:r>
-                        <a:t>До самостоятельных работ</a:t>
+                        <a:t>12.09.2027</a:t>
                       </a:r>
                     </a:p>
                   </a:txBody>
@@ -24511,7 +24318,7 @@
                         <a:spcAft>
                           <a:spcPts val="0"/>
                         </a:spcAft>
-                        <a:defRPr sz="1700" b="0">
+                        <a:defRPr sz="1500" b="0">
                           <a:solidFill>
                             <a:srgbClr val="092A20"/>
                           </a:solidFill>
@@ -24519,7 +24326,7 @@
                         </a:defRPr>
                       </a:pPr>
                       <a:r>
-                        <a:t>Наставник; единые критерии допуска</a:t>
+                        <a:t>Директор; акты и учет</a:t>
                       </a:r>
                     </a:p>
                   </a:txBody>
@@ -24530,6 +24337,89 @@
                   </a:tcPr>
                 </a:tc>
               </a:tr>
+              <a:tr h="502920">
+                <a:tc>
+                  <a:txBody>
+                    <a:bodyPr/>
+                    <a:lstStyle/>
+                    <a:p>
+                      <a:pPr>
+                        <a:spcAft>
+                          <a:spcPts val="0"/>
+                        </a:spcAft>
+                        <a:defRPr sz="1500" b="0">
+                          <a:solidFill>
+                            <a:srgbClr val="092A20"/>
+                          </a:solidFill>
+                          <a:latin typeface="Arial"/>
+                        </a:defRPr>
+                      </a:pPr>
+                      <a:r>
+                        <a:t>2 оператора: обучение и наставник</a:t>
+                      </a:r>
+                    </a:p>
+                  </a:txBody>
+                  <a:tcPr marL="91440" marR="91440" marT="45720" marB="45720">
+                    <a:solidFill>
+                      <a:srgbClr val="EFF4EF"/>
+                    </a:solidFill>
+                  </a:tcPr>
+                </a:tc>
+                <a:tc>
+                  <a:txBody>
+                    <a:bodyPr/>
+                    <a:lstStyle/>
+                    <a:p>
+                      <a:pPr>
+                        <a:spcAft>
+                          <a:spcPts val="0"/>
+                        </a:spcAft>
+                        <a:defRPr sz="1500" b="0">
+                          <a:solidFill>
+                            <a:srgbClr val="092A20"/>
+                          </a:solidFill>
+                          <a:latin typeface="Arial"/>
+                        </a:defRPr>
+                      </a:pPr>
+                      <a:r>
+                        <a:t>11.04.2027; контроль 12.07.2027</a:t>
+                      </a:r>
+                    </a:p>
+                  </a:txBody>
+                  <a:tcPr marL="91440" marR="91440" marT="45720" marB="45720">
+                    <a:solidFill>
+                      <a:srgbClr val="EFF4EF"/>
+                    </a:solidFill>
+                  </a:tcPr>
+                </a:tc>
+                <a:tc>
+                  <a:txBody>
+                    <a:bodyPr/>
+                    <a:lstStyle/>
+                    <a:p>
+                      <a:pPr>
+                        <a:spcAft>
+                          <a:spcPts val="0"/>
+                        </a:spcAft>
+                        <a:defRPr sz="1500" b="0">
+                          <a:solidFill>
+                            <a:srgbClr val="092A20"/>
+                          </a:solidFill>
+                          <a:latin typeface="Arial"/>
+                        </a:defRPr>
+                      </a:pPr>
+                      <a:r>
+                        <a:t>Опер. руководитель; протоколы</a:t>
+                      </a:r>
+                    </a:p>
+                  </a:txBody>
+                  <a:tcPr marL="91440" marR="91440" marT="45720" marB="45720">
+                    <a:solidFill>
+                      <a:srgbClr val="EFF4EF"/>
+                    </a:solidFill>
+                  </a:tcPr>
+                </a:tc>
+              </a:tr>
             </a:tbl>
           </a:graphicData>
         </a:graphic>
@@ -24542,7 +24432,7 @@
         </p:nvSpPr>
         <p:spPr>
           <a:xfrm>
-            <a:off x="502920" y="5513832"/>
+            <a:off x="502920" y="5715000"/>
             <a:ext cx="11183112" cy="448056"/>
           </a:xfrm>
           <a:prstGeom prst="roundRect">
@@ -24587,7 +24477,7 @@
         </p:nvSpPr>
         <p:spPr>
           <a:xfrm>
-            <a:off x="658368" y="5596128"/>
+            <a:off x="658368" y="5797296"/>
             <a:ext cx="10881360" cy="320040"/>
           </a:xfrm>
           <a:prstGeom prst="rect">
@@ -24617,6 +24507,48 @@
             </a:pPr>
             <a:r>
               <a:t>Коммерческие цели не отменяют право остановить небезопасное задание</a:t>
+            </a:r>
+          </a:p>
+        </p:txBody>
+      </p:sp>
+      <p:sp>
+        <p:nvSpPr>
+          <p:cNvPr id="10" name="TextBox 9"/>
+          <p:cNvSpPr txBox="1"/>
+          <p:nvPr/>
+        </p:nvSpPr>
+        <p:spPr>
+          <a:xfrm>
+            <a:off x="594360" y="5321808"/>
+            <a:ext cx="10972800" cy="329184"/>
+          </a:xfrm>
+          <a:prstGeom prst="rect">
+            <a:avLst/>
+          </a:prstGeom>
+          <a:noFill/>
+        </p:spPr>
+        <p:txBody>
+          <a:bodyPr wrap="square" lIns="13716" rIns="13716" tIns="0" bIns="0">
+            <a:spAutoFit/>
+          </a:bodyPr>
+          <a:lstStyle/>
+          <a:p>
+            <a:pPr>
+              <a:spcBef>
+                <a:spcPts val="0"/>
+              </a:spcBef>
+              <a:spcAft>
+                <a:spcPts val="500"/>
+              </a:spcAft>
+              <a:defRPr sz="1500" b="0">
+                <a:solidFill>
+                  <a:srgbClr val="AFC5B8"/>
+                </a:solidFill>
+                <a:latin typeface="Arial"/>
+              </a:defRPr>
+            </a:pPr>
+            <a:r>
+              <a:t>Объемы: га-проходы внесения / га-обследования. Это разные операции, не сумма площади.</a:t>
             </a:r>
           </a:p>
         </p:txBody>
@@ -27901,7 +27833,7 @@
               </a:defRPr>
             </a:pPr>
             <a:r>
-              <a:t>[ДОПУЩЕНИЕ] Продукт и стратегическая канва: экспертная шкала 1–5, не исследование рынка</a:t>
+              <a:t>Качественная стратегическая канва: цель проекта и публичные предложения конкурентов</a:t>
             </a:r>
           </a:p>
         </p:txBody>
@@ -28032,72 +27964,860 @@
           </a:p>
         </p:txBody>
       </p:sp>
-      <p:sp>
-        <p:nvSpPr>
-          <p:cNvPr id="8" name="Rounded Rectangle 7"/>
-          <p:cNvSpPr/>
-          <p:nvPr/>
-        </p:nvSpPr>
-        <p:spPr>
-          <a:xfrm>
-            <a:off x="502920" y="2249424"/>
-            <a:ext cx="11183112" cy="3182112"/>
-          </a:xfrm>
-          <a:prstGeom prst="roundRect">
-            <a:avLst>
-              <a:gd name="adj" fmla="val 8000"/>
-            </a:avLst>
-          </a:prstGeom>
-          <a:solidFill>
-            <a:srgbClr val="FFFFFF"/>
-          </a:solidFill>
-          <a:ln>
-            <a:noFill/>
-          </a:ln>
-        </p:spPr>
-        <p:style>
-          <a:lnRef idx="1">
-            <a:schemeClr val="accent1"/>
-          </a:lnRef>
-          <a:fillRef idx="3">
-            <a:schemeClr val="accent1"/>
-          </a:fillRef>
-          <a:effectRef idx="2">
-            <a:schemeClr val="accent1"/>
-          </a:effectRef>
-          <a:fontRef idx="minor">
-            <a:schemeClr val="lt1"/>
-          </a:fontRef>
-        </p:style>
-        <p:txBody>
-          <a:bodyPr rtlCol="0" anchor="ctr"/>
-          <a:lstStyle/>
-          <a:p>
-            <a:pPr algn="ctr"/>
-          </a:p>
-        </p:txBody>
-      </p:sp>
       <p:graphicFrame>
         <p:nvGraphicFramePr>
-          <p:cNvPr id="9" name="Chart 8"/>
+          <p:cNvPr id="8" name="Table 7"/>
           <p:cNvGraphicFramePr>
             <a:graphicFrameLocks noGrp="1"/>
           </p:cNvGraphicFramePr>
           <p:nvPr/>
         </p:nvGraphicFramePr>
         <p:xfrm>
-          <a:off x="640080" y="2359152"/>
-          <a:ext cx="10908792" cy="2962656"/>
+          <a:off x="502920" y="2194560"/>
+          <a:ext cx="11183112" cy="3246120"/>
         </p:xfrm>
         <a:graphic>
-          <a:graphicData uri="http://schemas.openxmlformats.org/drawingml/2006/chart">
-            <c:chart xmlns:c="http://schemas.openxmlformats.org/drawingml/2006/chart" r:id="rId2"/>
+          <a:graphicData uri="http://schemas.openxmlformats.org/drawingml/2006/table">
+            <a:tbl>
+              <a:tblPr firstRow="1" bandRow="1">
+                <a:tableStyleId>{5C22544A-7EE6-4342-B048-85BDC9FD1C3A}</a:tableStyleId>
+              </a:tblPr>
+              <a:tblGrid>
+                <a:gridCol w="2103120"/>
+                <a:gridCol w="2267712"/>
+                <a:gridCol w="2267712"/>
+                <a:gridCol w="2276856"/>
+                <a:gridCol w="2267712"/>
+              </a:tblGrid>
+              <a:tr h="541020">
+                <a:tc>
+                  <a:txBody>
+                    <a:bodyPr/>
+                    <a:lstStyle/>
+                    <a:p>
+                      <a:pPr>
+                        <a:spcAft>
+                          <a:spcPts val="0"/>
+                        </a:spcAft>
+                        <a:defRPr sz="1500" b="1">
+                          <a:solidFill>
+                            <a:srgbClr val="FFFFFF"/>
+                          </a:solidFill>
+                          <a:latin typeface="Arial"/>
+                        </a:defRPr>
+                      </a:pPr>
+                      <a:r>
+                        <a:t>Фактор выбора клиента</a:t>
+                      </a:r>
+                    </a:p>
+                  </a:txBody>
+                  <a:tcPr marL="91440" marR="91440" marT="45720" marB="45720">
+                    <a:solidFill>
+                      <a:srgbClr val="164C38"/>
+                    </a:solidFill>
+                  </a:tcPr>
+                </a:tc>
+                <a:tc>
+                  <a:txBody>
+                    <a:bodyPr/>
+                    <a:lstStyle/>
+                    <a:p>
+                      <a:pPr>
+                        <a:spcAft>
+                          <a:spcPts val="0"/>
+                        </a:spcAft>
+                        <a:defRPr sz="1500" b="1">
+                          <a:solidFill>
+                            <a:srgbClr val="FFFFFF"/>
+                          </a:solidFill>
+                          <a:latin typeface="Arial"/>
+                        </a:defRPr>
+                      </a:pPr>
+                      <a:r>
+                        <a:t>АгроВектор: цель</a:t>
+                      </a:r>
+                    </a:p>
+                  </a:txBody>
+                  <a:tcPr marL="91440" marR="91440" marT="45720" marB="45720">
+                    <a:solidFill>
+                      <a:srgbClr val="164C38"/>
+                    </a:solidFill>
+                  </a:tcPr>
+                </a:tc>
+                <a:tc>
+                  <a:txBody>
+                    <a:bodyPr/>
+                    <a:lstStyle/>
+                    <a:p>
+                      <a:pPr>
+                        <a:spcAft>
+                          <a:spcPts val="0"/>
+                        </a:spcAft>
+                        <a:defRPr sz="1500" b="1">
+                          <a:solidFill>
+                            <a:srgbClr val="FFFFFF"/>
+                          </a:solidFill>
+                          <a:latin typeface="Arial"/>
+                        </a:defRPr>
+                      </a:pPr>
+                      <a:r>
+                        <a:t>Агропрофи / XAG</a:t>
+                      </a:r>
+                    </a:p>
+                  </a:txBody>
+                  <a:tcPr marL="91440" marR="91440" marT="45720" marB="45720">
+                    <a:solidFill>
+                      <a:srgbClr val="164C38"/>
+                    </a:solidFill>
+                  </a:tcPr>
+                </a:tc>
+                <a:tc>
+                  <a:txBody>
+                    <a:bodyPr/>
+                    <a:lstStyle/>
+                    <a:p>
+                      <a:pPr>
+                        <a:spcAft>
+                          <a:spcPts val="0"/>
+                        </a:spcAft>
+                        <a:defRPr sz="1500" b="1">
+                          <a:solidFill>
+                            <a:srgbClr val="FFFFFF"/>
+                          </a:solidFill>
+                          <a:latin typeface="Arial"/>
+                        </a:defRPr>
+                      </a:pPr>
+                      <a:r>
+                        <a:t>Агродроны ЮФО</a:t>
+                      </a:r>
+                    </a:p>
+                  </a:txBody>
+                  <a:tcPr marL="91440" marR="91440" marT="45720" marB="45720">
+                    <a:solidFill>
+                      <a:srgbClr val="164C38"/>
+                    </a:solidFill>
+                  </a:tcPr>
+                </a:tc>
+                <a:tc>
+                  <a:txBody>
+                    <a:bodyPr/>
+                    <a:lstStyle/>
+                    <a:p>
+                      <a:pPr>
+                        <a:spcAft>
+                          <a:spcPts val="0"/>
+                        </a:spcAft>
+                        <a:defRPr sz="1500" b="1">
+                          <a:solidFill>
+                            <a:srgbClr val="FFFFFF"/>
+                          </a:solidFill>
+                          <a:latin typeface="Arial"/>
+                        </a:defRPr>
+                      </a:pPr>
+                      <a:r>
+                        <a:t>Гермес</a:t>
+                      </a:r>
+                    </a:p>
+                  </a:txBody>
+                  <a:tcPr marL="91440" marR="91440" marT="45720" marB="45720">
+                    <a:solidFill>
+                      <a:srgbClr val="164C38"/>
+                    </a:solidFill>
+                  </a:tcPr>
+                </a:tc>
+              </a:tr>
+              <a:tr h="541020">
+                <a:tc>
+                  <a:txBody>
+                    <a:bodyPr/>
+                    <a:lstStyle/>
+                    <a:p>
+                      <a:pPr>
+                        <a:spcAft>
+                          <a:spcPts val="0"/>
+                        </a:spcAft>
+                        <a:defRPr sz="1500" b="0">
+                          <a:solidFill>
+                            <a:srgbClr val="092A20"/>
+                          </a:solidFill>
+                          <a:latin typeface="Arial"/>
+                        </a:defRPr>
+                      </a:pPr>
+                      <a:r>
+                        <a:t>Цена внесения, руб./га</a:t>
+                      </a:r>
+                    </a:p>
+                  </a:txBody>
+                  <a:tcPr marL="91440" marR="91440" marT="45720" marB="45720">
+                    <a:solidFill>
+                      <a:srgbClr val="FFFFFF"/>
+                    </a:solidFill>
+                  </a:tcPr>
+                </a:tc>
+                <a:tc>
+                  <a:txBody>
+                    <a:bodyPr/>
+                    <a:lstStyle/>
+                    <a:p>
+                      <a:pPr>
+                        <a:spcAft>
+                          <a:spcPts val="0"/>
+                        </a:spcAft>
+                        <a:defRPr sz="1500" b="0">
+                          <a:solidFill>
+                            <a:srgbClr val="092A20"/>
+                          </a:solidFill>
+                          <a:latin typeface="Arial"/>
+                        </a:defRPr>
+                      </a:pPr>
+                      <a:r>
+                        <a:t>1 300 без НДС</a:t>
+                      </a:r>
+                    </a:p>
+                  </a:txBody>
+                  <a:tcPr marL="91440" marR="91440" marT="45720" marB="45720">
+                    <a:solidFill>
+                      <a:srgbClr val="FFFFFF"/>
+                    </a:solidFill>
+                  </a:tcPr>
+                </a:tc>
+                <a:tc>
+                  <a:txBody>
+                    <a:bodyPr/>
+                    <a:lstStyle/>
+                    <a:p>
+                      <a:pPr>
+                        <a:spcAft>
+                          <a:spcPts val="0"/>
+                        </a:spcAft>
+                        <a:defRPr sz="1500" b="0">
+                          <a:solidFill>
+                            <a:srgbClr val="092A20"/>
+                          </a:solidFill>
+                          <a:latin typeface="Arial"/>
+                        </a:defRPr>
+                      </a:pPr>
+                      <a:r>
+                        <a:t>По запросу</a:t>
+                      </a:r>
+                    </a:p>
+                  </a:txBody>
+                  <a:tcPr marL="91440" marR="91440" marT="45720" marB="45720">
+                    <a:solidFill>
+                      <a:srgbClr val="FFFFFF"/>
+                    </a:solidFill>
+                  </a:tcPr>
+                </a:tc>
+                <a:tc>
+                  <a:txBody>
+                    <a:bodyPr/>
+                    <a:lstStyle/>
+                    <a:p>
+                      <a:pPr>
+                        <a:spcAft>
+                          <a:spcPts val="0"/>
+                        </a:spcAft>
+                        <a:defRPr sz="1500" b="0">
+                          <a:solidFill>
+                            <a:srgbClr val="092A20"/>
+                          </a:solidFill>
+                          <a:latin typeface="Arial"/>
+                        </a:defRPr>
+                      </a:pPr>
+                      <a:r>
+                        <a:t>900, средняя; состав уточняется</a:t>
+                      </a:r>
+                    </a:p>
+                  </a:txBody>
+                  <a:tcPr marL="91440" marR="91440" marT="45720" marB="45720">
+                    <a:solidFill>
+                      <a:srgbClr val="FFFFFF"/>
+                    </a:solidFill>
+                  </a:tcPr>
+                </a:tc>
+                <a:tc>
+                  <a:txBody>
+                    <a:bodyPr/>
+                    <a:lstStyle/>
+                    <a:p>
+                      <a:pPr>
+                        <a:spcAft>
+                          <a:spcPts val="0"/>
+                        </a:spcAft>
+                        <a:defRPr sz="1500" b="0">
+                          <a:solidFill>
+                            <a:srgbClr val="092A20"/>
+                          </a:solidFill>
+                          <a:latin typeface="Arial"/>
+                        </a:defRPr>
+                      </a:pPr>
+                      <a:r>
+                        <a:t>По запросу</a:t>
+                      </a:r>
+                    </a:p>
+                  </a:txBody>
+                  <a:tcPr marL="91440" marR="91440" marT="45720" marB="45720">
+                    <a:solidFill>
+                      <a:srgbClr val="FFFFFF"/>
+                    </a:solidFill>
+                  </a:tcPr>
+                </a:tc>
+              </a:tr>
+              <a:tr h="541020">
+                <a:tc>
+                  <a:txBody>
+                    <a:bodyPr/>
+                    <a:lstStyle/>
+                    <a:p>
+                      <a:pPr>
+                        <a:spcAft>
+                          <a:spcPts val="0"/>
+                        </a:spcAft>
+                        <a:defRPr sz="1500" b="0">
+                          <a:solidFill>
+                            <a:srgbClr val="092A20"/>
+                          </a:solidFill>
+                          <a:latin typeface="Arial"/>
+                        </a:defRPr>
+                      </a:pPr>
+                      <a:r>
+                        <a:t>Мониторинг + внесение</a:t>
+                      </a:r>
+                    </a:p>
+                  </a:txBody>
+                  <a:tcPr marL="91440" marR="91440" marT="45720" marB="45720">
+                    <a:solidFill>
+                      <a:srgbClr val="EFF4EF"/>
+                    </a:solidFill>
+                  </a:tcPr>
+                </a:tc>
+                <a:tc>
+                  <a:txBody>
+                    <a:bodyPr/>
+                    <a:lstStyle/>
+                    <a:p>
+                      <a:pPr>
+                        <a:spcAft>
+                          <a:spcPts val="0"/>
+                        </a:spcAft>
+                        <a:defRPr sz="1500" b="0">
+                          <a:solidFill>
+                            <a:srgbClr val="092A20"/>
+                          </a:solidFill>
+                          <a:latin typeface="Arial"/>
+                        </a:defRPr>
+                      </a:pPr>
+                      <a:r>
+                        <a:t>Один договор, план</a:t>
+                      </a:r>
+                    </a:p>
+                  </a:txBody>
+                  <a:tcPr marL="91440" marR="91440" marT="45720" marB="45720">
+                    <a:solidFill>
+                      <a:srgbClr val="EFF4EF"/>
+                    </a:solidFill>
+                  </a:tcPr>
+                </a:tc>
+                <a:tc>
+                  <a:txBody>
+                    <a:bodyPr/>
+                    <a:lstStyle/>
+                    <a:p>
+                      <a:pPr>
+                        <a:spcAft>
+                          <a:spcPts val="0"/>
+                        </a:spcAft>
+                        <a:defRPr sz="1500" b="0">
+                          <a:solidFill>
+                            <a:srgbClr val="092A20"/>
+                          </a:solidFill>
+                          <a:latin typeface="Arial"/>
+                        </a:defRPr>
+                      </a:pPr>
+                      <a:r>
+                        <a:t>Состав пакета уточняется</a:t>
+                      </a:r>
+                    </a:p>
+                  </a:txBody>
+                  <a:tcPr marL="91440" marR="91440" marT="45720" marB="45720">
+                    <a:solidFill>
+                      <a:srgbClr val="EFF4EF"/>
+                    </a:solidFill>
+                  </a:tcPr>
+                </a:tc>
+                <a:tc>
+                  <a:txBody>
+                    <a:bodyPr/>
+                    <a:lstStyle/>
+                    <a:p>
+                      <a:pPr>
+                        <a:spcAft>
+                          <a:spcPts val="0"/>
+                        </a:spcAft>
+                        <a:defRPr sz="1500" b="0">
+                          <a:solidFill>
+                            <a:srgbClr val="092A20"/>
+                          </a:solidFill>
+                          <a:latin typeface="Arial"/>
+                        </a:defRPr>
+                      </a:pPr>
+                      <a:r>
+                        <a:t>Мониторинг не подтвержден</a:t>
+                      </a:r>
+                    </a:p>
+                  </a:txBody>
+                  <a:tcPr marL="91440" marR="91440" marT="45720" marB="45720">
+                    <a:solidFill>
+                      <a:srgbClr val="EFF4EF"/>
+                    </a:solidFill>
+                  </a:tcPr>
+                </a:tc>
+                <a:tc>
+                  <a:txBody>
+                    <a:bodyPr/>
+                    <a:lstStyle/>
+                    <a:p>
+                      <a:pPr>
+                        <a:spcAft>
+                          <a:spcPts val="0"/>
+                        </a:spcAft>
+                        <a:defRPr sz="1500" b="0">
+                          <a:solidFill>
+                            <a:srgbClr val="092A20"/>
+                          </a:solidFill>
+                          <a:latin typeface="Arial"/>
+                        </a:defRPr>
+                      </a:pPr>
+                      <a:r>
+                        <a:t>Оба направления заявлены</a:t>
+                      </a:r>
+                    </a:p>
+                  </a:txBody>
+                  <a:tcPr marL="91440" marR="91440" marT="45720" marB="45720">
+                    <a:solidFill>
+                      <a:srgbClr val="EFF4EF"/>
+                    </a:solidFill>
+                  </a:tcPr>
+                </a:tc>
+              </a:tr>
+              <a:tr h="541020">
+                <a:tc>
+                  <a:txBody>
+                    <a:bodyPr/>
+                    <a:lstStyle/>
+                    <a:p>
+                      <a:pPr>
+                        <a:spcAft>
+                          <a:spcPts val="0"/>
+                        </a:spcAft>
+                        <a:defRPr sz="1500" b="0">
+                          <a:solidFill>
+                            <a:srgbClr val="092A20"/>
+                          </a:solidFill>
+                          <a:latin typeface="Arial"/>
+                        </a:defRPr>
+                      </a:pPr>
+                      <a:r>
+                        <a:t>Локальная доступность</a:t>
+                      </a:r>
+                    </a:p>
+                  </a:txBody>
+                  <a:tcPr marL="91440" marR="91440" marT="45720" marB="45720">
+                    <a:solidFill>
+                      <a:srgbClr val="FFFFFF"/>
+                    </a:solidFill>
+                  </a:tcPr>
+                </a:tc>
+                <a:tc>
+                  <a:txBody>
+                    <a:bodyPr/>
+                    <a:lstStyle/>
+                    <a:p>
+                      <a:pPr>
+                        <a:spcAft>
+                          <a:spcPts val="0"/>
+                        </a:spcAft>
+                        <a:defRPr sz="1500" b="0">
+                          <a:solidFill>
+                            <a:srgbClr val="092A20"/>
+                          </a:solidFill>
+                          <a:latin typeface="Arial"/>
+                        </a:defRPr>
+                      </a:pPr>
+                      <a:r>
+                        <a:t>Татарстан, до 150 км; условно</a:t>
+                      </a:r>
+                    </a:p>
+                  </a:txBody>
+                  <a:tcPr marL="91440" marR="91440" marT="45720" marB="45720">
+                    <a:solidFill>
+                      <a:srgbClr val="FFFFFF"/>
+                    </a:solidFill>
+                  </a:tcPr>
+                </a:tc>
+                <a:tc>
+                  <a:txBody>
+                    <a:bodyPr/>
+                    <a:lstStyle/>
+                    <a:p>
+                      <a:pPr>
+                        <a:spcAft>
+                          <a:spcPts val="0"/>
+                        </a:spcAft>
+                        <a:defRPr sz="1500" b="0">
+                          <a:solidFill>
+                            <a:srgbClr val="092A20"/>
+                          </a:solidFill>
+                          <a:latin typeface="Arial"/>
+                        </a:defRPr>
+                      </a:pPr>
+                      <a:r>
+                        <a:t>Татарстан заявлен</a:t>
+                      </a:r>
+                    </a:p>
+                  </a:txBody>
+                  <a:tcPr marL="91440" marR="91440" marT="45720" marB="45720">
+                    <a:solidFill>
+                      <a:srgbClr val="FFFFFF"/>
+                    </a:solidFill>
+                  </a:tcPr>
+                </a:tc>
+                <a:tc>
+                  <a:txBody>
+                    <a:bodyPr/>
+                    <a:lstStyle/>
+                    <a:p>
+                      <a:pPr>
+                        <a:spcAft>
+                          <a:spcPts val="0"/>
+                        </a:spcAft>
+                        <a:defRPr sz="1500" b="0">
+                          <a:solidFill>
+                            <a:srgbClr val="092A20"/>
+                          </a:solidFill>
+                          <a:latin typeface="Arial"/>
+                        </a:defRPr>
+                      </a:pPr>
+                      <a:r>
+                        <a:t>ЮФО</a:t>
+                      </a:r>
+                    </a:p>
+                  </a:txBody>
+                  <a:tcPr marL="91440" marR="91440" marT="45720" marB="45720">
+                    <a:solidFill>
+                      <a:srgbClr val="FFFFFF"/>
+                    </a:solidFill>
+                  </a:tcPr>
+                </a:tc>
+                <a:tc>
+                  <a:txBody>
+                    <a:bodyPr/>
+                    <a:lstStyle/>
+                    <a:p>
+                      <a:pPr>
+                        <a:spcAft>
+                          <a:spcPts val="0"/>
+                        </a:spcAft>
+                        <a:defRPr sz="1500" b="0">
+                          <a:solidFill>
+                            <a:srgbClr val="092A20"/>
+                          </a:solidFill>
+                          <a:latin typeface="Arial"/>
+                        </a:defRPr>
+                      </a:pPr>
+                      <a:r>
+                        <a:t>Краснодар / Адыгея</a:t>
+                      </a:r>
+                    </a:p>
+                  </a:txBody>
+                  <a:tcPr marL="91440" marR="91440" marT="45720" marB="45720">
+                    <a:solidFill>
+                      <a:srgbClr val="FFFFFF"/>
+                    </a:solidFill>
+                  </a:tcPr>
+                </a:tc>
+              </a:tr>
+              <a:tr h="541020">
+                <a:tc>
+                  <a:txBody>
+                    <a:bodyPr/>
+                    <a:lstStyle/>
+                    <a:p>
+                      <a:pPr>
+                        <a:spcAft>
+                          <a:spcPts val="0"/>
+                        </a:spcAft>
+                        <a:defRPr sz="1500" b="0">
+                          <a:solidFill>
+                            <a:srgbClr val="092A20"/>
+                          </a:solidFill>
+                          <a:latin typeface="Arial"/>
+                        </a:defRPr>
+                      </a:pPr>
+                      <a:r>
+                        <a:t>Минимальный маршрут</a:t>
+                      </a:r>
+                    </a:p>
+                  </a:txBody>
+                  <a:tcPr marL="91440" marR="91440" marT="45720" marB="45720">
+                    <a:solidFill>
+                      <a:srgbClr val="EFF4EF"/>
+                    </a:solidFill>
+                  </a:tcPr>
+                </a:tc>
+                <a:tc>
+                  <a:txBody>
+                    <a:bodyPr/>
+                    <a:lstStyle/>
+                    <a:p>
+                      <a:pPr>
+                        <a:spcAft>
+                          <a:spcPts val="0"/>
+                        </a:spcAft>
+                        <a:defRPr sz="1500" b="0">
+                          <a:solidFill>
+                            <a:srgbClr val="092A20"/>
+                          </a:solidFill>
+                          <a:latin typeface="Arial"/>
+                        </a:defRPr>
+                      </a:pPr>
+                      <a:r>
+                        <a:t>100 га-проходов, план</a:t>
+                      </a:r>
+                    </a:p>
+                  </a:txBody>
+                  <a:tcPr marL="91440" marR="91440" marT="45720" marB="45720">
+                    <a:solidFill>
+                      <a:srgbClr val="EFF4EF"/>
+                    </a:solidFill>
+                  </a:tcPr>
+                </a:tc>
+                <a:tc>
+                  <a:txBody>
+                    <a:bodyPr/>
+                    <a:lstStyle/>
+                    <a:p>
+                      <a:pPr>
+                        <a:spcAft>
+                          <a:spcPts val="0"/>
+                        </a:spcAft>
+                        <a:defRPr sz="1500" b="0">
+                          <a:solidFill>
+                            <a:srgbClr val="092A20"/>
+                          </a:solidFill>
+                          <a:latin typeface="Arial"/>
+                        </a:defRPr>
+                      </a:pPr>
+                      <a:r>
+                        <a:t>Не раскрыт</a:t>
+                      </a:r>
+                    </a:p>
+                  </a:txBody>
+                  <a:tcPr marL="91440" marR="91440" marT="45720" marB="45720">
+                    <a:solidFill>
+                      <a:srgbClr val="EFF4EF"/>
+                    </a:solidFill>
+                  </a:tcPr>
+                </a:tc>
+                <a:tc>
+                  <a:txBody>
+                    <a:bodyPr/>
+                    <a:lstStyle/>
+                    <a:p>
+                      <a:pPr>
+                        <a:spcAft>
+                          <a:spcPts val="0"/>
+                        </a:spcAft>
+                        <a:defRPr sz="1500" b="0">
+                          <a:solidFill>
+                            <a:srgbClr val="092A20"/>
+                          </a:solidFill>
+                          <a:latin typeface="Arial"/>
+                        </a:defRPr>
+                      </a:pPr>
+                      <a:r>
+                        <a:t>Не раскрыт</a:t>
+                      </a:r>
+                    </a:p>
+                  </a:txBody>
+                  <a:tcPr marL="91440" marR="91440" marT="45720" marB="45720">
+                    <a:solidFill>
+                      <a:srgbClr val="EFF4EF"/>
+                    </a:solidFill>
+                  </a:tcPr>
+                </a:tc>
+                <a:tc>
+                  <a:txBody>
+                    <a:bodyPr/>
+                    <a:lstStyle/>
+                    <a:p>
+                      <a:pPr>
+                        <a:spcAft>
+                          <a:spcPts val="0"/>
+                        </a:spcAft>
+                        <a:defRPr sz="1500" b="0">
+                          <a:solidFill>
+                            <a:srgbClr val="092A20"/>
+                          </a:solidFill>
+                          <a:latin typeface="Arial"/>
+                        </a:defRPr>
+                      </a:pPr>
+                      <a:r>
+                        <a:t>Не раскрыт</a:t>
+                      </a:r>
+                    </a:p>
+                  </a:txBody>
+                  <a:tcPr marL="91440" marR="91440" marT="45720" marB="45720">
+                    <a:solidFill>
+                      <a:srgbClr val="EFF4EF"/>
+                    </a:solidFill>
+                  </a:tcPr>
+                </a:tc>
+              </a:tr>
+              <a:tr h="541020">
+                <a:tc>
+                  <a:txBody>
+                    <a:bodyPr/>
+                    <a:lstStyle/>
+                    <a:p>
+                      <a:pPr>
+                        <a:spcAft>
+                          <a:spcPts val="0"/>
+                        </a:spcAft>
+                        <a:defRPr sz="1500" b="0">
+                          <a:solidFill>
+                            <a:srgbClr val="092A20"/>
+                          </a:solidFill>
+                          <a:latin typeface="Arial"/>
+                        </a:defRPr>
+                      </a:pPr>
+                      <a:r>
+                        <a:t>Срок отчета</a:t>
+                      </a:r>
+                    </a:p>
+                  </a:txBody>
+                  <a:tcPr marL="91440" marR="91440" marT="45720" marB="45720">
+                    <a:solidFill>
+                      <a:srgbClr val="FFFFFF"/>
+                    </a:solidFill>
+                  </a:tcPr>
+                </a:tc>
+                <a:tc>
+                  <a:txBody>
+                    <a:bodyPr/>
+                    <a:lstStyle/>
+                    <a:p>
+                      <a:pPr>
+                        <a:spcAft>
+                          <a:spcPts val="0"/>
+                        </a:spcAft>
+                        <a:defRPr sz="1500" b="0">
+                          <a:solidFill>
+                            <a:srgbClr val="092A20"/>
+                          </a:solidFill>
+                          <a:latin typeface="Arial"/>
+                        </a:defRPr>
+                      </a:pPr>
+                      <a:r>
+                        <a:t>Не более 48 часов, цель</a:t>
+                      </a:r>
+                    </a:p>
+                  </a:txBody>
+                  <a:tcPr marL="91440" marR="91440" marT="45720" marB="45720">
+                    <a:solidFill>
+                      <a:srgbClr val="FFFFFF"/>
+                    </a:solidFill>
+                  </a:tcPr>
+                </a:tc>
+                <a:tc>
+                  <a:txBody>
+                    <a:bodyPr/>
+                    <a:lstStyle/>
+                    <a:p>
+                      <a:pPr>
+                        <a:spcAft>
+                          <a:spcPts val="0"/>
+                        </a:spcAft>
+                        <a:defRPr sz="1500" b="0">
+                          <a:solidFill>
+                            <a:srgbClr val="092A20"/>
+                          </a:solidFill>
+                          <a:latin typeface="Arial"/>
+                        </a:defRPr>
+                      </a:pPr>
+                      <a:r>
+                        <a:t>Не раскрыт</a:t>
+                      </a:r>
+                    </a:p>
+                  </a:txBody>
+                  <a:tcPr marL="91440" marR="91440" marT="45720" marB="45720">
+                    <a:solidFill>
+                      <a:srgbClr val="FFFFFF"/>
+                    </a:solidFill>
+                  </a:tcPr>
+                </a:tc>
+                <a:tc>
+                  <a:txBody>
+                    <a:bodyPr/>
+                    <a:lstStyle/>
+                    <a:p>
+                      <a:pPr>
+                        <a:spcAft>
+                          <a:spcPts val="0"/>
+                        </a:spcAft>
+                        <a:defRPr sz="1500" b="0">
+                          <a:solidFill>
+                            <a:srgbClr val="092A20"/>
+                          </a:solidFill>
+                          <a:latin typeface="Arial"/>
+                        </a:defRPr>
+                      </a:pPr>
+                      <a:r>
+                        <a:t>Акты заявлены; срок не раскрыт</a:t>
+                      </a:r>
+                    </a:p>
+                  </a:txBody>
+                  <a:tcPr marL="91440" marR="91440" marT="45720" marB="45720">
+                    <a:solidFill>
+                      <a:srgbClr val="FFFFFF"/>
+                    </a:solidFill>
+                  </a:tcPr>
+                </a:tc>
+                <a:tc>
+                  <a:txBody>
+                    <a:bodyPr/>
+                    <a:lstStyle/>
+                    <a:p>
+                      <a:pPr>
+                        <a:spcAft>
+                          <a:spcPts val="0"/>
+                        </a:spcAft>
+                        <a:defRPr sz="1500" b="0">
+                          <a:solidFill>
+                            <a:srgbClr val="092A20"/>
+                          </a:solidFill>
+                          <a:latin typeface="Arial"/>
+                        </a:defRPr>
+                      </a:pPr>
+                      <a:r>
+                        <a:t>Не раскрыт</a:t>
+                      </a:r>
+                    </a:p>
+                  </a:txBody>
+                  <a:tcPr marL="91440" marR="91440" marT="45720" marB="45720">
+                    <a:solidFill>
+                      <a:srgbClr val="FFFFFF"/>
+                    </a:solidFill>
+                  </a:tcPr>
+                </a:tc>
+              </a:tr>
+            </a:tbl>
           </a:graphicData>
         </a:graphic>
       </p:graphicFrame>
       <p:sp>
         <p:nvSpPr>
-          <p:cNvPr id="10" name="Rounded Rectangle 9"/>
+          <p:cNvPr id="9" name="Rounded Rectangle 8"/>
           <p:cNvSpPr/>
           <p:nvPr/>
         </p:nvSpPr>
@@ -28142,7 +28862,7 @@
       </p:sp>
       <p:sp>
         <p:nvSpPr>
-          <p:cNvPr id="11" name="TextBox 10"/>
+          <p:cNvPr id="10" name="TextBox 9"/>
           <p:cNvSpPr txBox="1"/>
           <p:nvPr/>
         </p:nvSpPr>
@@ -28177,7 +28897,7 @@
               </a:defRPr>
             </a:pPr>
             <a:r>
-              <a:t>Препараты клиента; без обещания роста урожая. Орошение и продажа дронов не входят</a:t>
+              <a:t>Цель проекта — не достигнутое преимущество. Нераскрытая характеристика — не недостаток</a:t>
             </a:r>
           </a:p>
         </p:txBody>
@@ -30637,7 +31357,7 @@
               </a:defRPr>
             </a:pPr>
             <a:r>
-              <a:t>Воронка: 100 контактов → 40 разговоров → 20 предложений → 10 клиентов.</a:t>
+              <a:t>SOM / SAM: 7,07% выручки; 6,67% внесения; 13,33% мониторинга.</a:t>
             </a:r>
           </a:p>
           <a:p>
@@ -30656,7 +31376,7 @@
               </a:defRPr>
             </a:pPr>
             <a:r>
-              <a:t>[ФАКТ] Публикации об отрасли имеют разные оценки; не используются как база TAM.</a:t>
+              <a:t>2 000 / 200 хозяйств — гипотезы, не реестр. Микс SOM отличается от SAM.</a:t>
             </a:r>
           </a:p>
         </p:txBody>

</xml_diff>

<commit_message>
Reconcile AgroVector competitors, schedule and funding scenarios
</commit_message>
<xml_diff>
--- a/presentations/AGROVECTOR_22_SLIDES.pptx
+++ b/presentations/AGROVECTOR_22_SLIDES.pptx
@@ -1564,7 +1564,7 @@
           <a:p/>
           <a:p>
             <a:r>
-              <a:t>[ДОПУЩЕНИЕ] Отдельный пакет M предусматривает восемь недель предсезонной готовности и ожидания погодного окна после J. Приемочные испытания I не подменяются зимней коммерческой обработкой; полевой пилот включается в апрельский сезон. Закупка не разрешает автоматически начинать работы: необходима готовность по G и контроль перед конкретным выездом.</a:t>
+              <a:t>[ДОПУЩЕНИЕ] Отдельный пакет M предусматривает три недели предсезонной готовности и ожидания погодного окна после J. Приемочные испытания I не подменяются зимней коммерческой обработкой; полевой пилот включается в апрельский сезон. Закупка не разрешает автоматически начинать работы: необходима готовность по G и контроль перед конкретным выездом.</a:t>
             </a:r>
           </a:p>
           <a:p/>
@@ -1585,7 +1585,7 @@
           </a:p>
           <a:p>
             <a:r>
-              <a:t>| 1.2 | B | Интервью и предварительные заявки хозяйств | 20 интервью; заявки на 6000 га-проходов |</a:t>
+              <a:t>| 1.2 | B | Интервью и предварительные заявки хозяйств | 20 интервью; заявки на 6000 га-проходов и 4000 га-обследований |</a:t>
             </a:r>
           </a:p>
           <a:p>
@@ -1595,7 +1595,7 @@
           </a:p>
           <a:p>
             <a:r>
-              <a:t>| 2.1 | D | Инвестиционное решение и финансирование | 9.5 млн руб.; пройден юридический gate |</a:t>
+              <a:t>| 2.1 | D | Инвестиционное решение и финансирование | 9,5 млн руб. только для базы; КП и спрос подтверждены; при удорожании отдельное решение |</a:t>
             </a:r>
           </a:p>
           <a:p>
@@ -1721,7 +1721,7 @@
           <a:lstStyle/>
           <a:p>
             <a:r>
-              <a:t>[ДОПУЩЕНИЕ] Диаграмма Ганта должна строиться из того же набора задач, длительностей и зависимостей, что WBS и сетевой график. Базовый старт коммерческого сезона — 12 апреля 2027 года после восьминедельного пакета M; продолжительность сезона K — 22 недели. Это плановый ориентир, а не гарантия летной доступности.</a:t>
+              <a:t>[ДОПУЩЕНИЕ] Диаграмма Ганта должна строиться из того же набора задач, длительностей и зависимостей, что WBS и сетевой график. Базовый старт коммерческого сезона — 12 апреля 2027 года после трехнедельного пакета M; продолжительность сезона K — 22 недели. Это плановый ориентир, а не гарантия летной доступности.</a:t>
             </a:r>
           </a:p>
           <a:p/>
@@ -1733,7 +1733,7 @@
           <a:p/>
           <a:p>
             <a:r>
-              <a:t>[РАСЧЕТ] Календарь в календарных неделях; связи finish-to-start. Начало подготовки 07.09.2026. Даты — план, не выданные разрешения.</a:t>
+              <a:t>[РАСЧЕТ] Календарь в календарных неделях; связи окончание–начало. Перепланирование от 2026-10-19; прежние сентябрьские даты не означают выполненные работы. Даты — целевой план, не выданные разрешения. При задержке критического пути коммерческое окно и денежная модель пересматриваются.</a:t>
             </a:r>
           </a:p>
           <a:p/>
@@ -1749,57 +1749,57 @@
           </a:p>
           <a:p>
             <a:r>
-              <a:t>| A | 2026-09-07 | 2026-10-04 | 4 | 0 |</a:t>
-            </a:r>
-          </a:p>
-          <a:p>
-            <a:r>
-              <a:t>| B | 2026-09-07 | 2026-10-11 | 5 | 2 |</a:t>
-            </a:r>
-          </a:p>
-          <a:p>
-            <a:r>
-              <a:t>| C | 2026-10-05 | 2026-10-25 | 3 | 0 |</a:t>
-            </a:r>
-          </a:p>
-          <a:p>
-            <a:r>
-              <a:t>| D | 2026-10-26 | 2026-11-01 | 1 | 0 |</a:t>
-            </a:r>
-          </a:p>
-          <a:p>
-            <a:r>
-              <a:t>| E | 2026-11-02 | 2026-12-06 | 5 | 0 |</a:t>
-            </a:r>
-          </a:p>
-          <a:p>
-            <a:r>
-              <a:t>| F | 2026-11-02 | 2026-12-13 | 6 | 2 |</a:t>
-            </a:r>
-          </a:p>
-          <a:p>
-            <a:r>
-              <a:t>| G | 2026-12-07 | 2027-01-17 | 6 | 0 |</a:t>
-            </a:r>
-          </a:p>
-          <a:p>
-            <a:r>
-              <a:t>| H | 2026-12-14 | 2027-01-03 | 3 | 2 |</a:t>
-            </a:r>
-          </a:p>
-          <a:p>
-            <a:r>
-              <a:t>| I | 2027-01-18 | 2027-01-31 | 2 | 0 |</a:t>
-            </a:r>
-          </a:p>
-          <a:p>
-            <a:r>
-              <a:t>| J | 2027-02-01 | 2027-02-14 | 2 | 0 |</a:t>
-            </a:r>
-          </a:p>
-          <a:p>
-            <a:r>
-              <a:t>| M | 2027-02-15 | 2027-04-11 | 8 | 0 |</a:t>
+              <a:t>| A | 2026-10-19 | 2026-11-01 | 2 | 1 |</a:t>
+            </a:r>
+          </a:p>
+          <a:p>
+            <a:r>
+              <a:t>| B | 2026-10-19 | 2026-11-29 | 6 | 0 |</a:t>
+            </a:r>
+          </a:p>
+          <a:p>
+            <a:r>
+              <a:t>| C | 2026-11-02 | 2026-11-22 | 3 | 1 |</a:t>
+            </a:r>
+          </a:p>
+          <a:p>
+            <a:r>
+              <a:t>| D | 2026-11-30 | 2026-12-06 | 1 | 0 |</a:t>
+            </a:r>
+          </a:p>
+          <a:p>
+            <a:r>
+              <a:t>| E | 2026-12-07 | 2027-01-10 | 5 | 0 |</a:t>
+            </a:r>
+          </a:p>
+          <a:p>
+            <a:r>
+              <a:t>| F | 2026-12-07 | 2027-01-17 | 6 | 2 |</a:t>
+            </a:r>
+          </a:p>
+          <a:p>
+            <a:r>
+              <a:t>| G | 2027-01-11 | 2027-02-21 | 6 | 0 |</a:t>
+            </a:r>
+          </a:p>
+          <a:p>
+            <a:r>
+              <a:t>| H | 2027-01-18 | 2027-02-07 | 3 | 2 |</a:t>
+            </a:r>
+          </a:p>
+          <a:p>
+            <a:r>
+              <a:t>| I | 2027-02-22 | 2027-03-07 | 2 | 0 |</a:t>
+            </a:r>
+          </a:p>
+          <a:p>
+            <a:r>
+              <a:t>| J | 2027-03-08 | 2027-03-21 | 2 | 0 |</a:t>
+            </a:r>
+          </a:p>
+          <a:p>
+            <a:r>
+              <a:t>| M | 2027-03-22 | 2027-04-11 | 3 | 0 |</a:t>
             </a:r>
           </a:p>
           <a:p>
@@ -1835,57 +1835,57 @@
           </a:p>
           <a:p>
             <a:r>
-              <a:t>    A Проверка региона, полетов и схемы АХР :crit, A, 2026-09-07, 28 d</a:t>
-            </a:r>
-          </a:p>
-          <a:p>
-            <a:r>
-              <a:t>    B Интервью и предварительные заявки хозяйств :B, 2026-09-07, 35 d</a:t>
-            </a:r>
-          </a:p>
-          <a:p>
-            <a:r>
-              <a:t>    C ООО, договоры, учет и страховой проект :crit, C, 2026-10-05, 21 d</a:t>
-            </a:r>
-          </a:p>
-          <a:p>
-            <a:r>
-              <a:t>    D Инвестиционное решение и финансирование :crit, D, 2026-10-26, 7 d</a:t>
-            </a:r>
-          </a:p>
-          <a:p>
-            <a:r>
-              <a:t>    E Закупка и приемка оборудования :crit, E, 2026-11-02, 35 d</a:t>
-            </a:r>
-          </a:p>
-          <a:p>
-            <a:r>
-              <a:t>    F Подбор и гражданская переподготовка :F, 2026-11-02, 42 d</a:t>
-            </a:r>
-          </a:p>
-          <a:p>
-            <a:r>
-              <a:t>    G Разрешительная готовность и учет БВС :crit, G, 2026-12-07, 42 d</a:t>
-            </a:r>
-          </a:p>
-          <a:p>
-            <a:r>
-              <a:t>    H SOP, CRM, карты и контроль качества :H, 2026-12-14, 21 d</a:t>
-            </a:r>
-          </a:p>
-          <a:p>
-            <a:r>
-              <a:t>    I Стендовые и контролируемые приемочные испытания :crit, I, 2027-01-18, 14 d</a:t>
-            </a:r>
-          </a:p>
-          <a:p>
-            <a:r>
-              <a:t>    J Сезонные договоры и маршрутизация :crit, J, 2027-02-01, 14 d</a:t>
-            </a:r>
-          </a:p>
-          <a:p>
-            <a:r>
-              <a:t>    M Предсезонная готовность и ожидание погодного окна :crit, M, 2027-02-15, 56 d</a:t>
+              <a:t>    A Проверка региона, полетов и схемы АХР :A, 2026-10-19, 14 d</a:t>
+            </a:r>
+          </a:p>
+          <a:p>
+            <a:r>
+              <a:t>    B Интервью и предварительные заявки хозяйств :crit, B, 2026-10-19, 42 d</a:t>
+            </a:r>
+          </a:p>
+          <a:p>
+            <a:r>
+              <a:t>    C ООО, договоры, учет и страховой проект :C, 2026-11-02, 21 d</a:t>
+            </a:r>
+          </a:p>
+          <a:p>
+            <a:r>
+              <a:t>    D Инвестиционное решение и финансирование :crit, D, 2026-11-30, 7 d</a:t>
+            </a:r>
+          </a:p>
+          <a:p>
+            <a:r>
+              <a:t>    E Закупка и приемка оборудования :crit, E, 2026-12-07, 35 d</a:t>
+            </a:r>
+          </a:p>
+          <a:p>
+            <a:r>
+              <a:t>    F Подбор и гражданская переподготовка :F, 2026-12-07, 42 d</a:t>
+            </a:r>
+          </a:p>
+          <a:p>
+            <a:r>
+              <a:t>    G Разрешительная готовность и учет БВС :crit, G, 2027-01-11, 42 d</a:t>
+            </a:r>
+          </a:p>
+          <a:p>
+            <a:r>
+              <a:t>    H SOP, CRM, карты и контроль качества :H, 2027-01-18, 21 d</a:t>
+            </a:r>
+          </a:p>
+          <a:p>
+            <a:r>
+              <a:t>    I Стендовые и контролируемые приемочные испытания :crit, I, 2027-02-22, 14 d</a:t>
+            </a:r>
+          </a:p>
+          <a:p>
+            <a:r>
+              <a:t>    J Сезонные договоры и маршрутизация :crit, J, 2027-03-08, 14 d</a:t>
+            </a:r>
+          </a:p>
+          <a:p>
+            <a:r>
+              <a:t>    M Предсезонная готовность и ожидание погодного окна :crit, M, 2027-03-22, 21 d</a:t>
             </a:r>
           </a:p>
           <a:p>
@@ -1993,7 +1993,7 @@
           <a:p/>
           <a:p>
             <a:r>
-              <a:t>[РАСЧЕТ] Критический путь: **A → C → D → E → G → I → J → M → K → L**. Продолжительность 55 недель, включая погодный буфер M и первый сезон K. Это плановый CPM, не прогноз срока выдачи документов.</a:t>
+              <a:t>[РАСЧЕТ] Критический путь: **B → D → E → G → I → J → M → K → L**. Продолжительность 49 недель, включая погодный буфер M и первый сезон K. Это плановый CPM, не прогноз срока выдачи документов.</a:t>
             </a:r>
           </a:p>
           <a:p/>
@@ -2009,67 +2009,67 @@
           </a:p>
           <a:p>
             <a:r>
-              <a:t>| A | — | 0 | 4 | 0 | 4 | 0 |</a:t>
-            </a:r>
-          </a:p>
-          <a:p>
-            <a:r>
-              <a:t>| B | — | 0 | 5 | 2 | 7 | 2 |</a:t>
-            </a:r>
-          </a:p>
-          <a:p>
-            <a:r>
-              <a:t>| C | A | 4 | 7 | 4 | 7 | 0 |</a:t>
-            </a:r>
-          </a:p>
-          <a:p>
-            <a:r>
-              <a:t>| D | B;C | 7 | 8 | 7 | 8 | 0 |</a:t>
-            </a:r>
-          </a:p>
-          <a:p>
-            <a:r>
-              <a:t>| E | D | 8 | 13 | 8 | 13 | 0 |</a:t>
-            </a:r>
-          </a:p>
-          <a:p>
-            <a:r>
-              <a:t>| F | D | 8 | 14 | 10 | 16 | 2 |</a:t>
-            </a:r>
-          </a:p>
-          <a:p>
-            <a:r>
-              <a:t>| G | E | 13 | 19 | 13 | 19 | 0 |</a:t>
-            </a:r>
-          </a:p>
-          <a:p>
-            <a:r>
-              <a:t>| H | E;F | 14 | 17 | 16 | 19 | 2 |</a:t>
-            </a:r>
-          </a:p>
-          <a:p>
-            <a:r>
-              <a:t>| I | G;H | 19 | 21 | 19 | 21 | 0 |</a:t>
-            </a:r>
-          </a:p>
-          <a:p>
-            <a:r>
-              <a:t>| J | I | 21 | 23 | 21 | 23 | 0 |</a:t>
-            </a:r>
-          </a:p>
-          <a:p>
-            <a:r>
-              <a:t>| M | J | 23 | 31 | 23 | 31 | 0 |</a:t>
-            </a:r>
-          </a:p>
-          <a:p>
-            <a:r>
-              <a:t>| K | M | 31 | 53 | 31 | 53 | 0 |</a:t>
-            </a:r>
-          </a:p>
-          <a:p>
-            <a:r>
-              <a:t>| L | K | 53 | 55 | 53 | 55 | 0 |</a:t>
+              <a:t>| A | — | 0 | 2 | 1 | 3 | 1 |</a:t>
+            </a:r>
+          </a:p>
+          <a:p>
+            <a:r>
+              <a:t>| B | — | 0 | 6 | 0 | 6 | 0 |</a:t>
+            </a:r>
+          </a:p>
+          <a:p>
+            <a:r>
+              <a:t>| C | A | 2 | 5 | 3 | 6 | 1 |</a:t>
+            </a:r>
+          </a:p>
+          <a:p>
+            <a:r>
+              <a:t>| D | B;C | 6 | 7 | 6 | 7 | 0 |</a:t>
+            </a:r>
+          </a:p>
+          <a:p>
+            <a:r>
+              <a:t>| E | D | 7 | 12 | 7 | 12 | 0 |</a:t>
+            </a:r>
+          </a:p>
+          <a:p>
+            <a:r>
+              <a:t>| F | D | 7 | 13 | 9 | 15 | 2 |</a:t>
+            </a:r>
+          </a:p>
+          <a:p>
+            <a:r>
+              <a:t>| G | E | 12 | 18 | 12 | 18 | 0 |</a:t>
+            </a:r>
+          </a:p>
+          <a:p>
+            <a:r>
+              <a:t>| H | E;F | 13 | 16 | 15 | 18 | 2 |</a:t>
+            </a:r>
+          </a:p>
+          <a:p>
+            <a:r>
+              <a:t>| I | G;H | 18 | 20 | 18 | 20 | 0 |</a:t>
+            </a:r>
+          </a:p>
+          <a:p>
+            <a:r>
+              <a:t>| J | I | 20 | 22 | 20 | 22 | 0 |</a:t>
+            </a:r>
+          </a:p>
+          <a:p>
+            <a:r>
+              <a:t>| M | J | 22 | 25 | 22 | 25 | 0 |</a:t>
+            </a:r>
+          </a:p>
+          <a:p>
+            <a:r>
+              <a:t>| K | M | 25 | 47 | 25 | 47 | 0 |</a:t>
+            </a:r>
+          </a:p>
+          <a:p>
+            <a:r>
+              <a:t>| L | K | 47 | 49 | 47 | 49 | 0 |</a:t>
             </a:r>
           </a:p>
           <a:p/>
@@ -2085,12 +2085,12 @@
           </a:p>
           <a:p>
             <a:r>
-              <a:t>    A["A: 4 нед."]</a:t>
-            </a:r>
-          </a:p>
-          <a:p>
-            <a:r>
-              <a:t>    B["B: 5 нед."]</a:t>
+              <a:t>    A["A: 2 нед."]</a:t>
+            </a:r>
+          </a:p>
+          <a:p>
+            <a:r>
+              <a:t>    B["B: 6 нед."]</a:t>
             </a:r>
           </a:p>
           <a:p>
@@ -2190,7 +2190,7 @@
           </a:p>
           <a:p>
             <a:r>
-              <a:t>    M["M: 8 нед."]</a:t>
+              <a:t>    M["M: 3 нед."]</a:t>
             </a:r>
           </a:p>
           <a:p>
@@ -2236,67 +2236,67 @@
           </a:p>
           <a:p>
             <a:r>
-              <a:t>A Проверка региона, полетов и схемы АХР: предшественники нет, ES 0, EF 4, LS 0, LF 4, резерв 0</a:t>
-            </a:r>
-          </a:p>
-          <a:p>
-            <a:r>
-              <a:t>B Интервью и предварительные заявки хозяйств: предшественники нет, ES 0, EF 5, LS 2, LF 7, резерв 2</a:t>
-            </a:r>
-          </a:p>
-          <a:p>
-            <a:r>
-              <a:t>C ООО, договоры, учет и страховой проект: предшественники A, ES 4, EF 7, LS 4, LF 7, резерв 0</a:t>
-            </a:r>
-          </a:p>
-          <a:p>
-            <a:r>
-              <a:t>D Инвестиционное решение и финансирование: предшественники B;C, ES 7, EF 8, LS 7, LF 8, резерв 0</a:t>
-            </a:r>
-          </a:p>
-          <a:p>
-            <a:r>
-              <a:t>E Закупка и приемка оборудования: предшественники D, ES 8, EF 13, LS 8, LF 13, резерв 0</a:t>
-            </a:r>
-          </a:p>
-          <a:p>
-            <a:r>
-              <a:t>F Подбор и гражданская переподготовка: предшественники D, ES 8, EF 14, LS 10, LF 16, резерв 2</a:t>
-            </a:r>
-          </a:p>
-          <a:p>
-            <a:r>
-              <a:t>G Разрешительная готовность и учет БВС: предшественники E, ES 13, EF 19, LS 13, LF 19, резерв 0</a:t>
-            </a:r>
-          </a:p>
-          <a:p>
-            <a:r>
-              <a:t>H SOP, CRM, карты и контроль качества: предшественники E;F, ES 14, EF 17, LS 16, LF 19, резерв 2</a:t>
-            </a:r>
-          </a:p>
-          <a:p>
-            <a:r>
-              <a:t>I Стендовые и контролируемые приемочные испытания: предшественники G;H, ES 19, EF 21, LS 19, LF 21, резерв 0</a:t>
-            </a:r>
-          </a:p>
-          <a:p>
-            <a:r>
-              <a:t>J Сезонные договоры и маршрутизация: предшественники I, ES 21, EF 23, LS 21, LF 23, резерв 0</a:t>
-            </a:r>
-          </a:p>
-          <a:p>
-            <a:r>
-              <a:t>M Предсезонная готовность и ожидание погодного окна: предшественники J, ES 23, EF 31, LS 23, LF 31, резерв 0</a:t>
-            </a:r>
-          </a:p>
-          <a:p>
-            <a:r>
-              <a:t>K Первый коммерческий сезон: предшественники M, ES 31, EF 53, LS 31, LF 53, резерв 0</a:t>
-            </a:r>
-          </a:p>
-          <a:p>
-            <a:r>
-              <a:t>L Аудит сезона и решение о продолжении: предшественники K, ES 53, EF 55, LS 53, LF 55, резерв 0</a:t>
+              <a:t>A Проверка региона, полетов и схемы АХР: предшественники нет, ES 0, EF 2, LS 1, LF 3, резерв 1</a:t>
+            </a:r>
+          </a:p>
+          <a:p>
+            <a:r>
+              <a:t>B Интервью и предварительные заявки хозяйств: предшественники нет, ES 0, EF 6, LS 0, LF 6, резерв 0</a:t>
+            </a:r>
+          </a:p>
+          <a:p>
+            <a:r>
+              <a:t>C ООО, договоры, учет и страховой проект: предшественники A, ES 2, EF 5, LS 3, LF 6, резерв 1</a:t>
+            </a:r>
+          </a:p>
+          <a:p>
+            <a:r>
+              <a:t>D Инвестиционное решение и финансирование: предшественники B;C, ES 6, EF 7, LS 6, LF 7, резерв 0</a:t>
+            </a:r>
+          </a:p>
+          <a:p>
+            <a:r>
+              <a:t>E Закупка и приемка оборудования: предшественники D, ES 7, EF 12, LS 7, LF 12, резерв 0</a:t>
+            </a:r>
+          </a:p>
+          <a:p>
+            <a:r>
+              <a:t>F Подбор и гражданская переподготовка: предшественники D, ES 7, EF 13, LS 9, LF 15, резерв 2</a:t>
+            </a:r>
+          </a:p>
+          <a:p>
+            <a:r>
+              <a:t>G Разрешительная готовность и учет БВС: предшественники E, ES 12, EF 18, LS 12, LF 18, резерв 0</a:t>
+            </a:r>
+          </a:p>
+          <a:p>
+            <a:r>
+              <a:t>H SOP, CRM, карты и контроль качества: предшественники E;F, ES 13, EF 16, LS 15, LF 18, резерв 2</a:t>
+            </a:r>
+          </a:p>
+          <a:p>
+            <a:r>
+              <a:t>I Стендовые и контролируемые приемочные испытания: предшественники G;H, ES 18, EF 20, LS 18, LF 20, резерв 0</a:t>
+            </a:r>
+          </a:p>
+          <a:p>
+            <a:r>
+              <a:t>J Сезонные договоры и маршрутизация: предшественники I, ES 20, EF 22, LS 20, LF 22, резерв 0</a:t>
+            </a:r>
+          </a:p>
+          <a:p>
+            <a:r>
+              <a:t>M Предсезонная готовность и ожидание погодного окна: предшественники J, ES 22, EF 25, LS 22, LF 25, резерв 0</a:t>
+            </a:r>
+          </a:p>
+          <a:p>
+            <a:r>
+              <a:t>K Первый коммерческий сезон: предшественники M, ES 25, EF 47, LS 25, LF 47, резерв 0</a:t>
+            </a:r>
+          </a:p>
+          <a:p>
+            <a:r>
+              <a:t>L Аудит сезона и решение о продолжении: предшественники K, ES 47, EF 49, LS 47, LF 49, резерв 0</a:t>
             </a:r>
           </a:p>
         </p:txBody>
@@ -3197,17 +3197,17 @@
           </a:p>
           <a:p>
             <a:r>
-              <a:t>| Правовая применимость | Карта требований по всем выбранным полям; решение GO/NO-GO | 31.10.2026 | Директор; письменное заключение юриста |</a:t>
-            </a:r>
-          </a:p>
-          <a:p>
-            <a:r>
-              <a:t>| Подтверждение спроса | 20 интервью; заявки на 6 000 га-проходов и 4 000 га-обследований | 30.11.2026 | Директор; реестр полей и заявок, без объявления их продажами |</a:t>
-            </a:r>
-          </a:p>
-          <a:p>
-            <a:r>
-              <a:t>| Коммерческий портфель | 10 клиентов; суммарно 6 000 га-проходов и 4 000 га-обследований | 11.04.2027 | Директор; подписанные договоры и календарь |</a:t>
+              <a:t>| Правовая применимость | Карта требований по всем выбранным полям; решение GO/NO-GO | 01.11.2026 | Директор; письменное заключение юриста |</a:t>
+            </a:r>
+          </a:p>
+          <a:p>
+            <a:r>
+              <a:t>| Подтверждение спроса | 20 интервью; заявки на 6 000 га-проходов и 4 000 га-обследований | 29.11.2026 | Директор; реестр полей и заявок, без объявления их продажами |</a:t>
+            </a:r>
+          </a:p>
+          <a:p>
+            <a:r>
+              <a:t>| Коммерческий портфель | 10 клиентов; суммарно 6 000 га-проходов и 4 000 га-обследований | 21.03.2027 | Директор; подписанные договоры и календарь |</a:t>
             </a:r>
           </a:p>
           <a:p>
@@ -3347,12 +3347,18 @@
           <a:p/>
           <a:p>
             <a:r>
+              <a:t>[ДОПУЩЕНИЕ] Источники 2,5 + 7,0 млн руб. покрывают только базовые 9,5 млн. При закупочном стрессе 11,48 млн дефицит составляет 1,98 млн руб. Если вклад учредителя неизменен, внешнее финансирование требуется 8,98 млн вместо 7 млн. Дополнительные деньги не подтверждены; до согласования новых условий закупка не проводится. Увеличение суммы вклада не устанавливает автоматически долю инвестора.</a:t>
+            </a:r>
+          </a:p>
+          <a:p/>
+          <a:p>
+            <a:r>
               <a:t>Комментарий к слайду:</a:t>
             </a:r>
           </a:p>
           <a:p>
             <a:r>
-              <a:t>Редактируемые объекты. Финансовые показатели — расчет модели, входные данные — допущения; проект не является действующим подтвержденным бизнесом.</a:t>
+              <a:t>2,5 + 7,0 млн покрывают только базовые 9,5 млн. При закупочном стрессе нужно еще 1,98 млн; при неизменном вкладе учредителя внешний вклад 8,98 млн. Дополнительное финансирование не подтверждено. Без нового решения закупка не проводится.</a:t>
             </a:r>
           </a:p>
         </p:txBody>
@@ -3857,71 +3863,18 @@
           <a:p/>
           <a:p>
             <a:r>
-              <a:t>### Сравнение с конкретными конкурентами</a:t>
+              <a:t>### Стратегическая канва по факторам выбора клиента</a:t>
             </a:r>
           </a:p>
           <a:p/>
           <a:p>
             <a:r>
-              <a:t>Дата проверки открытых предложений: 06.10.2026. АгроВектор находится до запуска. Сравнение отражает наличие предложения, а не доказанное превосходство по качеству. Агропрофи — региональный конкурент; Агродроны ЮФО и Гермес — межрегиональные ориентиры, работа в Татарстане ими здесь не подтверждается.</a:t>
+              <a:t>Качественная канва сопоставляет цену, состав пакета, территорию, минимальный объем и срок отчета. Для несопоставимых и нераскрытых параметров числовые баллы не назначаются. Целевой профиль проекта не является достигнутым результатом.</a:t>
             </a:r>
           </a:p>
           <a:p/>
           <a:p>
             <a:r>
-              <a:t>| Фактор ценности | АгроВектор | ГК Агропрофи / XAG | Агродроны ЮФО | Гермес |</a:t>
-            </a:r>
-          </a:p>
-          <a:p>
-            <a:r>
-              <a:t>|---|---|---|---|---|</a:t>
-            </a:r>
-          </a:p>
-          <a:p>
-            <a:r>
-              <a:t>| Услуга внесения | Запланирована | Предлагается [3][4] | Предлагается [7] | Предлагается [6] |</a:t>
-            </a:r>
-          </a:p>
-          <a:p>
-            <a:r>
-              <a:t>| Мониторинг и картирование | Запланированы | Средства мониторинга заявлены; состав услуги уточняется [3] | Отдельная услуга не подтверждена | Мониторинг и карты заявлены [6] |</a:t>
-            </a:r>
-          </a:p>
-          <a:p>
-            <a:r>
-              <a:t>| Обслуживание Татарстана | План после проверки участков | Татарстан заявлен [3] | Заявлен ЮФО [7] | Краснодарский край и Адыгея [6] |</a:t>
-            </a:r>
-          </a:p>
-          <a:p>
-            <a:r>
-              <a:t>| Публичный тариф внесения | 1300 руб./га-проход, план | По запросу | В среднем 900 руб./га [7] | По запросу |</a:t>
-            </a:r>
-          </a:p>
-          <a:p>
-            <a:r>
-              <a:t>| Отчетность заказчику | Отчет за 48 часов, цель | Состав отчета уточняется | Акты и закрывающие документы заявлены [7] | Состав отчета уточняется |</a:t>
-            </a:r>
-          </a:p>
-          <a:p>
-            <a:r>
-              <a:t>| Опыт исполнения | Коммерческий сезон еще не проведен | Более 50 тыс. га суммарно, заявление без периода [3] | Собственный парк заявлен [7] | Полевые кейсы опубликованы [6] |</a:t>
-            </a:r>
-          </a:p>
-          <a:p/>
-          <a:p>
-            <a:r>
-              <a:t>### Стратегическая канва по факторам выбора клиента</a:t>
-            </a:r>
-          </a:p>
-          <a:p/>
-          <a:p>
-            <a:r>
-              <a:t>Качественная канва сопоставляет цену, состав пакета, территорию, минимальный объем и срок отчета. Для несопоставимых и нераскрытых параметров числовые баллы не назначаются. Целевой профиль проекта не является достигнутым результатом.</a:t>
-            </a:r>
-          </a:p>
-          <a:p/>
-          <a:p>
-            <a:r>
               <a:t>| Фактор выбора клиента | АгроВектор: цель | Агропрофи / XAG | Агродроны ЮФО | Гермес |</a:t>
             </a:r>
           </a:p>
@@ -3932,6 +3885,11 @@
           </a:p>
           <a:p>
             <a:r>
+              <a:t>| Внесение как услуга | Планируется | Предлагается [3][4] | Предлагается [7] | Предлагается [6] |</a:t>
+            </a:r>
+          </a:p>
+          <a:p>
+            <a:r>
               <a:t>| Цена внесения, руб./га | 1 300 без НДС | По запросу | 900, средняя; состав уточняется | По запросу |</a:t>
             </a:r>
           </a:p>
@@ -3953,6 +3911,11 @@
           <a:p>
             <a:r>
               <a:t>| Срок отчета | Не более 48 часов, цель | Не раскрыт | Акты заявлены; срок не раскрыт | Не раскрыт |</a:t>
+            </a:r>
+          </a:p>
+          <a:p>
+            <a:r>
+              <a:t>| Опыт исполнения | Сезон не проведен | 50 тыс. га суммарно [3] | Парк заявлен [7] | Кейсы опубликованы [6] |</a:t>
             </a:r>
           </a:p>
           <a:p/>
@@ -4270,12 +4233,24 @@
           <a:p/>
           <a:p>
             <a:r>
-              <a:t>Микс SOM отличается от среднего микса TAM/SAM: 0,667 обследования на проход против 0,333. Это возможно как отдельный спрос на мониторинг, но должно подтверждаться заявками. Если сохранить средний микс SAM, мониторинг при 6000 проходах составит 2000 обследований, SOM — 8,3 млн руб., доля — 6,67%. Финансовая база 8,8 млн сохранена как проверяемая цель, а не исправлена без подтверждения портфеля.</a:t>
+              <a:t>Основной SOM: 6 000 га-проходов и 4 000 га-обследований. Отношение обследований к проходам 0,667 против 0,333 в SAM. Дополнительный спрос на мониторинг подтверждается отдельно; поэтому денежная доля 7,07% не равна доле по внесению 6,67%.</a:t>
             </a:r>
           </a:p>
           <a:p/>
           <a:p>
             <a:r>
+              <a:t>### Альтернативный микс — не базовая выручка</a:t>
+            </a:r>
+          </a:p>
+          <a:p/>
+          <a:p>
+            <a:r>
+              <a:t>При среднем миксе SAM мониторинг составил бы 2 000 обследований, выручка — 8,3 млн руб., денежная доля — 6,67%. Это отдельный тест гипотезы, не замена 8,8 млн в финансовой базе. Снижение мониторинга на 2 000 обследований уменьшает денежный вклад 2027 после УСН на 350 000 руб. при неизменных фиксированных расходах.</a:t>
+            </a:r>
+          </a:p>
+          <a:p/>
+          <a:p>
+            <a:r>
               <a:t>[РАСЧЕТ] Ограничение мощности: 6000 / 130 + 4000 / 500 = 54,15 полевых дня при плановых производительностях проекта. Это ниже потолка 120 дней, однако пики агрономических окон, погода, транспорт и отдых могут ограничить загрузку. SOM проверяется одновременно по договорам, кадрам и календарю. Резервный борт не создает вторую бригаду.</a:t>
             </a:r>
           </a:p>
@@ -4375,6 +4350,12 @@
           <a:p>
             <a:r>
               <a:t>[РАСЧЕТ] Внутри оценки РСХБ прогнозный рост 2026 к 2025 составляет 35,47% (1058/781−1), но этот темп не переносится на финансовую модель АгроВектора: ее выручку определяют собственные гектары, тариф и мощность. Плановый средний CAC 24000 руб. и выручка 880000 руб. на клиента рассчитаны как 240000/10 и 8800000/10 соответственно.</a:t>
+            </a:r>
+          </a:p>
+          <a:p/>
+          <a:p>
+            <a:r>
+              <a:t>[ДОПУЩЕНИЕ] Основная база — 6 000 га-проходов и 4 000 га-обследований, 8,8 млн руб. Альтернативные 8,3 млн — только тест среднего микса SAM, а не исправленная выручка базы. Требуются отдельные заявки на мониторинг; его спрос нельзя выводить из числа проходов внесения.</a:t>
             </a:r>
           </a:p>
           <a:p/>
@@ -4471,13 +4452,13 @@
           <a:lstStyle/>
           <a:p>
             <a:r>
-              <a:t>[ФАКТ] Сопоставлены публичные предложения пяти сервисов. Дата проверки 05.09.2026; сведения — заявления самих поставщиков, не подтверждение действующих допусков, выручки или качества. Н/д означает отсутствие подтвержденной цифры, а не нулевую цену или долю.</a:t>
+              <a:t>[ФАКТ] Сопоставлены публичные предложения пяти сервисов. Основной снимок 05.09.2026; уточнения по Агропрофи, ЮФО и Гермесу 06.10.2026; сведения — заявления самих поставщиков, не подтверждение действующих допусков, выручки или качества. Н/д означает отсутствие подтвержденной цифры, а не нулевую цену или долю.</a:t>
             </a:r>
           </a:p>
           <a:p/>
           <a:p>
             <a:r>
-              <a:t>| Компания | География и услуга | Цена,руб./га | Доля рынка,% | Источник |</a:t>
+              <a:t>| Компания | География и услуга | Цена, руб./га | Доля услуг кластера | Источник |</a:t>
             </a:r>
           </a:p>
           <a:p>
@@ -4487,27 +4468,32 @@
           </a:p>
           <a:p>
             <a:r>
-              <a:t>| BeeAir / BeeUAV | Татарстан заявлен на сайте; контактный адрес МО; обработка; мониторинг; аренда | Н/д; по запросу | Н/д | [1][2] |</a:t>
-            </a:r>
-          </a:p>
-          <a:p>
-            <a:r>
-              <a:t>| ГК Агропрофи / XAG | Поволжье включая Татарстан; обработка; посев; продажа техники | Н/д; по запросу | Н/д | [3][4] |</a:t>
-            </a:r>
-          </a:p>
-          <a:p>
-            <a:r>
-              <a:t>| Аграс / аграс.рф | Челябинская область и Урал по материалам сайта; аренда пилота/техники; демонстрация | Н/д; по запросу | Н/д | [5] |</a:t>
-            </a:r>
-          </a:p>
-          <a:p>
-            <a:r>
-              <a:t>| Гермес | Краснодарский край и Адыгея; виноградники; удобрения; мониторинг | Н/д; по запросу | Н/д | [6] |</a:t>
-            </a:r>
-          </a:p>
-          <a:p>
-            <a:r>
-              <a:t>| Агродроны ЮФО | ЮФО; контакт в Элисте; обработка полей; внесение; посев | 900 | Н/д | [7] |</a:t>
+              <a:t>| BeeAir / BeeUAV | Татарстан заявлен; адрес МО; обработка, мониторинг, аренда | По запросу | Не установлена | [1][2] |</a:t>
+            </a:r>
+          </a:p>
+          <a:p>
+            <a:r>
+              <a:t>| Агропрофи / XAG | Поволжье, Татарстан; обработка и посев | По запросу | Не установлена | [3][4] |</a:t>
+            </a:r>
+          </a:p>
+          <a:p>
+            <a:r>
+              <a:t>| Аграс | Урал; аренда техники и пилота | По запросу | Не установлена | [5] |</a:t>
+            </a:r>
+          </a:p>
+          <a:p>
+            <a:r>
+              <a:t>| Гермес | Краснодар / Адыгея; внесение и мониторинг | По запросу | Не установлена | [6] |</a:t>
+            </a:r>
+          </a:p>
+          <a:p>
+            <a:r>
+              <a:t>| Агродроны ЮФО | ЮФО; обработка и посев | 900, средняя; НДС не раскрыт | Не установлена | [7] |</a:t>
+            </a:r>
+          </a:p>
+          <a:p>
+            <a:r>
+              <a:t>| АгроВектор [ДОПУЩЕНИЕ] | Татарстан до 150 км; внесение и мониторинг | 1 300 без НДС, план | Продажи не подтверждены; 7,07% — целевой SOM/SAM | Раздел 5 |</a:t>
             </a:r>
           </a:p>
           <a:p/>
@@ -4535,73 +4521,22 @@
             </a:r>
           </a:p>
           <a:p/>
-          <a:p>
-            <a:r>
-              <a:t>### Доли конкретных конкурентов</a:t>
-            </a:r>
-          </a:p>
           <a:p/>
-          <a:p>
-            <a:r>
-              <a:t>Доля по выручке = выручка компании от сопоставимых услуг в территории и году / суммарная выручка всех исполнителей тех же услуг в той же территории и году × 100%. Альтернатива — доля по оплачиваемым га-проходам; смешивать эти показатели нельзя. Для сопоставления с AgroVector нужен рынок услуг кластера Татарстана за один сезон, а не продажи оборудования или мировая доля марки XAG/DJI.</a:t>
-            </a:r>
-          </a:p>
           <a:p/>
           <a:p>
             <a:r>
-              <a:t>| Компания | Доля услуг кластера Татарстана, % | Доступное основание | Что требуется для расчета |</a:t>
-            </a:r>
-          </a:p>
-          <a:p>
-            <a:r>
-              <a:t>|---|---|---|---|</a:t>
-            </a:r>
-          </a:p>
-          <a:p>
-            <a:r>
-              <a:t>| ГК Агропрофи | Не установлена | 50 тыс.+ га суммарно; период и доля Татарстана не раскрыты | Годовой объем или выручка услуг в кластере и итог рынка |</a:t>
-            </a:r>
-          </a:p>
-          <a:p>
-            <a:r>
-              <a:t>| BeeAir / BeeUAV | Не установлена | В прежнем реестре заявлен Татарстан; сайт повторно недоступен 06.10.2026 | Подтверждение покрытия, годовые продажи и итог рынка |</a:t>
-            </a:r>
-          </a:p>
-          <a:p>
-            <a:r>
-              <a:t>| Агродроны ЮФО | Не установлена | Предложение относится к ЮФО; не подтверждено присутствие в кластере | Покрытие кластера и сопоставимая статистика |</a:t>
-            </a:r>
-          </a:p>
-          <a:p>
-            <a:r>
-              <a:t>| Гермес | Не установлена | Предложение относится к Краснодарскому краю и Адыгее | Покрытие кластера и сопоставимая статистика |</a:t>
-            </a:r>
-          </a:p>
-          <a:p>
-            <a:r>
-              <a:t>| Аграс | Не установлена | Межрегиональный ориентир из предыдущего реестра | Покрытие кластера и сопоставимая статистика |</a:t>
-            </a:r>
-          </a:p>
-          <a:p>
-            <a:r>
-              <a:t>| АгроВектор | Продажи проекта не подтверждены | 7,07% — цель от сценарного SAM, не фактическая доля | Фактические акты и подтвержденный знаменатель рынка |</a:t>
+              <a:t>Доля конкурента требует выручки или оплаченных га-проходов за тот же год и территорию и соответствующего знаменателя. Накопленные 50 тыс. га Агропрофи не являются годовой долей. Сведения [1][2][5] — снимок 05.09.2026; по [3][4][6][7] выполнена дополнительная проверка 06.10.2026. Редакция текста не означает обновление всех источников.</a:t>
             </a:r>
           </a:p>
           <a:p/>
           <a:p>
             <a:r>
-              <a:t>[ФАКТ] При проверке 06.10.2026 Агропрофи публикует более 50 тыс. обработанных гектаров без годового периода. Нельзя делить этот накопленный показатель на годовую площадь РФ, на сценарные 90000 га-проходов SAM или на 60000 га земли: полученные проценты не являются рыночной долей. Ни один сопоставимый процент по именованным конкурентам в проверенных источниках не подтвержден. Числовая доля требует данных исполнителей или исследования рынка с раскрытой методикой.</a:t>
-            </a:r>
-          </a:p>
-          <a:p/>
-          <a:p>
-            <a:r>
               <a:t>Комментарий к слайду:</a:t>
             </a:r>
           </a:p>
           <a:p>
             <a:r>
-              <a:t>Агродроны ЮФО: «Стоимость зависит от вида обработки и объёма участка. В среднем 900 рублей за гектар. Итоговая цена рассчитывается индивидуально». Состав, НДС, логистика и препараты требуют запроса КП. Доли всех участников неизвестны. BeeUAV рекламирует Татарстан; адрес на сайте — Московская область, локальное присутствие требует проверки. Канва слайда 3 не является оценкой перечисленных компаний.</a:t>
+              <a:t>Агродроны ЮФО: «Стоимость зависит от вида обработки и объёма участка. В среднем 900 рублей за гектар. Итоговая цена рассчитывается индивидуально». Состав, НДС, логистика и препараты требуют запроса КП. Доли всех участников неизвестны. BeeUAV рекламирует Татарстан; адрес на сайте — Московская область, локальное присутствие требует проверки. Слайд 3 сравнивает публичные предложения этих компаний с целевым профилем проекта; это не рейтинг качества.</a:t>
             </a:r>
           </a:p>
           <a:p/>
@@ -13472,7 +13407,7 @@
         </p:nvSpPr>
         <p:spPr>
           <a:xfrm>
-            <a:off x="4453959" y="1965960"/>
+            <a:off x="4536916" y="1965960"/>
             <a:ext cx="7315" cy="3630168"/>
           </a:xfrm>
           <a:prstGeom prst="rect">
@@ -13515,7 +13450,7 @@
         </p:nvSpPr>
         <p:spPr>
           <a:xfrm>
-            <a:off x="4316799" y="1746504"/>
+            <a:off x="4399756" y="1746504"/>
             <a:ext cx="365760" cy="228600"/>
           </a:xfrm>
           <a:prstGeom prst="rect">
@@ -13557,7 +13492,7 @@
         </p:nvSpPr>
         <p:spPr>
           <a:xfrm>
-            <a:off x="5131446" y="1965960"/>
+            <a:off x="5297361" y="1965960"/>
             <a:ext cx="7315" cy="3630168"/>
           </a:xfrm>
           <a:prstGeom prst="rect">
@@ -13600,7 +13535,7 @@
         </p:nvSpPr>
         <p:spPr>
           <a:xfrm>
-            <a:off x="4994286" y="1746504"/>
+            <a:off x="5160201" y="1746504"/>
             <a:ext cx="365760" cy="228600"/>
           </a:xfrm>
           <a:prstGeom prst="rect">
@@ -13642,7 +13577,7 @@
         </p:nvSpPr>
         <p:spPr>
           <a:xfrm>
-            <a:off x="5808933" y="1965960"/>
+            <a:off x="6057806" y="1965960"/>
             <a:ext cx="7315" cy="3630168"/>
           </a:xfrm>
           <a:prstGeom prst="rect">
@@ -13685,7 +13620,7 @@
         </p:nvSpPr>
         <p:spPr>
           <a:xfrm>
-            <a:off x="5671773" y="1746504"/>
+            <a:off x="5920646" y="1746504"/>
             <a:ext cx="365760" cy="228600"/>
           </a:xfrm>
           <a:prstGeom prst="rect">
@@ -13727,7 +13662,7 @@
         </p:nvSpPr>
         <p:spPr>
           <a:xfrm>
-            <a:off x="6486421" y="1965960"/>
+            <a:off x="6818251" y="1965960"/>
             <a:ext cx="7315" cy="3630168"/>
           </a:xfrm>
           <a:prstGeom prst="rect">
@@ -13770,7 +13705,7 @@
         </p:nvSpPr>
         <p:spPr>
           <a:xfrm>
-            <a:off x="6349261" y="1746504"/>
+            <a:off x="6681091" y="1746504"/>
             <a:ext cx="365760" cy="228600"/>
           </a:xfrm>
           <a:prstGeom prst="rect">
@@ -13812,7 +13747,7 @@
         </p:nvSpPr>
         <p:spPr>
           <a:xfrm>
-            <a:off x="7163908" y="1965960"/>
+            <a:off x="7578696" y="1965960"/>
             <a:ext cx="7315" cy="3630168"/>
           </a:xfrm>
           <a:prstGeom prst="rect">
@@ -13855,7 +13790,7 @@
         </p:nvSpPr>
         <p:spPr>
           <a:xfrm>
-            <a:off x="7026748" y="1746504"/>
+            <a:off x="7441536" y="1746504"/>
             <a:ext cx="365760" cy="228600"/>
           </a:xfrm>
           <a:prstGeom prst="rect">
@@ -13897,7 +13832,7 @@
         </p:nvSpPr>
         <p:spPr>
           <a:xfrm>
-            <a:off x="7841395" y="1965960"/>
+            <a:off x="8339141" y="1965960"/>
             <a:ext cx="7315" cy="3630168"/>
           </a:xfrm>
           <a:prstGeom prst="rect">
@@ -13940,7 +13875,7 @@
         </p:nvSpPr>
         <p:spPr>
           <a:xfrm>
-            <a:off x="7704235" y="1746504"/>
+            <a:off x="8201981" y="1746504"/>
             <a:ext cx="365760" cy="228600"/>
           </a:xfrm>
           <a:prstGeom prst="rect">
@@ -13982,7 +13917,7 @@
         </p:nvSpPr>
         <p:spPr>
           <a:xfrm>
-            <a:off x="8518882" y="1965960"/>
+            <a:off x="9099586" y="1965960"/>
             <a:ext cx="7315" cy="3630168"/>
           </a:xfrm>
           <a:prstGeom prst="rect">
@@ -14025,7 +13960,7 @@
         </p:nvSpPr>
         <p:spPr>
           <a:xfrm>
-            <a:off x="8381722" y="1746504"/>
+            <a:off x="8962426" y="1746504"/>
             <a:ext cx="365760" cy="228600"/>
           </a:xfrm>
           <a:prstGeom prst="rect">
@@ -14067,7 +14002,7 @@
         </p:nvSpPr>
         <p:spPr>
           <a:xfrm>
-            <a:off x="9196370" y="1965960"/>
+            <a:off x="9860031" y="1965960"/>
             <a:ext cx="7315" cy="3630168"/>
           </a:xfrm>
           <a:prstGeom prst="rect">
@@ -14110,7 +14045,7 @@
         </p:nvSpPr>
         <p:spPr>
           <a:xfrm>
-            <a:off x="9059210" y="1746504"/>
+            <a:off x="9722871" y="1746504"/>
             <a:ext cx="365760" cy="228600"/>
           </a:xfrm>
           <a:prstGeom prst="rect">
@@ -14152,7 +14087,7 @@
         </p:nvSpPr>
         <p:spPr>
           <a:xfrm>
-            <a:off x="9873857" y="1965960"/>
+            <a:off x="10620476" y="1965960"/>
             <a:ext cx="7315" cy="3630168"/>
           </a:xfrm>
           <a:prstGeom prst="rect">
@@ -14195,7 +14130,7 @@
         </p:nvSpPr>
         <p:spPr>
           <a:xfrm>
-            <a:off x="9736697" y="1746504"/>
+            <a:off x="10483316" y="1746504"/>
             <a:ext cx="365760" cy="228600"/>
           </a:xfrm>
           <a:prstGeom prst="rect">
@@ -14231,20 +14166,64 @@
       </p:sp>
       <p:sp>
         <p:nvSpPr>
-          <p:cNvPr id="28" name="Rectangle 27"/>
-          <p:cNvSpPr/>
-          <p:nvPr/>
-        </p:nvSpPr>
-        <p:spPr>
-          <a:xfrm>
-            <a:off x="10551344" y="1965960"/>
-            <a:ext cx="7315" cy="3630168"/>
+          <p:cNvPr id="28" name="TextBox 27"/>
+          <p:cNvSpPr txBox="1"/>
+          <p:nvPr/>
+        </p:nvSpPr>
+        <p:spPr>
+          <a:xfrm>
+            <a:off x="640080" y="1965960"/>
+            <a:ext cx="3017520" cy="265176"/>
           </a:xfrm>
           <a:prstGeom prst="rect">
             <a:avLst/>
           </a:prstGeom>
+          <a:noFill/>
+        </p:spPr>
+        <p:txBody>
+          <a:bodyPr wrap="square" lIns="13716" rIns="13716" tIns="0" bIns="0">
+            <a:spAutoFit/>
+          </a:bodyPr>
+          <a:lstStyle/>
+          <a:p>
+            <a:pPr>
+              <a:spcBef>
+                <a:spcPts val="0"/>
+              </a:spcBef>
+              <a:spcAft>
+                <a:spcPts val="500"/>
+              </a:spcAft>
+              <a:defRPr sz="1500" b="0">
+                <a:solidFill>
+                  <a:srgbClr val="092A20"/>
+                </a:solidFill>
+                <a:latin typeface="Arial"/>
+              </a:defRPr>
+            </a:pPr>
+            <a:r>
+              <a:t>A  Правовой gate</a:t>
+            </a:r>
+          </a:p>
+        </p:txBody>
+      </p:sp>
+      <p:sp>
+        <p:nvSpPr>
+          <p:cNvPr id="29" name="Rounded Rectangle 28"/>
+          <p:cNvSpPr/>
+          <p:nvPr/>
+        </p:nvSpPr>
+        <p:spPr>
+          <a:xfrm>
+            <a:off x="3776472" y="2007107"/>
+            <a:ext cx="304177" cy="164592"/>
+          </a:xfrm>
+          <a:prstGeom prst="roundRect">
+            <a:avLst>
+              <a:gd name="adj" fmla="val 8000"/>
+            </a:avLst>
+          </a:prstGeom>
           <a:solidFill>
-            <a:srgbClr val="EFF4EF"/>
+            <a:srgbClr val="91B663"/>
           </a:solidFill>
           <a:ln>
             <a:noFill/>
@@ -14274,14 +14253,1058 @@
       </p:sp>
       <p:sp>
         <p:nvSpPr>
-          <p:cNvPr id="29" name="TextBox 28"/>
+          <p:cNvPr id="30" name="TextBox 29"/>
           <p:cNvSpPr txBox="1"/>
           <p:nvPr/>
         </p:nvSpPr>
         <p:spPr>
           <a:xfrm>
-            <a:off x="10414184" y="1746504"/>
-            <a:ext cx="365760" cy="228600"/>
+            <a:off x="640080" y="2231136"/>
+            <a:ext cx="3017520" cy="265176"/>
+          </a:xfrm>
+          <a:prstGeom prst="rect">
+            <a:avLst/>
+          </a:prstGeom>
+          <a:noFill/>
+        </p:spPr>
+        <p:txBody>
+          <a:bodyPr wrap="square" lIns="13716" rIns="13716" tIns="0" bIns="0">
+            <a:spAutoFit/>
+          </a:bodyPr>
+          <a:lstStyle/>
+          <a:p>
+            <a:pPr>
+              <a:spcBef>
+                <a:spcPts val="0"/>
+              </a:spcBef>
+              <a:spcAft>
+                <a:spcPts val="500"/>
+              </a:spcAft>
+              <a:defRPr sz="1500" b="0">
+                <a:solidFill>
+                  <a:srgbClr val="092A20"/>
+                </a:solidFill>
+                <a:latin typeface="Arial"/>
+              </a:defRPr>
+            </a:pPr>
+            <a:r>
+              <a:t>B  Спрос / заявки</a:t>
+            </a:r>
+          </a:p>
+        </p:txBody>
+      </p:sp>
+      <p:sp>
+        <p:nvSpPr>
+          <p:cNvPr id="31" name="Rounded Rectangle 30"/>
+          <p:cNvSpPr/>
+          <p:nvPr/>
+        </p:nvSpPr>
+        <p:spPr>
+          <a:xfrm>
+            <a:off x="3776472" y="2272284"/>
+            <a:ext cx="912533" cy="164592"/>
+          </a:xfrm>
+          <a:prstGeom prst="roundRect">
+            <a:avLst>
+              <a:gd name="adj" fmla="val 8000"/>
+            </a:avLst>
+          </a:prstGeom>
+          <a:solidFill>
+            <a:srgbClr val="164C38"/>
+          </a:solidFill>
+          <a:ln>
+            <a:noFill/>
+          </a:ln>
+        </p:spPr>
+        <p:style>
+          <a:lnRef idx="1">
+            <a:schemeClr val="accent1"/>
+          </a:lnRef>
+          <a:fillRef idx="3">
+            <a:schemeClr val="accent1"/>
+          </a:fillRef>
+          <a:effectRef idx="2">
+            <a:schemeClr val="accent1"/>
+          </a:effectRef>
+          <a:fontRef idx="minor">
+            <a:schemeClr val="lt1"/>
+          </a:fontRef>
+        </p:style>
+        <p:txBody>
+          <a:bodyPr rtlCol="0" anchor="ctr"/>
+          <a:lstStyle/>
+          <a:p>
+            <a:pPr algn="ctr"/>
+          </a:p>
+        </p:txBody>
+      </p:sp>
+      <p:sp>
+        <p:nvSpPr>
+          <p:cNvPr id="32" name="TextBox 31"/>
+          <p:cNvSpPr txBox="1"/>
+          <p:nvPr/>
+        </p:nvSpPr>
+        <p:spPr>
+          <a:xfrm>
+            <a:off x="640080" y="2496312"/>
+            <a:ext cx="3017520" cy="265176"/>
+          </a:xfrm>
+          <a:prstGeom prst="rect">
+            <a:avLst/>
+          </a:prstGeom>
+          <a:noFill/>
+        </p:spPr>
+        <p:txBody>
+          <a:bodyPr wrap="square" lIns="13716" rIns="13716" tIns="0" bIns="0">
+            <a:spAutoFit/>
+          </a:bodyPr>
+          <a:lstStyle/>
+          <a:p>
+            <a:pPr>
+              <a:spcBef>
+                <a:spcPts val="0"/>
+              </a:spcBef>
+              <a:spcAft>
+                <a:spcPts val="500"/>
+              </a:spcAft>
+              <a:defRPr sz="1500" b="0">
+                <a:solidFill>
+                  <a:srgbClr val="092A20"/>
+                </a:solidFill>
+                <a:latin typeface="Arial"/>
+              </a:defRPr>
+            </a:pPr>
+            <a:r>
+              <a:t>C  ООО и договоры</a:t>
+            </a:r>
+          </a:p>
+        </p:txBody>
+      </p:sp>
+      <p:sp>
+        <p:nvSpPr>
+          <p:cNvPr id="33" name="Rounded Rectangle 32"/>
+          <p:cNvSpPr/>
+          <p:nvPr/>
+        </p:nvSpPr>
+        <p:spPr>
+          <a:xfrm>
+            <a:off x="4080649" y="2537460"/>
+            <a:ext cx="456266" cy="164592"/>
+          </a:xfrm>
+          <a:prstGeom prst="roundRect">
+            <a:avLst>
+              <a:gd name="adj" fmla="val 8000"/>
+            </a:avLst>
+          </a:prstGeom>
+          <a:solidFill>
+            <a:srgbClr val="91B663"/>
+          </a:solidFill>
+          <a:ln>
+            <a:noFill/>
+          </a:ln>
+        </p:spPr>
+        <p:style>
+          <a:lnRef idx="1">
+            <a:schemeClr val="accent1"/>
+          </a:lnRef>
+          <a:fillRef idx="3">
+            <a:schemeClr val="accent1"/>
+          </a:fillRef>
+          <a:effectRef idx="2">
+            <a:schemeClr val="accent1"/>
+          </a:effectRef>
+          <a:fontRef idx="minor">
+            <a:schemeClr val="lt1"/>
+          </a:fontRef>
+        </p:style>
+        <p:txBody>
+          <a:bodyPr rtlCol="0" anchor="ctr"/>
+          <a:lstStyle/>
+          <a:p>
+            <a:pPr algn="ctr"/>
+          </a:p>
+        </p:txBody>
+      </p:sp>
+      <p:sp>
+        <p:nvSpPr>
+          <p:cNvPr id="34" name="TextBox 33"/>
+          <p:cNvSpPr txBox="1"/>
+          <p:nvPr/>
+        </p:nvSpPr>
+        <p:spPr>
+          <a:xfrm>
+            <a:off x="640080" y="2761487"/>
+            <a:ext cx="3017520" cy="265176"/>
+          </a:xfrm>
+          <a:prstGeom prst="rect">
+            <a:avLst/>
+          </a:prstGeom>
+          <a:noFill/>
+        </p:spPr>
+        <p:txBody>
+          <a:bodyPr wrap="square" lIns="13716" rIns="13716" tIns="0" bIns="0">
+            <a:spAutoFit/>
+          </a:bodyPr>
+          <a:lstStyle/>
+          <a:p>
+            <a:pPr>
+              <a:spcBef>
+                <a:spcPts val="0"/>
+              </a:spcBef>
+              <a:spcAft>
+                <a:spcPts val="500"/>
+              </a:spcAft>
+              <a:defRPr sz="1500" b="0">
+                <a:solidFill>
+                  <a:srgbClr val="092A20"/>
+                </a:solidFill>
+                <a:latin typeface="Arial"/>
+              </a:defRPr>
+            </a:pPr>
+            <a:r>
+              <a:t>D  Финансирование</a:t>
+            </a:r>
+          </a:p>
+        </p:txBody>
+      </p:sp>
+      <p:sp>
+        <p:nvSpPr>
+          <p:cNvPr id="35" name="Rounded Rectangle 34"/>
+          <p:cNvSpPr/>
+          <p:nvPr/>
+        </p:nvSpPr>
+        <p:spPr>
+          <a:xfrm>
+            <a:off x="4689005" y="2802635"/>
+            <a:ext cx="152088" cy="164592"/>
+          </a:xfrm>
+          <a:prstGeom prst="roundRect">
+            <a:avLst>
+              <a:gd name="adj" fmla="val 8000"/>
+            </a:avLst>
+          </a:prstGeom>
+          <a:solidFill>
+            <a:srgbClr val="164C38"/>
+          </a:solidFill>
+          <a:ln>
+            <a:noFill/>
+          </a:ln>
+        </p:spPr>
+        <p:style>
+          <a:lnRef idx="1">
+            <a:schemeClr val="accent1"/>
+          </a:lnRef>
+          <a:fillRef idx="3">
+            <a:schemeClr val="accent1"/>
+          </a:fillRef>
+          <a:effectRef idx="2">
+            <a:schemeClr val="accent1"/>
+          </a:effectRef>
+          <a:fontRef idx="minor">
+            <a:schemeClr val="lt1"/>
+          </a:fontRef>
+        </p:style>
+        <p:txBody>
+          <a:bodyPr rtlCol="0" anchor="ctr"/>
+          <a:lstStyle/>
+          <a:p>
+            <a:pPr algn="ctr"/>
+          </a:p>
+        </p:txBody>
+      </p:sp>
+      <p:sp>
+        <p:nvSpPr>
+          <p:cNvPr id="36" name="TextBox 35"/>
+          <p:cNvSpPr txBox="1"/>
+          <p:nvPr/>
+        </p:nvSpPr>
+        <p:spPr>
+          <a:xfrm>
+            <a:off x="640080" y="3026663"/>
+            <a:ext cx="3017520" cy="265176"/>
+          </a:xfrm>
+          <a:prstGeom prst="rect">
+            <a:avLst/>
+          </a:prstGeom>
+          <a:noFill/>
+        </p:spPr>
+        <p:txBody>
+          <a:bodyPr wrap="square" lIns="13716" rIns="13716" tIns="0" bIns="0">
+            <a:spAutoFit/>
+          </a:bodyPr>
+          <a:lstStyle/>
+          <a:p>
+            <a:pPr>
+              <a:spcBef>
+                <a:spcPts val="0"/>
+              </a:spcBef>
+              <a:spcAft>
+                <a:spcPts val="500"/>
+              </a:spcAft>
+              <a:defRPr sz="1500" b="0">
+                <a:solidFill>
+                  <a:srgbClr val="092A20"/>
+                </a:solidFill>
+                <a:latin typeface="Arial"/>
+              </a:defRPr>
+            </a:pPr>
+            <a:r>
+              <a:t>E  Закупка</a:t>
+            </a:r>
+          </a:p>
+        </p:txBody>
+      </p:sp>
+      <p:sp>
+        <p:nvSpPr>
+          <p:cNvPr id="37" name="Rounded Rectangle 36"/>
+          <p:cNvSpPr/>
+          <p:nvPr/>
+        </p:nvSpPr>
+        <p:spPr>
+          <a:xfrm>
+            <a:off x="4841094" y="3067811"/>
+            <a:ext cx="760444" cy="164592"/>
+          </a:xfrm>
+          <a:prstGeom prst="roundRect">
+            <a:avLst>
+              <a:gd name="adj" fmla="val 8000"/>
+            </a:avLst>
+          </a:prstGeom>
+          <a:solidFill>
+            <a:srgbClr val="164C38"/>
+          </a:solidFill>
+          <a:ln>
+            <a:noFill/>
+          </a:ln>
+        </p:spPr>
+        <p:style>
+          <a:lnRef idx="1">
+            <a:schemeClr val="accent1"/>
+          </a:lnRef>
+          <a:fillRef idx="3">
+            <a:schemeClr val="accent1"/>
+          </a:fillRef>
+          <a:effectRef idx="2">
+            <a:schemeClr val="accent1"/>
+          </a:effectRef>
+          <a:fontRef idx="minor">
+            <a:schemeClr val="lt1"/>
+          </a:fontRef>
+        </p:style>
+        <p:txBody>
+          <a:bodyPr rtlCol="0" anchor="ctr"/>
+          <a:lstStyle/>
+          <a:p>
+            <a:pPr algn="ctr"/>
+          </a:p>
+        </p:txBody>
+      </p:sp>
+      <p:sp>
+        <p:nvSpPr>
+          <p:cNvPr id="38" name="TextBox 37"/>
+          <p:cNvSpPr txBox="1"/>
+          <p:nvPr/>
+        </p:nvSpPr>
+        <p:spPr>
+          <a:xfrm>
+            <a:off x="640080" y="3291839"/>
+            <a:ext cx="3017520" cy="265176"/>
+          </a:xfrm>
+          <a:prstGeom prst="rect">
+            <a:avLst/>
+          </a:prstGeom>
+          <a:noFill/>
+        </p:spPr>
+        <p:txBody>
+          <a:bodyPr wrap="square" lIns="13716" rIns="13716" tIns="0" bIns="0">
+            <a:spAutoFit/>
+          </a:bodyPr>
+          <a:lstStyle/>
+          <a:p>
+            <a:pPr>
+              <a:spcBef>
+                <a:spcPts val="0"/>
+              </a:spcBef>
+              <a:spcAft>
+                <a:spcPts val="500"/>
+              </a:spcAft>
+              <a:defRPr sz="1500" b="0">
+                <a:solidFill>
+                  <a:srgbClr val="092A20"/>
+                </a:solidFill>
+                <a:latin typeface="Arial"/>
+              </a:defRPr>
+            </a:pPr>
+            <a:r>
+              <a:t>F  Обучение</a:t>
+            </a:r>
+          </a:p>
+        </p:txBody>
+      </p:sp>
+      <p:sp>
+        <p:nvSpPr>
+          <p:cNvPr id="39" name="Rounded Rectangle 38"/>
+          <p:cNvSpPr/>
+          <p:nvPr/>
+        </p:nvSpPr>
+        <p:spPr>
+          <a:xfrm>
+            <a:off x="4841094" y="3332987"/>
+            <a:ext cx="912533" cy="164592"/>
+          </a:xfrm>
+          <a:prstGeom prst="roundRect">
+            <a:avLst>
+              <a:gd name="adj" fmla="val 8000"/>
+            </a:avLst>
+          </a:prstGeom>
+          <a:solidFill>
+            <a:srgbClr val="91B663"/>
+          </a:solidFill>
+          <a:ln>
+            <a:noFill/>
+          </a:ln>
+        </p:spPr>
+        <p:style>
+          <a:lnRef idx="1">
+            <a:schemeClr val="accent1"/>
+          </a:lnRef>
+          <a:fillRef idx="3">
+            <a:schemeClr val="accent1"/>
+          </a:fillRef>
+          <a:effectRef idx="2">
+            <a:schemeClr val="accent1"/>
+          </a:effectRef>
+          <a:fontRef idx="minor">
+            <a:schemeClr val="lt1"/>
+          </a:fontRef>
+        </p:style>
+        <p:txBody>
+          <a:bodyPr rtlCol="0" anchor="ctr"/>
+          <a:lstStyle/>
+          <a:p>
+            <a:pPr algn="ctr"/>
+          </a:p>
+        </p:txBody>
+      </p:sp>
+      <p:sp>
+        <p:nvSpPr>
+          <p:cNvPr id="40" name="TextBox 39"/>
+          <p:cNvSpPr txBox="1"/>
+          <p:nvPr/>
+        </p:nvSpPr>
+        <p:spPr>
+          <a:xfrm>
+            <a:off x="640080" y="3557015"/>
+            <a:ext cx="3017520" cy="265176"/>
+          </a:xfrm>
+          <a:prstGeom prst="rect">
+            <a:avLst/>
+          </a:prstGeom>
+          <a:noFill/>
+        </p:spPr>
+        <p:txBody>
+          <a:bodyPr wrap="square" lIns="13716" rIns="13716" tIns="0" bIns="0">
+            <a:spAutoFit/>
+          </a:bodyPr>
+          <a:lstStyle/>
+          <a:p>
+            <a:pPr>
+              <a:spcBef>
+                <a:spcPts val="0"/>
+              </a:spcBef>
+              <a:spcAft>
+                <a:spcPts val="500"/>
+              </a:spcAft>
+              <a:defRPr sz="1500" b="0">
+                <a:solidFill>
+                  <a:srgbClr val="092A20"/>
+                </a:solidFill>
+                <a:latin typeface="Arial"/>
+              </a:defRPr>
+            </a:pPr>
+            <a:r>
+              <a:t>G  Готовность БВС</a:t>
+            </a:r>
+          </a:p>
+        </p:txBody>
+      </p:sp>
+      <p:sp>
+        <p:nvSpPr>
+          <p:cNvPr id="41" name="Rounded Rectangle 40"/>
+          <p:cNvSpPr/>
+          <p:nvPr/>
+        </p:nvSpPr>
+        <p:spPr>
+          <a:xfrm>
+            <a:off x="5601539" y="3598163"/>
+            <a:ext cx="912533" cy="164592"/>
+          </a:xfrm>
+          <a:prstGeom prst="roundRect">
+            <a:avLst>
+              <a:gd name="adj" fmla="val 8000"/>
+            </a:avLst>
+          </a:prstGeom>
+          <a:solidFill>
+            <a:srgbClr val="164C38"/>
+          </a:solidFill>
+          <a:ln>
+            <a:noFill/>
+          </a:ln>
+        </p:spPr>
+        <p:style>
+          <a:lnRef idx="1">
+            <a:schemeClr val="accent1"/>
+          </a:lnRef>
+          <a:fillRef idx="3">
+            <a:schemeClr val="accent1"/>
+          </a:fillRef>
+          <a:effectRef idx="2">
+            <a:schemeClr val="accent1"/>
+          </a:effectRef>
+          <a:fontRef idx="minor">
+            <a:schemeClr val="lt1"/>
+          </a:fontRef>
+        </p:style>
+        <p:txBody>
+          <a:bodyPr rtlCol="0" anchor="ctr"/>
+          <a:lstStyle/>
+          <a:p>
+            <a:pPr algn="ctr"/>
+          </a:p>
+        </p:txBody>
+      </p:sp>
+      <p:sp>
+        <p:nvSpPr>
+          <p:cNvPr id="42" name="TextBox 41"/>
+          <p:cNvSpPr txBox="1"/>
+          <p:nvPr/>
+        </p:nvSpPr>
+        <p:spPr>
+          <a:xfrm>
+            <a:off x="640080" y="3822191"/>
+            <a:ext cx="3017520" cy="265176"/>
+          </a:xfrm>
+          <a:prstGeom prst="rect">
+            <a:avLst/>
+          </a:prstGeom>
+          <a:noFill/>
+        </p:spPr>
+        <p:txBody>
+          <a:bodyPr wrap="square" lIns="13716" rIns="13716" tIns="0" bIns="0">
+            <a:spAutoFit/>
+          </a:bodyPr>
+          <a:lstStyle/>
+          <a:p>
+            <a:pPr>
+              <a:spcBef>
+                <a:spcPts val="0"/>
+              </a:spcBef>
+              <a:spcAft>
+                <a:spcPts val="500"/>
+              </a:spcAft>
+              <a:defRPr sz="1500" b="0">
+                <a:solidFill>
+                  <a:srgbClr val="092A20"/>
+                </a:solidFill>
+                <a:latin typeface="Arial"/>
+              </a:defRPr>
+            </a:pPr>
+            <a:r>
+              <a:t>H  SOP / CRM</a:t>
+            </a:r>
+          </a:p>
+        </p:txBody>
+      </p:sp>
+      <p:sp>
+        <p:nvSpPr>
+          <p:cNvPr id="43" name="Rounded Rectangle 42"/>
+          <p:cNvSpPr/>
+          <p:nvPr/>
+        </p:nvSpPr>
+        <p:spPr>
+          <a:xfrm>
+            <a:off x="5753628" y="3863339"/>
+            <a:ext cx="456266" cy="164592"/>
+          </a:xfrm>
+          <a:prstGeom prst="roundRect">
+            <a:avLst>
+              <a:gd name="adj" fmla="val 8000"/>
+            </a:avLst>
+          </a:prstGeom>
+          <a:solidFill>
+            <a:srgbClr val="91B663"/>
+          </a:solidFill>
+          <a:ln>
+            <a:noFill/>
+          </a:ln>
+        </p:spPr>
+        <p:style>
+          <a:lnRef idx="1">
+            <a:schemeClr val="accent1"/>
+          </a:lnRef>
+          <a:fillRef idx="3">
+            <a:schemeClr val="accent1"/>
+          </a:fillRef>
+          <a:effectRef idx="2">
+            <a:schemeClr val="accent1"/>
+          </a:effectRef>
+          <a:fontRef idx="minor">
+            <a:schemeClr val="lt1"/>
+          </a:fontRef>
+        </p:style>
+        <p:txBody>
+          <a:bodyPr rtlCol="0" anchor="ctr"/>
+          <a:lstStyle/>
+          <a:p>
+            <a:pPr algn="ctr"/>
+          </a:p>
+        </p:txBody>
+      </p:sp>
+      <p:sp>
+        <p:nvSpPr>
+          <p:cNvPr id="44" name="TextBox 43"/>
+          <p:cNvSpPr txBox="1"/>
+          <p:nvPr/>
+        </p:nvSpPr>
+        <p:spPr>
+          <a:xfrm>
+            <a:off x="640080" y="4087368"/>
+            <a:ext cx="3017520" cy="265176"/>
+          </a:xfrm>
+          <a:prstGeom prst="rect">
+            <a:avLst/>
+          </a:prstGeom>
+          <a:noFill/>
+        </p:spPr>
+        <p:txBody>
+          <a:bodyPr wrap="square" lIns="13716" rIns="13716" tIns="0" bIns="0">
+            <a:spAutoFit/>
+          </a:bodyPr>
+          <a:lstStyle/>
+          <a:p>
+            <a:pPr>
+              <a:spcBef>
+                <a:spcPts val="0"/>
+              </a:spcBef>
+              <a:spcAft>
+                <a:spcPts val="500"/>
+              </a:spcAft>
+              <a:defRPr sz="1500" b="0">
+                <a:solidFill>
+                  <a:srgbClr val="092A20"/>
+                </a:solidFill>
+                <a:latin typeface="Arial"/>
+              </a:defRPr>
+            </a:pPr>
+            <a:r>
+              <a:t>I  Испытания</a:t>
+            </a:r>
+          </a:p>
+        </p:txBody>
+      </p:sp>
+      <p:sp>
+        <p:nvSpPr>
+          <p:cNvPr id="45" name="Rounded Rectangle 44"/>
+          <p:cNvSpPr/>
+          <p:nvPr/>
+        </p:nvSpPr>
+        <p:spPr>
+          <a:xfrm>
+            <a:off x="6514073" y="4128515"/>
+            <a:ext cx="304177" cy="164592"/>
+          </a:xfrm>
+          <a:prstGeom prst="roundRect">
+            <a:avLst>
+              <a:gd name="adj" fmla="val 8000"/>
+            </a:avLst>
+          </a:prstGeom>
+          <a:solidFill>
+            <a:srgbClr val="164C38"/>
+          </a:solidFill>
+          <a:ln>
+            <a:noFill/>
+          </a:ln>
+        </p:spPr>
+        <p:style>
+          <a:lnRef idx="1">
+            <a:schemeClr val="accent1"/>
+          </a:lnRef>
+          <a:fillRef idx="3">
+            <a:schemeClr val="accent1"/>
+          </a:fillRef>
+          <a:effectRef idx="2">
+            <a:schemeClr val="accent1"/>
+          </a:effectRef>
+          <a:fontRef idx="minor">
+            <a:schemeClr val="lt1"/>
+          </a:fontRef>
+        </p:style>
+        <p:txBody>
+          <a:bodyPr rtlCol="0" anchor="ctr"/>
+          <a:lstStyle/>
+          <a:p>
+            <a:pPr algn="ctr"/>
+          </a:p>
+        </p:txBody>
+      </p:sp>
+      <p:sp>
+        <p:nvSpPr>
+          <p:cNvPr id="46" name="TextBox 45"/>
+          <p:cNvSpPr txBox="1"/>
+          <p:nvPr/>
+        </p:nvSpPr>
+        <p:spPr>
+          <a:xfrm>
+            <a:off x="640080" y="4352544"/>
+            <a:ext cx="3017520" cy="265176"/>
+          </a:xfrm>
+          <a:prstGeom prst="rect">
+            <a:avLst/>
+          </a:prstGeom>
+          <a:noFill/>
+        </p:spPr>
+        <p:txBody>
+          <a:bodyPr wrap="square" lIns="13716" rIns="13716" tIns="0" bIns="0">
+            <a:spAutoFit/>
+          </a:bodyPr>
+          <a:lstStyle/>
+          <a:p>
+            <a:pPr>
+              <a:spcBef>
+                <a:spcPts val="0"/>
+              </a:spcBef>
+              <a:spcAft>
+                <a:spcPts val="500"/>
+              </a:spcAft>
+              <a:defRPr sz="1500" b="0">
+                <a:solidFill>
+                  <a:srgbClr val="092A20"/>
+                </a:solidFill>
+                <a:latin typeface="Arial"/>
+              </a:defRPr>
+            </a:pPr>
+            <a:r>
+              <a:t>J  Договоры сезона</a:t>
+            </a:r>
+          </a:p>
+        </p:txBody>
+      </p:sp>
+      <p:sp>
+        <p:nvSpPr>
+          <p:cNvPr id="47" name="Rounded Rectangle 46"/>
+          <p:cNvSpPr/>
+          <p:nvPr/>
+        </p:nvSpPr>
+        <p:spPr>
+          <a:xfrm>
+            <a:off x="6818251" y="4393692"/>
+            <a:ext cx="304177" cy="164592"/>
+          </a:xfrm>
+          <a:prstGeom prst="roundRect">
+            <a:avLst>
+              <a:gd name="adj" fmla="val 8000"/>
+            </a:avLst>
+          </a:prstGeom>
+          <a:solidFill>
+            <a:srgbClr val="164C38"/>
+          </a:solidFill>
+          <a:ln>
+            <a:noFill/>
+          </a:ln>
+        </p:spPr>
+        <p:style>
+          <a:lnRef idx="1">
+            <a:schemeClr val="accent1"/>
+          </a:lnRef>
+          <a:fillRef idx="3">
+            <a:schemeClr val="accent1"/>
+          </a:fillRef>
+          <a:effectRef idx="2">
+            <a:schemeClr val="accent1"/>
+          </a:effectRef>
+          <a:fontRef idx="minor">
+            <a:schemeClr val="lt1"/>
+          </a:fontRef>
+        </p:style>
+        <p:txBody>
+          <a:bodyPr rtlCol="0" anchor="ctr"/>
+          <a:lstStyle/>
+          <a:p>
+            <a:pPr algn="ctr"/>
+          </a:p>
+        </p:txBody>
+      </p:sp>
+      <p:sp>
+        <p:nvSpPr>
+          <p:cNvPr id="48" name="TextBox 47"/>
+          <p:cNvSpPr txBox="1"/>
+          <p:nvPr/>
+        </p:nvSpPr>
+        <p:spPr>
+          <a:xfrm>
+            <a:off x="640080" y="4617720"/>
+            <a:ext cx="3017520" cy="265176"/>
+          </a:xfrm>
+          <a:prstGeom prst="rect">
+            <a:avLst/>
+          </a:prstGeom>
+          <a:noFill/>
+        </p:spPr>
+        <p:txBody>
+          <a:bodyPr wrap="square" lIns="13716" rIns="13716" tIns="0" bIns="0">
+            <a:spAutoFit/>
+          </a:bodyPr>
+          <a:lstStyle/>
+          <a:p>
+            <a:pPr>
+              <a:spcBef>
+                <a:spcPts val="0"/>
+              </a:spcBef>
+              <a:spcAft>
+                <a:spcPts val="500"/>
+              </a:spcAft>
+              <a:defRPr sz="1500" b="0">
+                <a:solidFill>
+                  <a:srgbClr val="092A20"/>
+                </a:solidFill>
+                <a:latin typeface="Arial"/>
+              </a:defRPr>
+            </a:pPr>
+            <a:r>
+              <a:t>M  Ожидание окна</a:t>
+            </a:r>
+          </a:p>
+        </p:txBody>
+      </p:sp>
+      <p:sp>
+        <p:nvSpPr>
+          <p:cNvPr id="49" name="Rounded Rectangle 48"/>
+          <p:cNvSpPr/>
+          <p:nvPr/>
+        </p:nvSpPr>
+        <p:spPr>
+          <a:xfrm>
+            <a:off x="7122429" y="4658868"/>
+            <a:ext cx="456266" cy="164592"/>
+          </a:xfrm>
+          <a:prstGeom prst="roundRect">
+            <a:avLst>
+              <a:gd name="adj" fmla="val 8000"/>
+            </a:avLst>
+          </a:prstGeom>
+          <a:solidFill>
+            <a:srgbClr val="164C38"/>
+          </a:solidFill>
+          <a:ln>
+            <a:noFill/>
+          </a:ln>
+        </p:spPr>
+        <p:style>
+          <a:lnRef idx="1">
+            <a:schemeClr val="accent1"/>
+          </a:lnRef>
+          <a:fillRef idx="3">
+            <a:schemeClr val="accent1"/>
+          </a:fillRef>
+          <a:effectRef idx="2">
+            <a:schemeClr val="accent1"/>
+          </a:effectRef>
+          <a:fontRef idx="minor">
+            <a:schemeClr val="lt1"/>
+          </a:fontRef>
+        </p:style>
+        <p:txBody>
+          <a:bodyPr rtlCol="0" anchor="ctr"/>
+          <a:lstStyle/>
+          <a:p>
+            <a:pPr algn="ctr"/>
+          </a:p>
+        </p:txBody>
+      </p:sp>
+      <p:sp>
+        <p:nvSpPr>
+          <p:cNvPr id="50" name="TextBox 49"/>
+          <p:cNvSpPr txBox="1"/>
+          <p:nvPr/>
+        </p:nvSpPr>
+        <p:spPr>
+          <a:xfrm>
+            <a:off x="640080" y="4882896"/>
+            <a:ext cx="3017520" cy="265176"/>
+          </a:xfrm>
+          <a:prstGeom prst="rect">
+            <a:avLst/>
+          </a:prstGeom>
+          <a:noFill/>
+        </p:spPr>
+        <p:txBody>
+          <a:bodyPr wrap="square" lIns="13716" rIns="13716" tIns="0" bIns="0">
+            <a:spAutoFit/>
+          </a:bodyPr>
+          <a:lstStyle/>
+          <a:p>
+            <a:pPr>
+              <a:spcBef>
+                <a:spcPts val="0"/>
+              </a:spcBef>
+              <a:spcAft>
+                <a:spcPts val="500"/>
+              </a:spcAft>
+              <a:defRPr sz="1500" b="0">
+                <a:solidFill>
+                  <a:srgbClr val="092A20"/>
+                </a:solidFill>
+                <a:latin typeface="Arial"/>
+              </a:defRPr>
+            </a:pPr>
+            <a:r>
+              <a:t>K  Сезон</a:t>
+            </a:r>
+          </a:p>
+        </p:txBody>
+      </p:sp>
+      <p:sp>
+        <p:nvSpPr>
+          <p:cNvPr id="51" name="Rounded Rectangle 50"/>
+          <p:cNvSpPr/>
+          <p:nvPr/>
+        </p:nvSpPr>
+        <p:spPr>
+          <a:xfrm>
+            <a:off x="7578696" y="4924044"/>
+            <a:ext cx="3345957" cy="164592"/>
+          </a:xfrm>
+          <a:prstGeom prst="roundRect">
+            <a:avLst>
+              <a:gd name="adj" fmla="val 8000"/>
+            </a:avLst>
+          </a:prstGeom>
+          <a:solidFill>
+            <a:srgbClr val="164C38"/>
+          </a:solidFill>
+          <a:ln>
+            <a:noFill/>
+          </a:ln>
+        </p:spPr>
+        <p:style>
+          <a:lnRef idx="1">
+            <a:schemeClr val="accent1"/>
+          </a:lnRef>
+          <a:fillRef idx="3">
+            <a:schemeClr val="accent1"/>
+          </a:fillRef>
+          <a:effectRef idx="2">
+            <a:schemeClr val="accent1"/>
+          </a:effectRef>
+          <a:fontRef idx="minor">
+            <a:schemeClr val="lt1"/>
+          </a:fontRef>
+        </p:style>
+        <p:txBody>
+          <a:bodyPr rtlCol="0" anchor="ctr"/>
+          <a:lstStyle/>
+          <a:p>
+            <a:pPr algn="ctr"/>
+          </a:p>
+        </p:txBody>
+      </p:sp>
+      <p:sp>
+        <p:nvSpPr>
+          <p:cNvPr id="52" name="TextBox 51"/>
+          <p:cNvSpPr txBox="1"/>
+          <p:nvPr/>
+        </p:nvSpPr>
+        <p:spPr>
+          <a:xfrm>
+            <a:off x="640080" y="5148071"/>
+            <a:ext cx="3017520" cy="265176"/>
+          </a:xfrm>
+          <a:prstGeom prst="rect">
+            <a:avLst/>
+          </a:prstGeom>
+          <a:noFill/>
+        </p:spPr>
+        <p:txBody>
+          <a:bodyPr wrap="square" lIns="13716" rIns="13716" tIns="0" bIns="0">
+            <a:spAutoFit/>
+          </a:bodyPr>
+          <a:lstStyle/>
+          <a:p>
+            <a:pPr>
+              <a:spcBef>
+                <a:spcPts val="0"/>
+              </a:spcBef>
+              <a:spcAft>
+                <a:spcPts val="500"/>
+              </a:spcAft>
+              <a:defRPr sz="1500" b="0">
+                <a:solidFill>
+                  <a:srgbClr val="092A20"/>
+                </a:solidFill>
+                <a:latin typeface="Arial"/>
+              </a:defRPr>
+            </a:pPr>
+            <a:r>
+              <a:t>L  Аудит</a:t>
+            </a:r>
+          </a:p>
+        </p:txBody>
+      </p:sp>
+      <p:sp>
+        <p:nvSpPr>
+          <p:cNvPr id="53" name="Rounded Rectangle 52"/>
+          <p:cNvSpPr/>
+          <p:nvPr/>
+        </p:nvSpPr>
+        <p:spPr>
+          <a:xfrm>
+            <a:off x="10924654" y="5189219"/>
+            <a:ext cx="304177" cy="164592"/>
+          </a:xfrm>
+          <a:prstGeom prst="roundRect">
+            <a:avLst>
+              <a:gd name="adj" fmla="val 8000"/>
+            </a:avLst>
+          </a:prstGeom>
+          <a:solidFill>
+            <a:srgbClr val="164C38"/>
+          </a:solidFill>
+          <a:ln>
+            <a:noFill/>
+          </a:ln>
+        </p:spPr>
+        <p:style>
+          <a:lnRef idx="1">
+            <a:schemeClr val="accent1"/>
+          </a:lnRef>
+          <a:fillRef idx="3">
+            <a:schemeClr val="accent1"/>
+          </a:fillRef>
+          <a:effectRef idx="2">
+            <a:schemeClr val="accent1"/>
+          </a:effectRef>
+          <a:fontRef idx="minor">
+            <a:schemeClr val="lt1"/>
+          </a:fontRef>
+        </p:style>
+        <p:txBody>
+          <a:bodyPr rtlCol="0" anchor="ctr"/>
+          <a:lstStyle/>
+          <a:p>
+            <a:pPr algn="ctr"/>
+          </a:p>
+        </p:txBody>
+      </p:sp>
+      <p:sp>
+        <p:nvSpPr>
+          <p:cNvPr id="54" name="TextBox 53"/>
+          <p:cNvSpPr txBox="1"/>
+          <p:nvPr/>
+        </p:nvSpPr>
+        <p:spPr>
+          <a:xfrm>
+            <a:off x="640080" y="5522976"/>
+            <a:ext cx="10698480" cy="301752"/>
           </a:xfrm>
           <a:prstGeom prst="rect">
             <a:avLst/>
@@ -14309,1272 +15332,14 @@
               </a:defRPr>
             </a:pPr>
             <a:r>
-              <a:t>50</a:t>
-            </a:r>
-          </a:p>
-        </p:txBody>
-      </p:sp>
-      <p:sp>
-        <p:nvSpPr>
-          <p:cNvPr id="30" name="Rectangle 29"/>
-          <p:cNvSpPr/>
-          <p:nvPr/>
-        </p:nvSpPr>
-        <p:spPr>
-          <a:xfrm>
-            <a:off x="11228832" y="1965960"/>
-            <a:ext cx="7315" cy="3630168"/>
-          </a:xfrm>
-          <a:prstGeom prst="rect">
-            <a:avLst/>
-          </a:prstGeom>
-          <a:solidFill>
-            <a:srgbClr val="EFF4EF"/>
-          </a:solidFill>
-          <a:ln>
-            <a:noFill/>
-          </a:ln>
-        </p:spPr>
-        <p:style>
-          <a:lnRef idx="1">
-            <a:schemeClr val="accent1"/>
-          </a:lnRef>
-          <a:fillRef idx="3">
-            <a:schemeClr val="accent1"/>
-          </a:fillRef>
-          <a:effectRef idx="2">
-            <a:schemeClr val="accent1"/>
-          </a:effectRef>
-          <a:fontRef idx="minor">
-            <a:schemeClr val="lt1"/>
-          </a:fontRef>
-        </p:style>
-        <p:txBody>
-          <a:bodyPr rtlCol="0" anchor="ctr"/>
-          <a:lstStyle/>
-          <a:p>
-            <a:pPr algn="ctr"/>
-          </a:p>
-        </p:txBody>
-      </p:sp>
-      <p:sp>
-        <p:nvSpPr>
-          <p:cNvPr id="31" name="TextBox 30"/>
-          <p:cNvSpPr txBox="1"/>
-          <p:nvPr/>
-        </p:nvSpPr>
-        <p:spPr>
-          <a:xfrm>
-            <a:off x="11091672" y="1746504"/>
-            <a:ext cx="365760" cy="228600"/>
-          </a:xfrm>
-          <a:prstGeom prst="rect">
-            <a:avLst/>
-          </a:prstGeom>
-          <a:noFill/>
-        </p:spPr>
-        <p:txBody>
-          <a:bodyPr wrap="square" lIns="13716" rIns="13716" tIns="0" bIns="0">
-            <a:spAutoFit/>
-          </a:bodyPr>
-          <a:lstStyle/>
-          <a:p>
-            <a:pPr>
-              <a:spcBef>
-                <a:spcPts val="0"/>
-              </a:spcBef>
-              <a:spcAft>
-                <a:spcPts val="500"/>
-              </a:spcAft>
-              <a:defRPr sz="1500" b="0">
-                <a:solidFill>
-                  <a:srgbClr val="164C38"/>
-                </a:solidFill>
-                <a:latin typeface="Arial"/>
-              </a:defRPr>
-            </a:pPr>
-            <a:r>
-              <a:t>55</a:t>
-            </a:r>
-          </a:p>
-        </p:txBody>
-      </p:sp>
-      <p:sp>
-        <p:nvSpPr>
-          <p:cNvPr id="32" name="TextBox 31"/>
-          <p:cNvSpPr txBox="1"/>
-          <p:nvPr/>
-        </p:nvSpPr>
-        <p:spPr>
-          <a:xfrm>
-            <a:off x="640080" y="1965960"/>
-            <a:ext cx="3017520" cy="265176"/>
-          </a:xfrm>
-          <a:prstGeom prst="rect">
-            <a:avLst/>
-          </a:prstGeom>
-          <a:noFill/>
-        </p:spPr>
-        <p:txBody>
-          <a:bodyPr wrap="square" lIns="13716" rIns="13716" tIns="0" bIns="0">
-            <a:spAutoFit/>
-          </a:bodyPr>
-          <a:lstStyle/>
-          <a:p>
-            <a:pPr>
-              <a:spcBef>
-                <a:spcPts val="0"/>
-              </a:spcBef>
-              <a:spcAft>
-                <a:spcPts val="500"/>
-              </a:spcAft>
-              <a:defRPr sz="1500" b="0">
-                <a:solidFill>
-                  <a:srgbClr val="092A20"/>
-                </a:solidFill>
-                <a:latin typeface="Arial"/>
-              </a:defRPr>
-            </a:pPr>
-            <a:r>
-              <a:t>A  Правовой gate</a:t>
-            </a:r>
-          </a:p>
-        </p:txBody>
-      </p:sp>
-      <p:sp>
-        <p:nvSpPr>
-          <p:cNvPr id="33" name="Rounded Rectangle 32"/>
-          <p:cNvSpPr/>
-          <p:nvPr/>
-        </p:nvSpPr>
-        <p:spPr>
-          <a:xfrm>
-            <a:off x="3776472" y="2007107"/>
-            <a:ext cx="541989" cy="164592"/>
-          </a:xfrm>
-          <a:prstGeom prst="roundRect">
-            <a:avLst>
-              <a:gd name="adj" fmla="val 8000"/>
-            </a:avLst>
-          </a:prstGeom>
-          <a:solidFill>
-            <a:srgbClr val="164C38"/>
-          </a:solidFill>
-          <a:ln>
-            <a:noFill/>
-          </a:ln>
-        </p:spPr>
-        <p:style>
-          <a:lnRef idx="1">
-            <a:schemeClr val="accent1"/>
-          </a:lnRef>
-          <a:fillRef idx="3">
-            <a:schemeClr val="accent1"/>
-          </a:fillRef>
-          <a:effectRef idx="2">
-            <a:schemeClr val="accent1"/>
-          </a:effectRef>
-          <a:fontRef idx="minor">
-            <a:schemeClr val="lt1"/>
-          </a:fontRef>
-        </p:style>
-        <p:txBody>
-          <a:bodyPr rtlCol="0" anchor="ctr"/>
-          <a:lstStyle/>
-          <a:p>
-            <a:pPr algn="ctr"/>
-          </a:p>
-        </p:txBody>
-      </p:sp>
-      <p:sp>
-        <p:nvSpPr>
-          <p:cNvPr id="34" name="TextBox 33"/>
-          <p:cNvSpPr txBox="1"/>
-          <p:nvPr/>
-        </p:nvSpPr>
-        <p:spPr>
-          <a:xfrm>
-            <a:off x="640080" y="2231136"/>
-            <a:ext cx="3017520" cy="265176"/>
-          </a:xfrm>
-          <a:prstGeom prst="rect">
-            <a:avLst/>
-          </a:prstGeom>
-          <a:noFill/>
-        </p:spPr>
-        <p:txBody>
-          <a:bodyPr wrap="square" lIns="13716" rIns="13716" tIns="0" bIns="0">
-            <a:spAutoFit/>
-          </a:bodyPr>
-          <a:lstStyle/>
-          <a:p>
-            <a:pPr>
-              <a:spcBef>
-                <a:spcPts val="0"/>
-              </a:spcBef>
-              <a:spcAft>
-                <a:spcPts val="500"/>
-              </a:spcAft>
-              <a:defRPr sz="1500" b="0">
-                <a:solidFill>
-                  <a:srgbClr val="092A20"/>
-                </a:solidFill>
-                <a:latin typeface="Arial"/>
-              </a:defRPr>
-            </a:pPr>
-            <a:r>
-              <a:t>B  Спрос / заявки</a:t>
-            </a:r>
-          </a:p>
-        </p:txBody>
-      </p:sp>
-      <p:sp>
-        <p:nvSpPr>
-          <p:cNvPr id="35" name="Rounded Rectangle 34"/>
-          <p:cNvSpPr/>
-          <p:nvPr/>
-        </p:nvSpPr>
-        <p:spPr>
-          <a:xfrm>
-            <a:off x="3776472" y="2272284"/>
-            <a:ext cx="677487" cy="164592"/>
-          </a:xfrm>
-          <a:prstGeom prst="roundRect">
-            <a:avLst>
-              <a:gd name="adj" fmla="val 8000"/>
-            </a:avLst>
-          </a:prstGeom>
-          <a:solidFill>
-            <a:srgbClr val="91B663"/>
-          </a:solidFill>
-          <a:ln>
-            <a:noFill/>
-          </a:ln>
-        </p:spPr>
-        <p:style>
-          <a:lnRef idx="1">
-            <a:schemeClr val="accent1"/>
-          </a:lnRef>
-          <a:fillRef idx="3">
-            <a:schemeClr val="accent1"/>
-          </a:fillRef>
-          <a:effectRef idx="2">
-            <a:schemeClr val="accent1"/>
-          </a:effectRef>
-          <a:fontRef idx="minor">
-            <a:schemeClr val="lt1"/>
-          </a:fontRef>
-        </p:style>
-        <p:txBody>
-          <a:bodyPr rtlCol="0" anchor="ctr"/>
-          <a:lstStyle/>
-          <a:p>
-            <a:pPr algn="ctr"/>
-          </a:p>
-        </p:txBody>
-      </p:sp>
-      <p:sp>
-        <p:nvSpPr>
-          <p:cNvPr id="36" name="TextBox 35"/>
-          <p:cNvSpPr txBox="1"/>
-          <p:nvPr/>
-        </p:nvSpPr>
-        <p:spPr>
-          <a:xfrm>
-            <a:off x="640080" y="2496312"/>
-            <a:ext cx="3017520" cy="265176"/>
-          </a:xfrm>
-          <a:prstGeom prst="rect">
-            <a:avLst/>
-          </a:prstGeom>
-          <a:noFill/>
-        </p:spPr>
-        <p:txBody>
-          <a:bodyPr wrap="square" lIns="13716" rIns="13716" tIns="0" bIns="0">
-            <a:spAutoFit/>
-          </a:bodyPr>
-          <a:lstStyle/>
-          <a:p>
-            <a:pPr>
-              <a:spcBef>
-                <a:spcPts val="0"/>
-              </a:spcBef>
-              <a:spcAft>
-                <a:spcPts val="500"/>
-              </a:spcAft>
-              <a:defRPr sz="1500" b="0">
-                <a:solidFill>
-                  <a:srgbClr val="092A20"/>
-                </a:solidFill>
-                <a:latin typeface="Arial"/>
-              </a:defRPr>
-            </a:pPr>
-            <a:r>
-              <a:t>C  ООО и договоры</a:t>
-            </a:r>
-          </a:p>
-        </p:txBody>
-      </p:sp>
-      <p:sp>
-        <p:nvSpPr>
-          <p:cNvPr id="37" name="Rounded Rectangle 36"/>
-          <p:cNvSpPr/>
-          <p:nvPr/>
-        </p:nvSpPr>
-        <p:spPr>
-          <a:xfrm>
-            <a:off x="4318461" y="2537460"/>
-            <a:ext cx="406492" cy="164592"/>
-          </a:xfrm>
-          <a:prstGeom prst="roundRect">
-            <a:avLst>
-              <a:gd name="adj" fmla="val 8000"/>
-            </a:avLst>
-          </a:prstGeom>
-          <a:solidFill>
-            <a:srgbClr val="164C38"/>
-          </a:solidFill>
-          <a:ln>
-            <a:noFill/>
-          </a:ln>
-        </p:spPr>
-        <p:style>
-          <a:lnRef idx="1">
-            <a:schemeClr val="accent1"/>
-          </a:lnRef>
-          <a:fillRef idx="3">
-            <a:schemeClr val="accent1"/>
-          </a:fillRef>
-          <a:effectRef idx="2">
-            <a:schemeClr val="accent1"/>
-          </a:effectRef>
-          <a:fontRef idx="minor">
-            <a:schemeClr val="lt1"/>
-          </a:fontRef>
-        </p:style>
-        <p:txBody>
-          <a:bodyPr rtlCol="0" anchor="ctr"/>
-          <a:lstStyle/>
-          <a:p>
-            <a:pPr algn="ctr"/>
-          </a:p>
-        </p:txBody>
-      </p:sp>
-      <p:sp>
-        <p:nvSpPr>
-          <p:cNvPr id="38" name="TextBox 37"/>
-          <p:cNvSpPr txBox="1"/>
-          <p:nvPr/>
-        </p:nvSpPr>
-        <p:spPr>
-          <a:xfrm>
-            <a:off x="640080" y="2761487"/>
-            <a:ext cx="3017520" cy="265176"/>
-          </a:xfrm>
-          <a:prstGeom prst="rect">
-            <a:avLst/>
-          </a:prstGeom>
-          <a:noFill/>
-        </p:spPr>
-        <p:txBody>
-          <a:bodyPr wrap="square" lIns="13716" rIns="13716" tIns="0" bIns="0">
-            <a:spAutoFit/>
-          </a:bodyPr>
-          <a:lstStyle/>
-          <a:p>
-            <a:pPr>
-              <a:spcBef>
-                <a:spcPts val="0"/>
-              </a:spcBef>
-              <a:spcAft>
-                <a:spcPts val="500"/>
-              </a:spcAft>
-              <a:defRPr sz="1500" b="0">
-                <a:solidFill>
-                  <a:srgbClr val="092A20"/>
-                </a:solidFill>
-                <a:latin typeface="Arial"/>
-              </a:defRPr>
-            </a:pPr>
-            <a:r>
-              <a:t>D  Финансирование</a:t>
-            </a:r>
-          </a:p>
-        </p:txBody>
-      </p:sp>
-      <p:sp>
-        <p:nvSpPr>
-          <p:cNvPr id="39" name="Rounded Rectangle 38"/>
-          <p:cNvSpPr/>
-          <p:nvPr/>
-        </p:nvSpPr>
-        <p:spPr>
-          <a:xfrm>
-            <a:off x="4724954" y="2802635"/>
-            <a:ext cx="135497" cy="164592"/>
-          </a:xfrm>
-          <a:prstGeom prst="roundRect">
-            <a:avLst>
-              <a:gd name="adj" fmla="val 8000"/>
-            </a:avLst>
-          </a:prstGeom>
-          <a:solidFill>
-            <a:srgbClr val="164C38"/>
-          </a:solidFill>
-          <a:ln>
-            <a:noFill/>
-          </a:ln>
-        </p:spPr>
-        <p:style>
-          <a:lnRef idx="1">
-            <a:schemeClr val="accent1"/>
-          </a:lnRef>
-          <a:fillRef idx="3">
-            <a:schemeClr val="accent1"/>
-          </a:fillRef>
-          <a:effectRef idx="2">
-            <a:schemeClr val="accent1"/>
-          </a:effectRef>
-          <a:fontRef idx="minor">
-            <a:schemeClr val="lt1"/>
-          </a:fontRef>
-        </p:style>
-        <p:txBody>
-          <a:bodyPr rtlCol="0" anchor="ctr"/>
-          <a:lstStyle/>
-          <a:p>
-            <a:pPr algn="ctr"/>
-          </a:p>
-        </p:txBody>
-      </p:sp>
-      <p:sp>
-        <p:nvSpPr>
-          <p:cNvPr id="40" name="TextBox 39"/>
-          <p:cNvSpPr txBox="1"/>
-          <p:nvPr/>
-        </p:nvSpPr>
-        <p:spPr>
-          <a:xfrm>
-            <a:off x="640080" y="3026663"/>
-            <a:ext cx="3017520" cy="265176"/>
-          </a:xfrm>
-          <a:prstGeom prst="rect">
-            <a:avLst/>
-          </a:prstGeom>
-          <a:noFill/>
-        </p:spPr>
-        <p:txBody>
-          <a:bodyPr wrap="square" lIns="13716" rIns="13716" tIns="0" bIns="0">
-            <a:spAutoFit/>
-          </a:bodyPr>
-          <a:lstStyle/>
-          <a:p>
-            <a:pPr>
-              <a:spcBef>
-                <a:spcPts val="0"/>
-              </a:spcBef>
-              <a:spcAft>
-                <a:spcPts val="500"/>
-              </a:spcAft>
-              <a:defRPr sz="1500" b="0">
-                <a:solidFill>
-                  <a:srgbClr val="092A20"/>
-                </a:solidFill>
-                <a:latin typeface="Arial"/>
-              </a:defRPr>
-            </a:pPr>
-            <a:r>
-              <a:t>E  Закупка</a:t>
-            </a:r>
-          </a:p>
-        </p:txBody>
-      </p:sp>
-      <p:sp>
-        <p:nvSpPr>
-          <p:cNvPr id="41" name="Rounded Rectangle 40"/>
-          <p:cNvSpPr/>
-          <p:nvPr/>
-        </p:nvSpPr>
-        <p:spPr>
-          <a:xfrm>
-            <a:off x="4860451" y="3067811"/>
-            <a:ext cx="677487" cy="164592"/>
-          </a:xfrm>
-          <a:prstGeom prst="roundRect">
-            <a:avLst>
-              <a:gd name="adj" fmla="val 8000"/>
-            </a:avLst>
-          </a:prstGeom>
-          <a:solidFill>
-            <a:srgbClr val="164C38"/>
-          </a:solidFill>
-          <a:ln>
-            <a:noFill/>
-          </a:ln>
-        </p:spPr>
-        <p:style>
-          <a:lnRef idx="1">
-            <a:schemeClr val="accent1"/>
-          </a:lnRef>
-          <a:fillRef idx="3">
-            <a:schemeClr val="accent1"/>
-          </a:fillRef>
-          <a:effectRef idx="2">
-            <a:schemeClr val="accent1"/>
-          </a:effectRef>
-          <a:fontRef idx="minor">
-            <a:schemeClr val="lt1"/>
-          </a:fontRef>
-        </p:style>
-        <p:txBody>
-          <a:bodyPr rtlCol="0" anchor="ctr"/>
-          <a:lstStyle/>
-          <a:p>
-            <a:pPr algn="ctr"/>
-          </a:p>
-        </p:txBody>
-      </p:sp>
-      <p:sp>
-        <p:nvSpPr>
-          <p:cNvPr id="42" name="TextBox 41"/>
-          <p:cNvSpPr txBox="1"/>
-          <p:nvPr/>
-        </p:nvSpPr>
-        <p:spPr>
-          <a:xfrm>
-            <a:off x="640080" y="3291839"/>
-            <a:ext cx="3017520" cy="265176"/>
-          </a:xfrm>
-          <a:prstGeom prst="rect">
-            <a:avLst/>
-          </a:prstGeom>
-          <a:noFill/>
-        </p:spPr>
-        <p:txBody>
-          <a:bodyPr wrap="square" lIns="13716" rIns="13716" tIns="0" bIns="0">
-            <a:spAutoFit/>
-          </a:bodyPr>
-          <a:lstStyle/>
-          <a:p>
-            <a:pPr>
-              <a:spcBef>
-                <a:spcPts val="0"/>
-              </a:spcBef>
-              <a:spcAft>
-                <a:spcPts val="500"/>
-              </a:spcAft>
-              <a:defRPr sz="1500" b="0">
-                <a:solidFill>
-                  <a:srgbClr val="092A20"/>
-                </a:solidFill>
-                <a:latin typeface="Arial"/>
-              </a:defRPr>
-            </a:pPr>
-            <a:r>
-              <a:t>F  Обучение</a:t>
-            </a:r>
-          </a:p>
-        </p:txBody>
-      </p:sp>
-      <p:sp>
-        <p:nvSpPr>
-          <p:cNvPr id="43" name="Rounded Rectangle 42"/>
-          <p:cNvSpPr/>
-          <p:nvPr/>
-        </p:nvSpPr>
-        <p:spPr>
-          <a:xfrm>
-            <a:off x="4860451" y="3332987"/>
-            <a:ext cx="812984" cy="164592"/>
-          </a:xfrm>
-          <a:prstGeom prst="roundRect">
-            <a:avLst>
-              <a:gd name="adj" fmla="val 8000"/>
-            </a:avLst>
-          </a:prstGeom>
-          <a:solidFill>
-            <a:srgbClr val="91B663"/>
-          </a:solidFill>
-          <a:ln>
-            <a:noFill/>
-          </a:ln>
-        </p:spPr>
-        <p:style>
-          <a:lnRef idx="1">
-            <a:schemeClr val="accent1"/>
-          </a:lnRef>
-          <a:fillRef idx="3">
-            <a:schemeClr val="accent1"/>
-          </a:fillRef>
-          <a:effectRef idx="2">
-            <a:schemeClr val="accent1"/>
-          </a:effectRef>
-          <a:fontRef idx="minor">
-            <a:schemeClr val="lt1"/>
-          </a:fontRef>
-        </p:style>
-        <p:txBody>
-          <a:bodyPr rtlCol="0" anchor="ctr"/>
-          <a:lstStyle/>
-          <a:p>
-            <a:pPr algn="ctr"/>
-          </a:p>
-        </p:txBody>
-      </p:sp>
-      <p:sp>
-        <p:nvSpPr>
-          <p:cNvPr id="44" name="TextBox 43"/>
-          <p:cNvSpPr txBox="1"/>
-          <p:nvPr/>
-        </p:nvSpPr>
-        <p:spPr>
-          <a:xfrm>
-            <a:off x="640080" y="3557015"/>
-            <a:ext cx="3017520" cy="265176"/>
-          </a:xfrm>
-          <a:prstGeom prst="rect">
-            <a:avLst/>
-          </a:prstGeom>
-          <a:noFill/>
-        </p:spPr>
-        <p:txBody>
-          <a:bodyPr wrap="square" lIns="13716" rIns="13716" tIns="0" bIns="0">
-            <a:spAutoFit/>
-          </a:bodyPr>
-          <a:lstStyle/>
-          <a:p>
-            <a:pPr>
-              <a:spcBef>
-                <a:spcPts val="0"/>
-              </a:spcBef>
-              <a:spcAft>
-                <a:spcPts val="500"/>
-              </a:spcAft>
-              <a:defRPr sz="1500" b="0">
-                <a:solidFill>
-                  <a:srgbClr val="092A20"/>
-                </a:solidFill>
-                <a:latin typeface="Arial"/>
-              </a:defRPr>
-            </a:pPr>
-            <a:r>
-              <a:t>G  Готовность БВС</a:t>
-            </a:r>
-          </a:p>
-        </p:txBody>
-      </p:sp>
-      <p:sp>
-        <p:nvSpPr>
-          <p:cNvPr id="45" name="Rounded Rectangle 44"/>
-          <p:cNvSpPr/>
-          <p:nvPr/>
-        </p:nvSpPr>
-        <p:spPr>
-          <a:xfrm>
-            <a:off x="5537938" y="3598163"/>
-            <a:ext cx="812984" cy="164592"/>
-          </a:xfrm>
-          <a:prstGeom prst="roundRect">
-            <a:avLst>
-              <a:gd name="adj" fmla="val 8000"/>
-            </a:avLst>
-          </a:prstGeom>
-          <a:solidFill>
-            <a:srgbClr val="164C38"/>
-          </a:solidFill>
-          <a:ln>
-            <a:noFill/>
-          </a:ln>
-        </p:spPr>
-        <p:style>
-          <a:lnRef idx="1">
-            <a:schemeClr val="accent1"/>
-          </a:lnRef>
-          <a:fillRef idx="3">
-            <a:schemeClr val="accent1"/>
-          </a:fillRef>
-          <a:effectRef idx="2">
-            <a:schemeClr val="accent1"/>
-          </a:effectRef>
-          <a:fontRef idx="minor">
-            <a:schemeClr val="lt1"/>
-          </a:fontRef>
-        </p:style>
-        <p:txBody>
-          <a:bodyPr rtlCol="0" anchor="ctr"/>
-          <a:lstStyle/>
-          <a:p>
-            <a:pPr algn="ctr"/>
-          </a:p>
-        </p:txBody>
-      </p:sp>
-      <p:sp>
-        <p:nvSpPr>
-          <p:cNvPr id="46" name="TextBox 45"/>
-          <p:cNvSpPr txBox="1"/>
-          <p:nvPr/>
-        </p:nvSpPr>
-        <p:spPr>
-          <a:xfrm>
-            <a:off x="640080" y="3822191"/>
-            <a:ext cx="3017520" cy="265176"/>
-          </a:xfrm>
-          <a:prstGeom prst="rect">
-            <a:avLst/>
-          </a:prstGeom>
-          <a:noFill/>
-        </p:spPr>
-        <p:txBody>
-          <a:bodyPr wrap="square" lIns="13716" rIns="13716" tIns="0" bIns="0">
-            <a:spAutoFit/>
-          </a:bodyPr>
-          <a:lstStyle/>
-          <a:p>
-            <a:pPr>
-              <a:spcBef>
-                <a:spcPts val="0"/>
-              </a:spcBef>
-              <a:spcAft>
-                <a:spcPts val="500"/>
-              </a:spcAft>
-              <a:defRPr sz="1500" b="0">
-                <a:solidFill>
-                  <a:srgbClr val="092A20"/>
-                </a:solidFill>
-                <a:latin typeface="Arial"/>
-              </a:defRPr>
-            </a:pPr>
-            <a:r>
-              <a:t>H  SOP / CRM</a:t>
-            </a:r>
-          </a:p>
-        </p:txBody>
-      </p:sp>
-      <p:sp>
-        <p:nvSpPr>
-          <p:cNvPr id="47" name="Rounded Rectangle 46"/>
-          <p:cNvSpPr/>
-          <p:nvPr/>
-        </p:nvSpPr>
-        <p:spPr>
-          <a:xfrm>
-            <a:off x="5673436" y="3863339"/>
-            <a:ext cx="406492" cy="164592"/>
-          </a:xfrm>
-          <a:prstGeom prst="roundRect">
-            <a:avLst>
-              <a:gd name="adj" fmla="val 8000"/>
-            </a:avLst>
-          </a:prstGeom>
-          <a:solidFill>
-            <a:srgbClr val="91B663"/>
-          </a:solidFill>
-          <a:ln>
-            <a:noFill/>
-          </a:ln>
-        </p:spPr>
-        <p:style>
-          <a:lnRef idx="1">
-            <a:schemeClr val="accent1"/>
-          </a:lnRef>
-          <a:fillRef idx="3">
-            <a:schemeClr val="accent1"/>
-          </a:fillRef>
-          <a:effectRef idx="2">
-            <a:schemeClr val="accent1"/>
-          </a:effectRef>
-          <a:fontRef idx="minor">
-            <a:schemeClr val="lt1"/>
-          </a:fontRef>
-        </p:style>
-        <p:txBody>
-          <a:bodyPr rtlCol="0" anchor="ctr"/>
-          <a:lstStyle/>
-          <a:p>
-            <a:pPr algn="ctr"/>
-          </a:p>
-        </p:txBody>
-      </p:sp>
-      <p:sp>
-        <p:nvSpPr>
-          <p:cNvPr id="48" name="TextBox 47"/>
-          <p:cNvSpPr txBox="1"/>
-          <p:nvPr/>
-        </p:nvSpPr>
-        <p:spPr>
-          <a:xfrm>
-            <a:off x="640080" y="4087368"/>
-            <a:ext cx="3017520" cy="265176"/>
-          </a:xfrm>
-          <a:prstGeom prst="rect">
-            <a:avLst/>
-          </a:prstGeom>
-          <a:noFill/>
-        </p:spPr>
-        <p:txBody>
-          <a:bodyPr wrap="square" lIns="13716" rIns="13716" tIns="0" bIns="0">
-            <a:spAutoFit/>
-          </a:bodyPr>
-          <a:lstStyle/>
-          <a:p>
-            <a:pPr>
-              <a:spcBef>
-                <a:spcPts val="0"/>
-              </a:spcBef>
-              <a:spcAft>
-                <a:spcPts val="500"/>
-              </a:spcAft>
-              <a:defRPr sz="1500" b="0">
-                <a:solidFill>
-                  <a:srgbClr val="092A20"/>
-                </a:solidFill>
-                <a:latin typeface="Arial"/>
-              </a:defRPr>
-            </a:pPr>
-            <a:r>
-              <a:t>I  Испытания</a:t>
-            </a:r>
-          </a:p>
-        </p:txBody>
-      </p:sp>
-      <p:sp>
-        <p:nvSpPr>
-          <p:cNvPr id="49" name="Rounded Rectangle 48"/>
-          <p:cNvSpPr/>
-          <p:nvPr/>
-        </p:nvSpPr>
-        <p:spPr>
-          <a:xfrm>
-            <a:off x="6350923" y="4128515"/>
-            <a:ext cx="270994" cy="164592"/>
-          </a:xfrm>
-          <a:prstGeom prst="roundRect">
-            <a:avLst>
-              <a:gd name="adj" fmla="val 8000"/>
-            </a:avLst>
-          </a:prstGeom>
-          <a:solidFill>
-            <a:srgbClr val="164C38"/>
-          </a:solidFill>
-          <a:ln>
-            <a:noFill/>
-          </a:ln>
-        </p:spPr>
-        <p:style>
-          <a:lnRef idx="1">
-            <a:schemeClr val="accent1"/>
-          </a:lnRef>
-          <a:fillRef idx="3">
-            <a:schemeClr val="accent1"/>
-          </a:fillRef>
-          <a:effectRef idx="2">
-            <a:schemeClr val="accent1"/>
-          </a:effectRef>
-          <a:fontRef idx="minor">
-            <a:schemeClr val="lt1"/>
-          </a:fontRef>
-        </p:style>
-        <p:txBody>
-          <a:bodyPr rtlCol="0" anchor="ctr"/>
-          <a:lstStyle/>
-          <a:p>
-            <a:pPr algn="ctr"/>
-          </a:p>
-        </p:txBody>
-      </p:sp>
-      <p:sp>
-        <p:nvSpPr>
-          <p:cNvPr id="50" name="TextBox 49"/>
-          <p:cNvSpPr txBox="1"/>
-          <p:nvPr/>
-        </p:nvSpPr>
-        <p:spPr>
-          <a:xfrm>
-            <a:off x="640080" y="4352544"/>
-            <a:ext cx="3017520" cy="265176"/>
-          </a:xfrm>
-          <a:prstGeom prst="rect">
-            <a:avLst/>
-          </a:prstGeom>
-          <a:noFill/>
-        </p:spPr>
-        <p:txBody>
-          <a:bodyPr wrap="square" lIns="13716" rIns="13716" tIns="0" bIns="0">
-            <a:spAutoFit/>
-          </a:bodyPr>
-          <a:lstStyle/>
-          <a:p>
-            <a:pPr>
-              <a:spcBef>
-                <a:spcPts val="0"/>
-              </a:spcBef>
-              <a:spcAft>
-                <a:spcPts val="500"/>
-              </a:spcAft>
-              <a:defRPr sz="1500" b="0">
-                <a:solidFill>
-                  <a:srgbClr val="092A20"/>
-                </a:solidFill>
-                <a:latin typeface="Arial"/>
-              </a:defRPr>
-            </a:pPr>
-            <a:r>
-              <a:t>J  Договоры сезона</a:t>
-            </a:r>
-          </a:p>
-        </p:txBody>
-      </p:sp>
-      <p:sp>
-        <p:nvSpPr>
-          <p:cNvPr id="51" name="Rounded Rectangle 50"/>
-          <p:cNvSpPr/>
-          <p:nvPr/>
-        </p:nvSpPr>
-        <p:spPr>
-          <a:xfrm>
-            <a:off x="6621918" y="4393692"/>
-            <a:ext cx="270994" cy="164592"/>
-          </a:xfrm>
-          <a:prstGeom prst="roundRect">
-            <a:avLst>
-              <a:gd name="adj" fmla="val 8000"/>
-            </a:avLst>
-          </a:prstGeom>
-          <a:solidFill>
-            <a:srgbClr val="164C38"/>
-          </a:solidFill>
-          <a:ln>
-            <a:noFill/>
-          </a:ln>
-        </p:spPr>
-        <p:style>
-          <a:lnRef idx="1">
-            <a:schemeClr val="accent1"/>
-          </a:lnRef>
-          <a:fillRef idx="3">
-            <a:schemeClr val="accent1"/>
-          </a:fillRef>
-          <a:effectRef idx="2">
-            <a:schemeClr val="accent1"/>
-          </a:effectRef>
-          <a:fontRef idx="minor">
-            <a:schemeClr val="lt1"/>
-          </a:fontRef>
-        </p:style>
-        <p:txBody>
-          <a:bodyPr rtlCol="0" anchor="ctr"/>
-          <a:lstStyle/>
-          <a:p>
-            <a:pPr algn="ctr"/>
-          </a:p>
-        </p:txBody>
-      </p:sp>
-      <p:sp>
-        <p:nvSpPr>
-          <p:cNvPr id="52" name="TextBox 51"/>
-          <p:cNvSpPr txBox="1"/>
-          <p:nvPr/>
-        </p:nvSpPr>
-        <p:spPr>
-          <a:xfrm>
-            <a:off x="640080" y="4617720"/>
-            <a:ext cx="3017520" cy="265176"/>
-          </a:xfrm>
-          <a:prstGeom prst="rect">
-            <a:avLst/>
-          </a:prstGeom>
-          <a:noFill/>
-        </p:spPr>
-        <p:txBody>
-          <a:bodyPr wrap="square" lIns="13716" rIns="13716" tIns="0" bIns="0">
-            <a:spAutoFit/>
-          </a:bodyPr>
-          <a:lstStyle/>
-          <a:p>
-            <a:pPr>
-              <a:spcBef>
-                <a:spcPts val="0"/>
-              </a:spcBef>
-              <a:spcAft>
-                <a:spcPts val="500"/>
-              </a:spcAft>
-              <a:defRPr sz="1500" b="0">
-                <a:solidFill>
-                  <a:srgbClr val="092A20"/>
-                </a:solidFill>
-                <a:latin typeface="Arial"/>
-              </a:defRPr>
-            </a:pPr>
-            <a:r>
-              <a:t>M  Ожидание окна</a:t>
-            </a:r>
-          </a:p>
-        </p:txBody>
-      </p:sp>
-      <p:sp>
-        <p:nvSpPr>
-          <p:cNvPr id="53" name="Rounded Rectangle 52"/>
-          <p:cNvSpPr/>
-          <p:nvPr/>
-        </p:nvSpPr>
-        <p:spPr>
-          <a:xfrm>
-            <a:off x="6892913" y="4658868"/>
-            <a:ext cx="1083979" cy="164592"/>
-          </a:xfrm>
-          <a:prstGeom prst="roundRect">
-            <a:avLst>
-              <a:gd name="adj" fmla="val 8000"/>
-            </a:avLst>
-          </a:prstGeom>
-          <a:solidFill>
-            <a:srgbClr val="164C38"/>
-          </a:solidFill>
-          <a:ln>
-            <a:noFill/>
-          </a:ln>
-        </p:spPr>
-        <p:style>
-          <a:lnRef idx="1">
-            <a:schemeClr val="accent1"/>
-          </a:lnRef>
-          <a:fillRef idx="3">
-            <a:schemeClr val="accent1"/>
-          </a:fillRef>
-          <a:effectRef idx="2">
-            <a:schemeClr val="accent1"/>
-          </a:effectRef>
-          <a:fontRef idx="minor">
-            <a:schemeClr val="lt1"/>
-          </a:fontRef>
-        </p:style>
-        <p:txBody>
-          <a:bodyPr rtlCol="0" anchor="ctr"/>
-          <a:lstStyle/>
-          <a:p>
-            <a:pPr algn="ctr"/>
-          </a:p>
-        </p:txBody>
-      </p:sp>
-      <p:sp>
-        <p:nvSpPr>
-          <p:cNvPr id="54" name="TextBox 53"/>
-          <p:cNvSpPr txBox="1"/>
-          <p:nvPr/>
-        </p:nvSpPr>
-        <p:spPr>
-          <a:xfrm>
-            <a:off x="640080" y="4882896"/>
-            <a:ext cx="3017520" cy="265176"/>
-          </a:xfrm>
-          <a:prstGeom prst="rect">
-            <a:avLst/>
-          </a:prstGeom>
-          <a:noFill/>
-        </p:spPr>
-        <p:txBody>
-          <a:bodyPr wrap="square" lIns="13716" rIns="13716" tIns="0" bIns="0">
-            <a:spAutoFit/>
-          </a:bodyPr>
-          <a:lstStyle/>
-          <a:p>
-            <a:pPr>
-              <a:spcBef>
-                <a:spcPts val="0"/>
-              </a:spcBef>
-              <a:spcAft>
-                <a:spcPts val="500"/>
-              </a:spcAft>
-              <a:defRPr sz="1500" b="0">
-                <a:solidFill>
-                  <a:srgbClr val="092A20"/>
-                </a:solidFill>
-                <a:latin typeface="Arial"/>
-              </a:defRPr>
-            </a:pPr>
-            <a:r>
-              <a:t>K  Сезон</a:t>
-            </a:r>
-          </a:p>
-        </p:txBody>
-      </p:sp>
-      <p:sp>
-        <p:nvSpPr>
-          <p:cNvPr id="55" name="Rounded Rectangle 54"/>
-          <p:cNvSpPr/>
-          <p:nvPr/>
-        </p:nvSpPr>
-        <p:spPr>
-          <a:xfrm>
-            <a:off x="7976893" y="4924044"/>
-            <a:ext cx="2980944" cy="164592"/>
-          </a:xfrm>
-          <a:prstGeom prst="roundRect">
-            <a:avLst>
-              <a:gd name="adj" fmla="val 8000"/>
-            </a:avLst>
-          </a:prstGeom>
-          <a:solidFill>
-            <a:srgbClr val="164C38"/>
-          </a:solidFill>
-          <a:ln>
-            <a:noFill/>
-          </a:ln>
-        </p:spPr>
-        <p:style>
-          <a:lnRef idx="1">
-            <a:schemeClr val="accent1"/>
-          </a:lnRef>
-          <a:fillRef idx="3">
-            <a:schemeClr val="accent1"/>
-          </a:fillRef>
-          <a:effectRef idx="2">
-            <a:schemeClr val="accent1"/>
-          </a:effectRef>
-          <a:fontRef idx="minor">
-            <a:schemeClr val="lt1"/>
-          </a:fontRef>
-        </p:style>
-        <p:txBody>
-          <a:bodyPr rtlCol="0" anchor="ctr"/>
-          <a:lstStyle/>
-          <a:p>
-            <a:pPr algn="ctr"/>
-          </a:p>
-        </p:txBody>
-      </p:sp>
-      <p:sp>
-        <p:nvSpPr>
-          <p:cNvPr id="56" name="TextBox 55"/>
-          <p:cNvSpPr txBox="1"/>
-          <p:nvPr/>
-        </p:nvSpPr>
-        <p:spPr>
-          <a:xfrm>
-            <a:off x="640080" y="5148071"/>
-            <a:ext cx="3017520" cy="265176"/>
-          </a:xfrm>
-          <a:prstGeom prst="rect">
-            <a:avLst/>
-          </a:prstGeom>
-          <a:noFill/>
-        </p:spPr>
-        <p:txBody>
-          <a:bodyPr wrap="square" lIns="13716" rIns="13716" tIns="0" bIns="0">
-            <a:spAutoFit/>
-          </a:bodyPr>
-          <a:lstStyle/>
-          <a:p>
-            <a:pPr>
-              <a:spcBef>
-                <a:spcPts val="0"/>
-              </a:spcBef>
-              <a:spcAft>
-                <a:spcPts val="500"/>
-              </a:spcAft>
-              <a:defRPr sz="1500" b="0">
-                <a:solidFill>
-                  <a:srgbClr val="092A20"/>
-                </a:solidFill>
-                <a:latin typeface="Arial"/>
-              </a:defRPr>
-            </a:pPr>
-            <a:r>
-              <a:t>L  Аудит</a:t>
-            </a:r>
-          </a:p>
-        </p:txBody>
-      </p:sp>
-      <p:sp>
-        <p:nvSpPr>
-          <p:cNvPr id="57" name="Rounded Rectangle 56"/>
-          <p:cNvSpPr/>
-          <p:nvPr/>
-        </p:nvSpPr>
-        <p:spPr>
-          <a:xfrm>
-            <a:off x="10957837" y="5189219"/>
-            <a:ext cx="270994" cy="164592"/>
-          </a:xfrm>
-          <a:prstGeom prst="roundRect">
-            <a:avLst>
-              <a:gd name="adj" fmla="val 8000"/>
-            </a:avLst>
-          </a:prstGeom>
-          <a:solidFill>
-            <a:srgbClr val="164C38"/>
-          </a:solidFill>
-          <a:ln>
-            <a:noFill/>
-          </a:ln>
-        </p:spPr>
-        <p:style>
-          <a:lnRef idx="1">
-            <a:schemeClr val="accent1"/>
-          </a:lnRef>
-          <a:fillRef idx="3">
-            <a:schemeClr val="accent1"/>
-          </a:fillRef>
-          <a:effectRef idx="2">
-            <a:schemeClr val="accent1"/>
-          </a:effectRef>
-          <a:fontRef idx="minor">
-            <a:schemeClr val="lt1"/>
-          </a:fontRef>
-        </p:style>
-        <p:txBody>
-          <a:bodyPr rtlCol="0" anchor="ctr"/>
-          <a:lstStyle/>
-          <a:p>
-            <a:pPr algn="ctr"/>
-          </a:p>
-        </p:txBody>
-      </p:sp>
-      <p:sp>
-        <p:nvSpPr>
-          <p:cNvPr id="58" name="TextBox 57"/>
-          <p:cNvSpPr txBox="1"/>
-          <p:nvPr/>
-        </p:nvSpPr>
-        <p:spPr>
-          <a:xfrm>
-            <a:off x="640080" y="5522976"/>
-            <a:ext cx="10698480" cy="301752"/>
-          </a:xfrm>
-          <a:prstGeom prst="rect">
-            <a:avLst/>
-          </a:prstGeom>
-          <a:noFill/>
-        </p:spPr>
-        <p:txBody>
-          <a:bodyPr wrap="square" lIns="13716" rIns="13716" tIns="0" bIns="0">
-            <a:spAutoFit/>
-          </a:bodyPr>
-          <a:lstStyle/>
-          <a:p>
-            <a:pPr>
-              <a:spcBef>
-                <a:spcPts val="0"/>
-              </a:spcBef>
-              <a:spcAft>
-                <a:spcPts val="500"/>
-              </a:spcAft>
-              <a:defRPr sz="1500" b="0">
-                <a:solidFill>
-                  <a:srgbClr val="164C38"/>
-                </a:solidFill>
-                <a:latin typeface="Arial"/>
-              </a:defRPr>
-            </a:pPr>
-            <a:r>
-              <a:t>Недели от 2026-09-07  •  Конец 2027-09-26  •  Темный = критический путь</a:t>
-            </a:r>
-          </a:p>
-        </p:txBody>
-      </p:sp>
-      <p:sp>
-        <p:nvSpPr>
-          <p:cNvPr id="59" name="TextBox 58"/>
+              <a:t>Недели от 2026-10-19  •  Конец 2027-09-26  •  Темный = критический путь</a:t>
+            </a:r>
+          </a:p>
+        </p:txBody>
+      </p:sp>
+      <p:sp>
+        <p:nvSpPr>
+          <p:cNvPr id="55" name="TextBox 54"/>
           <p:cNvSpPr txBox="1"/>
           <p:nvPr/>
         </p:nvSpPr>
@@ -15609,7 +15374,7 @@
               </a:defRPr>
             </a:pPr>
             <a:r>
-              <a:t>Сезон K: 2027-04-12 — 2027-09-12; пакет M: 8 недель ожидания окна.</a:t>
+              <a:t>Сезон K: 2027-04-12 — 2027-09-12; пакет M: 3 недель ожидания окна.</a:t>
             </a:r>
           </a:p>
         </p:txBody>
@@ -15867,7 +15632,7 @@
           </a:prstGeom>
           <a:ln w="21590">
             <a:solidFill>
-              <a:srgbClr val="C8F26B"/>
+              <a:srgbClr val="AFC5B8"/>
             </a:solidFill>
             <a:tailEnd type="triangle"/>
           </a:ln>
@@ -15903,7 +15668,7 @@
           </a:prstGeom>
           <a:ln w="21590">
             <a:solidFill>
-              <a:srgbClr val="AFC5B8"/>
+              <a:srgbClr val="C8F26B"/>
             </a:solidFill>
             <a:tailEnd type="triangle"/>
           </a:ln>
@@ -15939,7 +15704,7 @@
           </a:prstGeom>
           <a:ln w="21590">
             <a:solidFill>
-              <a:srgbClr val="C8F26B"/>
+              <a:srgbClr val="AFC5B8"/>
             </a:solidFill>
             <a:tailEnd type="triangle"/>
           </a:ln>
@@ -16372,7 +16137,7 @@
             </a:avLst>
           </a:prstGeom>
           <a:solidFill>
-            <a:srgbClr val="C8F26B"/>
+            <a:srgbClr val="FFFFFF"/>
           </a:solidFill>
           <a:ln>
             <a:noFill/>
@@ -16479,7 +16244,7 @@
               </a:defRPr>
             </a:pPr>
             <a:r>
-              <a:t>4 нед.</a:t>
+              <a:t>2 нед.</a:t>
             </a:r>
           </a:p>
         </p:txBody>
@@ -16501,7 +16266,7 @@
             </a:avLst>
           </a:prstGeom>
           <a:solidFill>
-            <a:srgbClr val="FFFFFF"/>
+            <a:srgbClr val="C8F26B"/>
           </a:solidFill>
           <a:ln>
             <a:noFill/>
@@ -16608,7 +16373,7 @@
               </a:defRPr>
             </a:pPr>
             <a:r>
-              <a:t>5 нед.</a:t>
+              <a:t>6 нед.</a:t>
             </a:r>
           </a:p>
         </p:txBody>
@@ -16630,7 +16395,7 @@
             </a:avLst>
           </a:prstGeom>
           <a:solidFill>
-            <a:srgbClr val="C8F26B"/>
+            <a:srgbClr val="FFFFFF"/>
           </a:solidFill>
           <a:ln>
             <a:noFill/>
@@ -17769,7 +17534,7 @@
               </a:defRPr>
             </a:pPr>
             <a:r>
-              <a:t>8 нед.</a:t>
+              <a:t>3 нед.</a:t>
             </a:r>
           </a:p>
         </p:txBody>
@@ -18069,7 +17834,7 @@
               </a:defRPr>
             </a:pPr>
             <a:r>
-              <a:t>Критический путь: A → C → D → E → G → I → J → M → K → L</a:t>
+              <a:t>Критический путь: B → D → E → G → I → J → M → K → L</a:t>
             </a:r>
           </a:p>
         </p:txBody>
@@ -18156,7 +17921,7 @@
               </a:defRPr>
             </a:pPr>
             <a:r>
-              <a:t>55 недель от проверки до аудита; M — явная работа ожидания, не свободный резерв</a:t>
+              <a:t>49 недель от проверки до аудита; M — явная работа ожидания, не свободный резерв</a:t>
             </a:r>
           </a:p>
         </p:txBody>
@@ -23967,7 +23732,7 @@
                         </a:defRPr>
                       </a:pPr>
                       <a:r>
-                        <a:t>31.10.2026</a:t>
+                        <a:t>01.11.2026</a:t>
                       </a:r>
                     </a:p>
                   </a:txBody>
@@ -24050,7 +23815,7 @@
                         </a:defRPr>
                       </a:pPr>
                       <a:r>
-                        <a:t>30.11.2026</a:t>
+                        <a:t>29.11.2026</a:t>
                       </a:r>
                     </a:p>
                   </a:txBody>
@@ -24133,7 +23898,7 @@
                         </a:defRPr>
                       </a:pPr>
                       <a:r>
-                        <a:t>11.04.2027</a:t>
+                        <a:t>21.03.2027</a:t>
                       </a:r>
                     </a:p>
                   </a:txBody>
@@ -25285,7 +25050,7 @@
               <a:spcAft>
                 <a:spcPts val="500"/>
               </a:spcAft>
-              <a:defRPr sz="1800" b="0">
+              <a:defRPr sz="1600" b="0">
                 <a:solidFill>
                   <a:srgbClr val="FFFFFF"/>
                 </a:solidFill>
@@ -25293,7 +25058,7 @@
               </a:defRPr>
             </a:pPr>
             <a:r>
-              <a:t>Долг и гранты не включены. Деньги пока не подтверждены.</a:t>
+              <a:t>База: 2,5 + 7,0 = 9,5 млн ₽; деньги не подтверждены.</a:t>
             </a:r>
           </a:p>
           <a:p>
@@ -25304,7 +25069,7 @@
               <a:spcAft>
                 <a:spcPts val="500"/>
               </a:spcAft>
-              <a:defRPr sz="1800" b="0">
+              <a:defRPr sz="1600" b="0">
                 <a:solidFill>
                   <a:srgbClr val="FFFFFF"/>
                 </a:solidFill>
@@ -25312,7 +25077,26 @@
               </a:defRPr>
             </a:pPr>
             <a:r>
-              <a:t>Оценка бизнеса, корпоративные права, выход и доля инвестора — предмет соглашения.</a:t>
+              <a:t>Закупочный стресс: внешний вклад 8,98 млн ₽; нужно еще 1,98 млн ₽.</a:t>
+            </a:r>
+          </a:p>
+          <a:p>
+            <a:pPr>
+              <a:spcBef>
+                <a:spcPts val="0"/>
+              </a:spcBef>
+              <a:spcAft>
+                <a:spcPts val="500"/>
+              </a:spcAft>
+              <a:defRPr sz="1600" b="0">
+                <a:solidFill>
+                  <a:srgbClr val="FFFFFF"/>
+                </a:solidFill>
+                <a:latin typeface="Arial"/>
+              </a:defRPr>
+            </a:pPr>
+            <a:r>
+              <a:t>Долг и гранты исключены; доля инвестора определяется отдельно.</a:t>
             </a:r>
           </a:p>
         </p:txBody>
@@ -27922,59 +27706,17 @@
           </a:p>
         </p:txBody>
       </p:sp>
-      <p:sp>
-        <p:nvSpPr>
-          <p:cNvPr id="7" name="TextBox 6"/>
-          <p:cNvSpPr txBox="1"/>
-          <p:nvPr/>
-        </p:nvSpPr>
-        <p:spPr>
-          <a:xfrm>
-            <a:off x="594360" y="1664208"/>
-            <a:ext cx="10972800" cy="457200"/>
-          </a:xfrm>
-          <a:prstGeom prst="rect">
-            <a:avLst/>
-          </a:prstGeom>
-          <a:noFill/>
-        </p:spPr>
-        <p:txBody>
-          <a:bodyPr wrap="square" lIns="13716" rIns="13716" tIns="0" bIns="0">
-            <a:spAutoFit/>
-          </a:bodyPr>
-          <a:lstStyle/>
-          <a:p>
-            <a:pPr>
-              <a:spcBef>
-                <a:spcPts val="0"/>
-              </a:spcBef>
-              <a:spcAft>
-                <a:spcPts val="500"/>
-              </a:spcAft>
-              <a:defRPr sz="2300" b="1">
-                <a:solidFill>
-                  <a:srgbClr val="FFFFFF"/>
-                </a:solidFill>
-                <a:latin typeface="Arial"/>
-              </a:defRPr>
-            </a:pPr>
-            <a:r>
-              <a:t>Обследование, карта задания, внесение, отчет</a:t>
-            </a:r>
-          </a:p>
-        </p:txBody>
-      </p:sp>
       <p:graphicFrame>
         <p:nvGraphicFramePr>
-          <p:cNvPr id="8" name="Table 7"/>
+          <p:cNvPr id="7" name="Table 6"/>
           <p:cNvGraphicFramePr>
             <a:graphicFrameLocks noGrp="1"/>
           </p:cNvGraphicFramePr>
           <p:nvPr/>
         </p:nvGraphicFramePr>
         <p:xfrm>
-          <a:off x="502920" y="2194560"/>
-          <a:ext cx="11183112" cy="3246120"/>
+          <a:off x="502920" y="1737360"/>
+          <a:ext cx="11183112" cy="4023360"/>
         </p:xfrm>
         <a:graphic>
           <a:graphicData uri="http://schemas.openxmlformats.org/drawingml/2006/table">
@@ -27989,7 +27731,7 @@
                 <a:gridCol w="2276856"/>
                 <a:gridCol w="2267712"/>
               </a:tblGrid>
-              <a:tr h="541020">
+              <a:tr h="502920">
                 <a:tc>
                   <a:txBody>
                     <a:bodyPr/>
@@ -28126,7 +27868,7 @@
                   </a:tcPr>
                 </a:tc>
               </a:tr>
-              <a:tr h="541020">
+              <a:tr h="502920">
                 <a:tc>
                   <a:txBody>
                     <a:bodyPr/>
@@ -28144,7 +27886,7 @@
                         </a:defRPr>
                       </a:pPr>
                       <a:r>
-                        <a:t>Цена внесения, руб./га</a:t>
+                        <a:t>Внесение как услуга</a:t>
                       </a:r>
                     </a:p>
                   </a:txBody>
@@ -28171,7 +27913,7 @@
                         </a:defRPr>
                       </a:pPr>
                       <a:r>
-                        <a:t>1 300 без НДС</a:t>
+                        <a:t>Планируется</a:t>
                       </a:r>
                     </a:p>
                   </a:txBody>
@@ -28198,7 +27940,7 @@
                         </a:defRPr>
                       </a:pPr>
                       <a:r>
-                        <a:t>По запросу</a:t>
+                        <a:t>Предлагается [3][4]</a:t>
                       </a:r>
                     </a:p>
                   </a:txBody>
@@ -28225,7 +27967,7 @@
                         </a:defRPr>
                       </a:pPr>
                       <a:r>
-                        <a:t>900, средняя; состав уточняется</a:t>
+                        <a:t>Предлагается [7]</a:t>
                       </a:r>
                     </a:p>
                   </a:txBody>
@@ -28252,7 +27994,7 @@
                         </a:defRPr>
                       </a:pPr>
                       <a:r>
-                        <a:t>По запросу</a:t>
+                        <a:t>Предлагается [6]</a:t>
                       </a:r>
                     </a:p>
                   </a:txBody>
@@ -28263,7 +28005,7 @@
                   </a:tcPr>
                 </a:tc>
               </a:tr>
-              <a:tr h="541020">
+              <a:tr h="502920">
                 <a:tc>
                   <a:txBody>
                     <a:bodyPr/>
@@ -28281,7 +28023,7 @@
                         </a:defRPr>
                       </a:pPr>
                       <a:r>
-                        <a:t>Мониторинг + внесение</a:t>
+                        <a:t>Цена внесения, руб./га</a:t>
                       </a:r>
                     </a:p>
                   </a:txBody>
@@ -28308,7 +28050,7 @@
                         </a:defRPr>
                       </a:pPr>
                       <a:r>
-                        <a:t>Один договор, план</a:t>
+                        <a:t>1 300 без НДС</a:t>
                       </a:r>
                     </a:p>
                   </a:txBody>
@@ -28335,7 +28077,7 @@
                         </a:defRPr>
                       </a:pPr>
                       <a:r>
-                        <a:t>Состав пакета уточняется</a:t>
+                        <a:t>По запросу</a:t>
                       </a:r>
                     </a:p>
                   </a:txBody>
@@ -28362,7 +28104,7 @@
                         </a:defRPr>
                       </a:pPr>
                       <a:r>
-                        <a:t>Мониторинг не подтвержден</a:t>
+                        <a:t>900, средняя; состав уточняется</a:t>
                       </a:r>
                     </a:p>
                   </a:txBody>
@@ -28389,7 +28131,7 @@
                         </a:defRPr>
                       </a:pPr>
                       <a:r>
-                        <a:t>Оба направления заявлены</a:t>
+                        <a:t>По запросу</a:t>
                       </a:r>
                     </a:p>
                   </a:txBody>
@@ -28400,7 +28142,7 @@
                   </a:tcPr>
                 </a:tc>
               </a:tr>
-              <a:tr h="541020">
+              <a:tr h="502920">
                 <a:tc>
                   <a:txBody>
                     <a:bodyPr/>
@@ -28418,7 +28160,7 @@
                         </a:defRPr>
                       </a:pPr>
                       <a:r>
-                        <a:t>Локальная доступность</a:t>
+                        <a:t>Мониторинг + внесение</a:t>
                       </a:r>
                     </a:p>
                   </a:txBody>
@@ -28445,7 +28187,7 @@
                         </a:defRPr>
                       </a:pPr>
                       <a:r>
-                        <a:t>Татарстан, до 150 км; условно</a:t>
+                        <a:t>Один договор, план</a:t>
                       </a:r>
                     </a:p>
                   </a:txBody>
@@ -28472,7 +28214,7 @@
                         </a:defRPr>
                       </a:pPr>
                       <a:r>
-                        <a:t>Татарстан заявлен</a:t>
+                        <a:t>Состав пакета уточняется</a:t>
                       </a:r>
                     </a:p>
                   </a:txBody>
@@ -28499,7 +28241,7 @@
                         </a:defRPr>
                       </a:pPr>
                       <a:r>
-                        <a:t>ЮФО</a:t>
+                        <a:t>Мониторинг не подтвержден</a:t>
                       </a:r>
                     </a:p>
                   </a:txBody>
@@ -28526,7 +28268,7 @@
                         </a:defRPr>
                       </a:pPr>
                       <a:r>
-                        <a:t>Краснодар / Адыгея</a:t>
+                        <a:t>Оба направления заявлены</a:t>
                       </a:r>
                     </a:p>
                   </a:txBody>
@@ -28537,7 +28279,7 @@
                   </a:tcPr>
                 </a:tc>
               </a:tr>
-              <a:tr h="541020">
+              <a:tr h="502920">
                 <a:tc>
                   <a:txBody>
                     <a:bodyPr/>
@@ -28555,7 +28297,7 @@
                         </a:defRPr>
                       </a:pPr>
                       <a:r>
-                        <a:t>Минимальный маршрут</a:t>
+                        <a:t>Локальная доступность</a:t>
                       </a:r>
                     </a:p>
                   </a:txBody>
@@ -28582,7 +28324,281 @@
                         </a:defRPr>
                       </a:pPr>
                       <a:r>
+                        <a:t>Татарстан, до 150 км; условно</a:t>
+                      </a:r>
+                    </a:p>
+                  </a:txBody>
+                  <a:tcPr marL="91440" marR="91440" marT="45720" marB="45720">
+                    <a:solidFill>
+                      <a:srgbClr val="EFF4EF"/>
+                    </a:solidFill>
+                  </a:tcPr>
+                </a:tc>
+                <a:tc>
+                  <a:txBody>
+                    <a:bodyPr/>
+                    <a:lstStyle/>
+                    <a:p>
+                      <a:pPr>
+                        <a:spcAft>
+                          <a:spcPts val="0"/>
+                        </a:spcAft>
+                        <a:defRPr sz="1500" b="0">
+                          <a:solidFill>
+                            <a:srgbClr val="092A20"/>
+                          </a:solidFill>
+                          <a:latin typeface="Arial"/>
+                        </a:defRPr>
+                      </a:pPr>
+                      <a:r>
+                        <a:t>Татарстан заявлен</a:t>
+                      </a:r>
+                    </a:p>
+                  </a:txBody>
+                  <a:tcPr marL="91440" marR="91440" marT="45720" marB="45720">
+                    <a:solidFill>
+                      <a:srgbClr val="EFF4EF"/>
+                    </a:solidFill>
+                  </a:tcPr>
+                </a:tc>
+                <a:tc>
+                  <a:txBody>
+                    <a:bodyPr/>
+                    <a:lstStyle/>
+                    <a:p>
+                      <a:pPr>
+                        <a:spcAft>
+                          <a:spcPts val="0"/>
+                        </a:spcAft>
+                        <a:defRPr sz="1500" b="0">
+                          <a:solidFill>
+                            <a:srgbClr val="092A20"/>
+                          </a:solidFill>
+                          <a:latin typeface="Arial"/>
+                        </a:defRPr>
+                      </a:pPr>
+                      <a:r>
+                        <a:t>ЮФО</a:t>
+                      </a:r>
+                    </a:p>
+                  </a:txBody>
+                  <a:tcPr marL="91440" marR="91440" marT="45720" marB="45720">
+                    <a:solidFill>
+                      <a:srgbClr val="EFF4EF"/>
+                    </a:solidFill>
+                  </a:tcPr>
+                </a:tc>
+                <a:tc>
+                  <a:txBody>
+                    <a:bodyPr/>
+                    <a:lstStyle/>
+                    <a:p>
+                      <a:pPr>
+                        <a:spcAft>
+                          <a:spcPts val="0"/>
+                        </a:spcAft>
+                        <a:defRPr sz="1500" b="0">
+                          <a:solidFill>
+                            <a:srgbClr val="092A20"/>
+                          </a:solidFill>
+                          <a:latin typeface="Arial"/>
+                        </a:defRPr>
+                      </a:pPr>
+                      <a:r>
+                        <a:t>Краснодар / Адыгея</a:t>
+                      </a:r>
+                    </a:p>
+                  </a:txBody>
+                  <a:tcPr marL="91440" marR="91440" marT="45720" marB="45720">
+                    <a:solidFill>
+                      <a:srgbClr val="EFF4EF"/>
+                    </a:solidFill>
+                  </a:tcPr>
+                </a:tc>
+              </a:tr>
+              <a:tr h="502920">
+                <a:tc>
+                  <a:txBody>
+                    <a:bodyPr/>
+                    <a:lstStyle/>
+                    <a:p>
+                      <a:pPr>
+                        <a:spcAft>
+                          <a:spcPts val="0"/>
+                        </a:spcAft>
+                        <a:defRPr sz="1500" b="0">
+                          <a:solidFill>
+                            <a:srgbClr val="092A20"/>
+                          </a:solidFill>
+                          <a:latin typeface="Arial"/>
+                        </a:defRPr>
+                      </a:pPr>
+                      <a:r>
+                        <a:t>Минимальный маршрут</a:t>
+                      </a:r>
+                    </a:p>
+                  </a:txBody>
+                  <a:tcPr marL="91440" marR="91440" marT="45720" marB="45720">
+                    <a:solidFill>
+                      <a:srgbClr val="FFFFFF"/>
+                    </a:solidFill>
+                  </a:tcPr>
+                </a:tc>
+                <a:tc>
+                  <a:txBody>
+                    <a:bodyPr/>
+                    <a:lstStyle/>
+                    <a:p>
+                      <a:pPr>
+                        <a:spcAft>
+                          <a:spcPts val="0"/>
+                        </a:spcAft>
+                        <a:defRPr sz="1500" b="0">
+                          <a:solidFill>
+                            <a:srgbClr val="092A20"/>
+                          </a:solidFill>
+                          <a:latin typeface="Arial"/>
+                        </a:defRPr>
+                      </a:pPr>
+                      <a:r>
                         <a:t>100 га-проходов, план</a:t>
+                      </a:r>
+                    </a:p>
+                  </a:txBody>
+                  <a:tcPr marL="91440" marR="91440" marT="45720" marB="45720">
+                    <a:solidFill>
+                      <a:srgbClr val="FFFFFF"/>
+                    </a:solidFill>
+                  </a:tcPr>
+                </a:tc>
+                <a:tc>
+                  <a:txBody>
+                    <a:bodyPr/>
+                    <a:lstStyle/>
+                    <a:p>
+                      <a:pPr>
+                        <a:spcAft>
+                          <a:spcPts val="0"/>
+                        </a:spcAft>
+                        <a:defRPr sz="1500" b="0">
+                          <a:solidFill>
+                            <a:srgbClr val="092A20"/>
+                          </a:solidFill>
+                          <a:latin typeface="Arial"/>
+                        </a:defRPr>
+                      </a:pPr>
+                      <a:r>
+                        <a:t>Не раскрыт</a:t>
+                      </a:r>
+                    </a:p>
+                  </a:txBody>
+                  <a:tcPr marL="91440" marR="91440" marT="45720" marB="45720">
+                    <a:solidFill>
+                      <a:srgbClr val="FFFFFF"/>
+                    </a:solidFill>
+                  </a:tcPr>
+                </a:tc>
+                <a:tc>
+                  <a:txBody>
+                    <a:bodyPr/>
+                    <a:lstStyle/>
+                    <a:p>
+                      <a:pPr>
+                        <a:spcAft>
+                          <a:spcPts val="0"/>
+                        </a:spcAft>
+                        <a:defRPr sz="1500" b="0">
+                          <a:solidFill>
+                            <a:srgbClr val="092A20"/>
+                          </a:solidFill>
+                          <a:latin typeface="Arial"/>
+                        </a:defRPr>
+                      </a:pPr>
+                      <a:r>
+                        <a:t>Не раскрыт</a:t>
+                      </a:r>
+                    </a:p>
+                  </a:txBody>
+                  <a:tcPr marL="91440" marR="91440" marT="45720" marB="45720">
+                    <a:solidFill>
+                      <a:srgbClr val="FFFFFF"/>
+                    </a:solidFill>
+                  </a:tcPr>
+                </a:tc>
+                <a:tc>
+                  <a:txBody>
+                    <a:bodyPr/>
+                    <a:lstStyle/>
+                    <a:p>
+                      <a:pPr>
+                        <a:spcAft>
+                          <a:spcPts val="0"/>
+                        </a:spcAft>
+                        <a:defRPr sz="1500" b="0">
+                          <a:solidFill>
+                            <a:srgbClr val="092A20"/>
+                          </a:solidFill>
+                          <a:latin typeface="Arial"/>
+                        </a:defRPr>
+                      </a:pPr>
+                      <a:r>
+                        <a:t>Не раскрыт</a:t>
+                      </a:r>
+                    </a:p>
+                  </a:txBody>
+                  <a:tcPr marL="91440" marR="91440" marT="45720" marB="45720">
+                    <a:solidFill>
+                      <a:srgbClr val="FFFFFF"/>
+                    </a:solidFill>
+                  </a:tcPr>
+                </a:tc>
+              </a:tr>
+              <a:tr h="502920">
+                <a:tc>
+                  <a:txBody>
+                    <a:bodyPr/>
+                    <a:lstStyle/>
+                    <a:p>
+                      <a:pPr>
+                        <a:spcAft>
+                          <a:spcPts val="0"/>
+                        </a:spcAft>
+                        <a:defRPr sz="1500" b="0">
+                          <a:solidFill>
+                            <a:srgbClr val="092A20"/>
+                          </a:solidFill>
+                          <a:latin typeface="Arial"/>
+                        </a:defRPr>
+                      </a:pPr>
+                      <a:r>
+                        <a:t>Срок отчета</a:t>
+                      </a:r>
+                    </a:p>
+                  </a:txBody>
+                  <a:tcPr marL="91440" marR="91440" marT="45720" marB="45720">
+                    <a:solidFill>
+                      <a:srgbClr val="EFF4EF"/>
+                    </a:solidFill>
+                  </a:tcPr>
+                </a:tc>
+                <a:tc>
+                  <a:txBody>
+                    <a:bodyPr/>
+                    <a:lstStyle/>
+                    <a:p>
+                      <a:pPr>
+                        <a:spcAft>
+                          <a:spcPts val="0"/>
+                        </a:spcAft>
+                        <a:defRPr sz="1500" b="0">
+                          <a:solidFill>
+                            <a:srgbClr val="092A20"/>
+                          </a:solidFill>
+                          <a:latin typeface="Arial"/>
+                        </a:defRPr>
+                      </a:pPr>
+                      <a:r>
+                        <a:t>Не более 48 часов, цель</a:t>
                       </a:r>
                     </a:p>
                   </a:txBody>
@@ -28636,7 +28652,7 @@
                         </a:defRPr>
                       </a:pPr>
                       <a:r>
-                        <a:t>Не раскрыт</a:t>
+                        <a:t>Акты заявлены; срок не раскрыт</a:t>
                       </a:r>
                     </a:p>
                   </a:txBody>
@@ -28674,7 +28690,7 @@
                   </a:tcPr>
                 </a:tc>
               </a:tr>
-              <a:tr h="541020">
+              <a:tr h="502920">
                 <a:tc>
                   <a:txBody>
                     <a:bodyPr/>
@@ -28692,7 +28708,7 @@
                         </a:defRPr>
                       </a:pPr>
                       <a:r>
-                        <a:t>Срок отчета</a:t>
+                        <a:t>Опыт исполнения</a:t>
                       </a:r>
                     </a:p>
                   </a:txBody>
@@ -28719,7 +28735,7 @@
                         </a:defRPr>
                       </a:pPr>
                       <a:r>
-                        <a:t>Не более 48 часов, цель</a:t>
+                        <a:t>Сезон не проведен</a:t>
                       </a:r>
                     </a:p>
                   </a:txBody>
@@ -28746,7 +28762,7 @@
                         </a:defRPr>
                       </a:pPr>
                       <a:r>
-                        <a:t>Не раскрыт</a:t>
+                        <a:t>50 тыс. га суммарно [3]</a:t>
                       </a:r>
                     </a:p>
                   </a:txBody>
@@ -28773,7 +28789,7 @@
                         </a:defRPr>
                       </a:pPr>
                       <a:r>
-                        <a:t>Акты заявлены; срок не раскрыт</a:t>
+                        <a:t>Парк заявлен [7]</a:t>
                       </a:r>
                     </a:p>
                   </a:txBody>
@@ -28800,7 +28816,7 @@
                         </a:defRPr>
                       </a:pPr>
                       <a:r>
-                        <a:t>Не раскрыт</a:t>
+                        <a:t>Кейсы опубликованы [6]</a:t>
                       </a:r>
                     </a:p>
                   </a:txBody>
@@ -28817,13 +28833,13 @@
       </p:graphicFrame>
       <p:sp>
         <p:nvSpPr>
-          <p:cNvPr id="9" name="Rounded Rectangle 8"/>
+          <p:cNvPr id="8" name="Rounded Rectangle 7"/>
           <p:cNvSpPr/>
           <p:nvPr/>
         </p:nvSpPr>
         <p:spPr>
           <a:xfrm>
-            <a:off x="502920" y="5513832"/>
+            <a:off x="502920" y="5852160"/>
             <a:ext cx="11183112" cy="448056"/>
           </a:xfrm>
           <a:prstGeom prst="roundRect">
@@ -28862,13 +28878,13 @@
       </p:sp>
       <p:sp>
         <p:nvSpPr>
-          <p:cNvPr id="10" name="TextBox 9"/>
+          <p:cNvPr id="9" name="TextBox 8"/>
           <p:cNvSpPr txBox="1"/>
           <p:nvPr/>
         </p:nvSpPr>
         <p:spPr>
           <a:xfrm>
-            <a:off x="658368" y="5596128"/>
+            <a:off x="658368" y="5934456"/>
             <a:ext cx="10881360" cy="320040"/>
           </a:xfrm>
           <a:prstGeom prst="rect">
@@ -28897,7 +28913,7 @@
               </a:defRPr>
             </a:pPr>
             <a:r>
-              <a:t>Цель проекта — не достигнутое преимущество. Нераскрытая характеристика — не недостаток</a:t>
+              <a:t>Целевой профиль проекта не означает доказанного превосходства над конкурентами</a:t>
             </a:r>
           </a:p>
         </p:txBody>

</xml_diff>

<commit_message>
feat: align AgroVector defense with teaching reference and payroll costs
Add Lean Canvas, national TAM, price benchmarks, full TOWS/Porter, Mendelow, WBS tree and role-based RACI. Recalculate payroll and contributions through all model outputs; disclose negative NPV. Render and independently recheck current Office artifacts.
</commit_message>
<xml_diff>
--- a/presentations/AGROVECTOR_22_SLIDES.pptx
+++ b/presentations/AGROVECTOR_22_SLIDES.pptx
@@ -264,19 +264,19 @@
                 <c:formatCode>General</c:formatCode>
                 <c:ptCount val="5"/>
                 <c:pt idx="0">
-                  <c:v>1.96</c:v>
+                  <c:v>0.2728</c:v>
                 </c:pt>
                 <c:pt idx="1">
-                  <c:v>5.16</c:v>
+                  <c:v>3.38844</c:v>
                 </c:pt>
                 <c:pt idx="2">
-                  <c:v>7.619380000000004</c:v>
+                  <c:v>5.759242000000004</c:v>
                 </c:pt>
                 <c:pt idx="3">
-                  <c:v>9.035079900000003</c:v>
+                  <c:v>7.081935000000001</c:v>
                 </c:pt>
                 <c:pt idx="4">
-                  <c:v>10.540193564000003</c:v>
+                  <c:v>8.489391419000002</c:v>
                 </c:pt>
               </c:numCache>
             </c:numRef>
@@ -336,19 +336,19 @@
                 <c:formatCode>General</c:formatCode>
                 <c:ptCount val="5"/>
                 <c:pt idx="0">
-                  <c:v>1.432</c:v>
+                  <c:v>-0.2552</c:v>
                 </c:pt>
                 <c:pt idx="1">
-                  <c:v>4.03632</c:v>
+                  <c:v>2.26476</c:v>
                 </c:pt>
                 <c:pt idx="2">
-                  <c:v>5.961575200000003</c:v>
+                  <c:v>4.101437200000003</c:v>
                 </c:pt>
                 <c:pt idx="3">
-                  <c:v>6.930350556000001</c:v>
+                  <c:v>4.9772056560000015</c:v>
                 </c:pt>
                 <c:pt idx="4">
-                  <c:v>10.578478200160003</c:v>
+                  <c:v>8.52767605516</c:v>
                 </c:pt>
               </c:numCache>
             </c:numRef>
@@ -505,22 +505,22 @@
                 <c:formatCode>General</c:formatCode>
                 <c:ptCount val="6"/>
                 <c:pt idx="0">
-                  <c:v>3.946443104442745</c:v>
+                  <c:v>-1.06765316170057</c:v>
                 </c:pt>
                 <c:pt idx="1">
-                  <c:v>0.04487293632982997</c:v>
+                  <c:v>-4.9692233298134845</c:v>
                 </c:pt>
                 <c:pt idx="2">
-                  <c:v>-2.6388362920894077</c:v>
+                  <c:v>-7.652932558232721</c:v>
                 </c:pt>
                 <c:pt idx="3">
-                  <c:v>1.4115262854426354</c:v>
+                  <c:v>-3.6025699807006792</c:v>
                 </c:pt>
                 <c:pt idx="4">
-                  <c:v>-1.4330412442990532</c:v>
+                  <c:v>-5.086492349152047</c:v>
                 </c:pt>
                 <c:pt idx="5">
-                  <c:v>-6.605370129557806</c:v>
+                  <c:v>-11.61946639570112</c:v>
                 </c:pt>
               </c:numCache>
             </c:numRef>
@@ -1036,23 +1036,23 @@
           </a:p>
           <a:p>
             <a:r>
-              <a:t>| Выручка 2027 / EBITDA2027 | 8 800 000 / 1 960 000 руб. |</a:t>
-            </a:r>
-          </a:p>
-          <a:p>
-            <a:r>
-              <a:t>| NPV за 5 лет, ставка 24% | 3 946 443 руб. |</a:t>
-            </a:r>
-          </a:p>
-          <a:p>
-            <a:r>
-              <a:t>| Простая / дисконтированная окупаемость | 2,68 / 3,88 года |</a:t>
+              <a:t>| Выручка 2027 / EBITDA2027 | 8 800 000 / 272 800 руб. |</a:t>
+            </a:r>
+          </a:p>
+          <a:p>
+            <a:r>
+              <a:t>| NPV за 5 лет, ставка 24% | -1 067 653 руб. |</a:t>
+            </a:r>
+          </a:p>
+          <a:p>
+            <a:r>
+              <a:t>| Простая / дисконтированная окупаемость | 3,68 / Не достигнута года |</a:t>
             </a:r>
           </a:p>
           <a:p/>
           <a:p>
             <a:r>
-              <a:t>[ДОПУЩЕНИЕ] Рекомендация инвестору — условное поэтапное финансирование. Не закупать весь парк без юридического заключения по региону, подтверждения кадрового бюджета и коммерческого портфеля. Положительная NPV не компенсирует отсутствие права на работы. Мониторинг без внесения не объявляется равноценной финансовой заменой: такой вариант требует отдельной малокапитальной модели.</a:t>
+              <a:t>[ДОПУЩЕНИЕ] Рекомендация инвестору — условное поэтапное финансирование. Не закупать весь парк без юридического заключения по региону, подтверждения кадрового бюджета и коммерческого портфеля. NPV и окупаемость рассматриваются вместе с риском сценарных предпосылок и не компенсируют отсутствие права на работы. Мониторинг без внесения не объявляется равноценной финансовой заменой: такой вариант требует отдельной малокапитальной модели.</a:t>
             </a:r>
           </a:p>
           <a:p/>
@@ -1133,75 +1133,44 @@
           <a:lstStyle/>
           <a:p>
             <a:r>
-              <a:t>[ДОПУЩЕНИЕ] Матрица власти и интереса используется для распределения коммуникаций. Высокая власть означает способность остановить финансирование, разрешение либо исполнение заказа, а не особый статус участника.</a:t>
+              <a:t>[ДОПУЩЕНИЕ] Модель Менделоу: вертикальная ось — власть, горизонтальная — интерес. Классификация плановая; власть означает возможность влиять на капитал, допуск или заказ. При изменении интереса/влияния участник перемещается между квадрантами.</a:t>
             </a:r>
           </a:p>
           <a:p/>
           <a:p>
             <a:r>
-              <a:t>| Стейкхолдер | Власть / интерес | Ожидание или конфликт | Взаимодействие | Ответственный |</a:t>
-            </a:r>
-          </a:p>
-          <a:p>
-            <a:r>
-              <a:t>|---|---|---|---|---|</a:t>
-            </a:r>
-          </a:p>
-          <a:p>
-            <a:r>
-              <a:t>| Учредитель | Высокая / высокий | Сохранение капитала и управляемость | Еженедельный контроль запуска, месячный план-факт | Директор |</a:t>
-            </a:r>
-          </a:p>
-          <a:p>
-            <a:r>
-              <a:t>| Долевой инвестор | Высокая / высокий | Прозрачность расходов и условий участия | Отчетность, согласование крупных решений | Директор |</a:t>
-            </a:r>
-          </a:p>
-          <a:p>
-            <a:r>
-              <a:t>| Клиенты и их агрономы | Высокая / высокий | Соблюдение окна, качество, понятная приемка | Паспорт поля, календарь, отчет, разбор претензий | Директор и операционный руководитель |</a:t>
-            </a:r>
-          </a:p>
-          <a:p>
-            <a:r>
-              <a:t>| Уполномоченные органы | Высокая / переменный | Соблюдение применимых требований | Документы и согласования по конкретной территории | Внешний юрист |</a:t>
-            </a:r>
-          </a:p>
-          <a:p>
-            <a:r>
-              <a:t>| Операторы | Средняя / высокий | Безопасность, оплата, реалистичная нагрузка | Инструктаж, обратная связь, право остановки | Операционный руководитель |</a:t>
-            </a:r>
-          </a:p>
-          <a:p>
-            <a:r>
-              <a:t>| Кандидаты после СВО | Низкая / высокий | Добровольный переход в гражданскую профессию | Конфиденциальный отбор, наставник, ясные требования | Директор |</a:t>
-            </a:r>
-          </a:p>
-          <a:p>
-            <a:r>
-              <a:t>| Учебный партнер и агроном | Средняя / высокий | Корректные задания и границы ответственности | Программа обучения, проверка знаний, согласование карт | Операционный руководитель |</a:t>
-            </a:r>
-          </a:p>
-          <a:p>
-            <a:r>
-              <a:t>| Сервис оборудования | Средняя / средний | Оплата и планируемое обслуживание | Регламент ремонтов, сроки реакции | Операционный руководитель |</a:t>
-            </a:r>
-          </a:p>
-          <a:p>
-            <a:r>
-              <a:t>| Соседи полей и местное сообщество | Низкая / переменный | Отсутствие недопустимого воздействия | Канал обращений, предусмотренное уведомление | Директор |</a:t>
+              <a:t>| Власть / интерес | Группы | Стратегия | Ответственный и частота |</a:t>
+            </a:r>
+          </a:p>
+          <a:p>
+            <a:r>
+              <a:t>|---|---|---|---|</a:t>
+            </a:r>
+          </a:p>
+          <a:p>
+            <a:r>
+              <a:t>| Высокая / высокий | Учредитель, инвестор, ключевые заказчики | Управлять тесно: решения, паспорт поля, контроль траншей | Директор: еженедельно при запуске и перед ключевым решением |</a:t>
+            </a:r>
+          </a:p>
+          <a:p>
+            <a:r>
+              <a:t>| Высокая / низкий или переменный | Регуляторы, страховщик | Поддерживать удовлетворенность: документы и применимые требования; не обещать разрешений | Юрист/директор: до допуска и при каждом изменении; внепланово при инциденте |</a:t>
+            </a:r>
+          </a:p>
+          <a:p>
+            <a:r>
+              <a:t>| Низкая / высокий | Операторы, агроном, учебный партнер, кандидаты, пчеловоды и соседи полей | Информировать и привлекать: обучение, обратная связь, уведомления и жалобы | Операционный руководитель: перед каждым выездом; директор: уведомления в законные сроки |</a:t>
+            </a:r>
+          </a:p>
+          <a:p>
+            <a:r>
+              <a:t>| Низкая / низкий | Пока не вовлеченные хозяйства вне маршрута, широкая аудитория | Наблюдать: без массовых обещаний и раскрытия персональных данных | Директор: ежемесячно; пересмотр при появлении интереса |</a:t>
             </a:r>
           </a:p>
           <a:p/>
           <a:p>
             <a:r>
-              <a:t>[ДОПУЩЕНИЕ] Социальная коммуникация не раскрывает персональную историю сотрудников без согласия и не обещает привилегированного допуска к полетам. Жалобы на безопасность рассматриваются независимо от коммерческой ценности заказа.</a:t>
-            </a:r>
-          </a:p>
-          <a:p/>
-          <a:p>
-            <a:r>
-              <a:t>[ДОПУЩЕНИЕ] Пчеловоды и владельцы соседних участков — отдельная группа с высоким интересом к безопасности: директор обеспечивает предусмотренные уведомления и канал жалоб; агроном проверяет ограничения. Жалоба или выявление угрозы может остановить работу независимо от формальной власти заявителя. Страховщик согласует покрытие и порядок сообщения об инциденте до допуска G.</a:t>
+              <a:t>[ДОПУЩЕНИЕ] Низкая власть не означает низкую значимость безопасности: обоснованная жалоба пчеловода или соседа инициирует остановку и проверку. Средние оценки сервиса/агронома относятся к нижней половине матрицы лишь условно; при критичной зависимости влияние повышается. Источник формы: референс, слайды 50–51.</a:t>
             </a:r>
           </a:p>
           <a:p/>
@@ -1372,7 +1341,7 @@
           <a:p/>
           <a:p>
             <a:r>
-              <a:t>[РАСЧЕТ] NPV ресурсного стресса — 2 309 588,02 руб.; простая / дисконтированная окупаемость — 2,758 / 4,259 года. Базовая модель не заменена. Помесячные объемы и годовые потоки: data/capacity_scenario_monthly.csv и data/capacity_scenario_annual.csv; формулы — scripts/build_capacity_scenario.py.</a:t>
+              <a:t>[РАСЧЕТ] NPV ресурсного стресса — -2 704 508,25 руб.; простая / дисконтированная окупаемость — 4,089 / Не достигнута года. Базовая модель не заменена. Помесячные объемы и годовые потоки: data/capacity_scenario_monthly.csv и data/capacity_scenario_annual.csv; формулы — scripts/build_capacity_scenario.py.</a:t>
             </a:r>
           </a:p>
           <a:p/>
@@ -1501,13 +1470,19 @@
           <a:p/>
           <a:p>
             <a:r>
-              <a:t>[ДОПУЩЕНИЕ] Полная стоимость штатного труда принята на уровне 3 млн руб. в год. Это экономный и рискованный бюджет, требующий проверки начислений, условий кандидатов и сезонной нагрузки; рост обязательных выплат нельзя скрывать за неоплачиваемыми переработками.</a:t>
+              <a:t>[ДОПУЩЕНИЕ] Штатные gross-оклады и страховые взносы раскрываются раздельно в data/payroll2027.csv и финансовом разделе. Региональная средняя зарплата служит ориентиром, а не подтверждением стоимости пилота БПЛА. НДФЛ удерживается из gross, а не прибавляется к стоимости работодателя. Взносы на травматизм до подтверждения класса являются допущением. Неоплачиваемые переработки не финансируют модель.</a:t>
             </a:r>
           </a:p>
           <a:p/>
           <a:p>
             <a:r>
               <a:t>[ДОПУЩЕНИЕ] Людям с опытом БПЛА после СВО предлагается добровольная гражданская переподготовка: оценка исходных навыков, обучение агротехнологии и безопасности, работа с наставником, практическая проверка и документированное решение о готовности. Требования одинаковы для всех кандидатов; прежний опыт не означает автоматического допуска. При необходимости предусматривается индивидуальный темп адаптации и добровольное обращение за поддержкой без раскрытия чувствительных данных клиентам.</a:t>
+            </a:r>
+          </a:p>
+          <a:p/>
+          <a:p>
+            <a:r>
+              <a:t>[ФАКТ] Региональный ориентир января–июня 2026 —98479 руб. начисленной зарплаты в месяц по сообщению СМИ со ссылкой на Татарстанстат.[34] Это вторичный источник, не ставка пилотаБПЛА. [ДОПУЩЕНИЕ] На 2027 принято 100000 руб.grossдля директора и каждого из двух операторов:3,6 млн руб. gross/год. Общий тариф 30%без неподтвержденной льготы плюс 0,2%травматизма до установления класса:1,0872 млн руб. взносов, всего 4,6872 млн руб./год. ПравилаФНС 2026 общего тарифа и базы проверены[35]; их перенос на 2027 и дальнейшая индексация — бюджетное допущение до сверки действующих норм. НДФЛ не начисляется повторно сверхуgross. Файл payroll2027.csv; 0,2%не подтвержденный тариф AgroVector.</a:t>
             </a:r>
           </a:p>
           <a:p/>
@@ -1600,6 +1575,12 @@
           <a:p/>
           <a:p>
             <a:r>
+              <a:t>[ДОПУЩЕНИЕ] Графическое дерево: AgroVector → 1. Проверка (A/B/C) → 2. Ресурсы (D/E/F/G) → 3. Готовность (H/I/J/M) → 4. Сезон и аудит (K/L). Ветви — декомпозиция результатов, не последовательность или зависимости; зависимости показаны отдельно сетевым графиком. На слайде каждый пакет привязан к ID единого CSV. Референс: слайды 71, 74–75.</a:t>
+            </a:r>
+          </a:p>
+          <a:p/>
+          <a:p>
+            <a:r>
               <a:t>| WBS | ID | Работа | Результат |</a:t>
             </a:r>
           </a:p>
@@ -2435,6 +2416,18 @@
           <a:p/>
           <a:p>
             <a:r>
+              <a:t>[ДОПУЩЕНИЕ] Визуальная RACI: строки — все 13 работ A–L и M; столбцы — роли; цветные R/A/C/I и «—» для незадействованных. В каждой строке ровно один A и хотя бы один R. Совмещенные должности нормализованы: продажи=директор, операционный руководитель=первый оператор; колонка «Оператор 2» — конкретно второй сотрудник, не первый оператор и не собирательная команда. Референс: фото 4 и слайд 82.</a:t>
+            </a:r>
+          </a:p>
+          <a:p/>
+          <a:p>
+            <a:r>
+              <a:t>[ДОПУЩЕНИЕ] В работах I и K R назначен второму оператору, A — первому оператору/операционному руководителю: это разные люди. Приемка качества задания дополнительно согласуется с внешним агрономом и клиентом. Это внутреннее разделение выполнения и утверждения, не независимый сертификационный аудит. Если второй оператор отсутствует, роли не объединяются молча: задание переносится либо назначается отдельный допущенный исполнитель с проверкой бюджета. «Команда» в I-уведомлениях D раскрыта обоим операторам.</a:t>
+            </a:r>
+          </a:p>
+          <a:p/>
+          <a:p>
+            <a:r>
               <a:t>| ID | R — выполняет | A — принимает | C — консультирует | I — информируется |</a:t>
             </a:r>
           </a:p>
@@ -2485,7 +2478,7 @@
           </a:p>
           <a:p>
             <a:r>
-              <a:t>| I | Оператор | Операционный руководитель | Агроном;Клиент | Директор |</a:t>
+              <a:t>| I | Второй оператор | Операционный руководитель | Агроном;Клиент | Директор |</a:t>
             </a:r>
           </a:p>
           <a:p>
@@ -2500,7 +2493,7 @@
           </a:p>
           <a:p>
             <a:r>
-              <a:t>| K | Оператор | Операционный руководитель | Агроном;Клиент | Директор |</a:t>
+              <a:t>| K | Второй оператор | Операционный руководитель | Агроном;Клиент | Директор |</a:t>
             </a:r>
           </a:p>
           <a:p>
@@ -2561,7 +2554,7 @@
           </a:p>
           <a:p>
             <a:r>
-              <a:t>I Стендовые и контролируемые приемочные испытания: R Оператор; A Операционный руководитель; C Агроном;Клиент; I Директор</a:t>
+              <a:t>I Стендовые и контролируемые приемочные испытания: R Второй оператор; A Операционный руководитель; C Агроном;Клиент; I Директор</a:t>
             </a:r>
           </a:p>
           <a:p>
@@ -2576,7 +2569,7 @@
           </a:p>
           <a:p>
             <a:r>
-              <a:t>K Первый коммерческий сезон: R Оператор; A Операционный руководитель; C Агроном;Клиент; I Директор</a:t>
+              <a:t>K Первый коммерческий сезон: R Второй оператор; A Операционный руководитель; C Агроном;Клиент; I Директор</a:t>
             </a:r>
           </a:p>
           <a:p>
@@ -2675,7 +2668,7 @@
           <a:p/>
           <a:p>
             <a:r>
-              <a:t>[ДОПУЩЕНИЕ] Постоянный OPEX2027 — 4,2млнруб.: штат с начислениями3млн; аренда360тыс.; страхование/комплаенс300тыс. (страхование120, юрист60, внешний агроном120); маркетинг240тыс.; IT120тыс.; администрирование180тыс. (бухгалтер120, банк/прочее60). Бюджеты внешних специалистов и труда экономные; подтверждение их достаточности является инвестиционным gate. Стартовые500тыс. распределены на первоначальное обучение200, подготовку правового/операционного досье200 и организационные расходы100; ежегодное сопровождение не дублирует эти разовые работы.</a:t>
+              <a:t>[ДОПУЩЕНИЕ] Постоянный OPEX2027 — {fmt(y1['fixed_opex_rub'])}руб.: прозрачный payroll директора и двух операторов {fmt(PAYROLL_GROSS_ANNUAL)}руб. gross + начисления {fmt(PAYROLL_CONTRIBUTIONS_ANNUAL)}руб. (30% общих взносов и 0,2% травматизм как допущение до подтверждения класса); всего работодателю {fmt(PAYROLL_TOTAL_ANNUAL)}руб.; аренда360тыс.; страхование/комплаенс300тыс. (страхование120, юрист60, внешний агроном120); маркетинг240тыс.; IT120тыс.; администрирование180тыс. (бухгалтер120, банк/прочее60). Бюджеты внешних специалистов и труда экономные; подтверждение их достаточности является инвестиционным gate. Стартовые500тыс. распределены на первоначальное обучение200, подготовку правового/операционного досье200 и организационные расходы100; ежегодное сопровождение не дублирует эти разовые работы.</a:t>
             </a:r>
           </a:p>
           <a:p/>
@@ -2708,7 +2701,7 @@
           <a:p/>
           <a:p>
             <a:r>
-              <a:t>[РАСЧЕТ] Вклад до постоянных затрат2027:6,16млнруб., маржинальность70%. После УСН вклад5,632млн. EBITDA-безубыточность при постоянном миксе услуг:6млнруб. выручки; денежная операционная безубыточность после УСН — 6 562 500руб., или одновременно 4 474,4га-проходов и 2 983,0га-обследований. Это пропорциональный набор услуг, не два независимых порога. CAPEX и возврат инвестиций этим порогом не покрываются.</a:t>
+              <a:t>[РАСЧЕТ] Вклад до постоянных затрат2027:6,16млнруб., маржинальность70%. После УСН вклад5,632млн. EBITDA-безубыточность при постоянном миксе услуг: 8 410 286руб. выручки; денежная операционная безубыточность после УСН — 9 198 750руб., или одновременно 6 271,9га-проходов и 4 181,2га-обследований. Это пропорциональный набор услуг, не два независимых порога. CAPEX и возврат инвестиций этим порогом не покрываются.</a:t>
             </a:r>
           </a:p>
           <a:p/>
@@ -2766,27 +2759,27 @@
           </a:p>
           <a:p>
             <a:r>
-              <a:t>| 2027 | 8 800 000,00 | 2 640 000,00 | 4 200 000,00 | 1 960 000,00 | 1 400 000,00 | 528 000,00 | 32 000,00 | 0,00 | 1 432 000,00 |</a:t>
-            </a:r>
-          </a:p>
-          <a:p>
-            <a:r>
-              <a:t>| 2028 | 13 728 000,00 | 4 158 000,00 | 4 410 000,00 | 5 160 000,00 | 1 500 000,00 | 823 680,00 | 2 836 320,00 | 300 000,00 | 4 036 320,00 |</a:t>
-            </a:r>
-          </a:p>
-          <a:p>
-            <a:r>
-              <a:t>| 2029 | 17 630 080,00 | 5 380 200,00 | 4 630 500,00 | 7 619 380,00 | 1 700 000,00 | 1 057 804,80 | 4 861 575,20 | 600 000,00 | 5 961 575,20 |</a:t>
-            </a:r>
-          </a:p>
-          <a:p>
-            <a:r>
-              <a:t>| 2030 | 20 078 822,40 | 6 181 717,50 | 4 862 025,00 | 9 035 079,90 | 2 000 000,00 | 1 204 729,34 | 5 830 350,56 | 900 000,00 | 6 930 350,56 |</a:t>
-            </a:r>
-          </a:p>
-          <a:p>
-            <a:r>
-              <a:t>| 2031 | 22 695 256,06 | 7 049 936,25 | 5 105 126,25 | 10 540 193,56 | 2 100 000,00 | 1 361 715,36 | 7 078 478,20 | 600 000,00 | 10 578 478,20 |</a:t>
+              <a:t>| 2027 | 8 800 000,00 | 2 640 000,00 | 5 887 200,00 | 272 800,00 | 1 400 000,00 | 528 000,00 | -1 655 200,00 | 0,00 | -255 200,00 |</a:t>
+            </a:r>
+          </a:p>
+          <a:p>
+            <a:r>
+              <a:t>| 2028 | 13 728 000,00 | 4 158 000,00 | 6 181 560,00 | 3 388 440,00 | 1 500 000,00 | 823 680,00 | 1 064 760,00 | 300 000,00 | 2 264 760,00 |</a:t>
+            </a:r>
+          </a:p>
+          <a:p>
+            <a:r>
+              <a:t>| 2029 | 17 630 080,00 | 5 380 200,00 | 6 490 638,00 | 5 759 242,00 | 1 700 000,00 | 1 057 804,80 | 3 001 437,20 | 600 000,00 | 4 101 437,20 |</a:t>
+            </a:r>
+          </a:p>
+          <a:p>
+            <a:r>
+              <a:t>| 2030 | 20 078 822,40 | 6 181 717,50 | 6 815 169,90 | 7 081 935,00 | 2 000 000,00 | 1 204 729,34 | 3 877 205,66 | 900 000,00 | 4 977 205,66 |</a:t>
+            </a:r>
+          </a:p>
+          <a:p>
+            <a:r>
+              <a:t>| 2031 | 22 695 256,06 | 7 049 936,25 | 7 155 928,40 | 8 489 391,42 | 2 100 000,00 | 1 361 715,36 | 5 027 676,06 | 600 000,00 | 8 527 676,06 |</a:t>
             </a:r>
           </a:p>
           <a:p/>
@@ -2798,13 +2791,13 @@
           <a:p/>
           <a:p>
             <a:r>
-              <a:t>[ДОПУЩЕНИЕ] Поступления и выполнение распределены апрель–сентябрь10/20/25/20/15/10%. Услуги оплачиваются в месяц выполнения; плановый договорный аванс30% не используется для улучшения модели. Фиксированные расходы350000руб./месяц. Подготовительные расходы2026 свернуты в t0; годовая модель оценивается на условную дату31.12.2026, не заменяет календарь траншей осени2026.</a:t>
+              <a:t>[ДОПУЩЕНИЕ] Поступления и выполнение распределены апрель–сентябрь10/20/25/20/15/10%. Услуги оплачиваются в месяц выполнения; плановый договорный аванс30% не используется для улучшения модели. Фиксированные расходы 490 600руб./месяц в 2027. Подготовительные расходы2026 свернуты в t0; годовая модель оценивается на условную дату31.12.2026, не заменяет календарь траншей осени2026.</a:t>
             </a:r>
           </a:p>
           <a:p/>
           <a:p>
             <a:r>
-              <a:t>[РАСЧЕТ] После оплаты оборудования и запуска на счете2млнруб. Минимум месячного остатка2027 — 950 000руб., конец года — 3 432 000руб. Без поступлений резерв покрывает 5,71месяца постоянных расходов. Отдельная таблица: `data/monthly_cashflow_2027.csv`; отсутствие месячного минуса не исключает внутримесячного разрыва.</a:t>
+              <a:t>[РАСЧЕТ] После оплаты оборудования и запуска на счете2млнруб. Минимум месячного остатка2027 — 528 200руб., конец года — 1 744 800руб. Без поступлений резерв покрывает 4,08месяца постоянных расходов. Отдельная таблица: `data/monthly_cashflow_2027.csv`; отсутствие месячного минуса не исключает внутримесячного разрыва.</a:t>
             </a:r>
           </a:p>
           <a:p/>
@@ -2834,7 +2827,7 @@
           <a:p/>
           <a:p>
             <a:r>
-              <a:t>[РАСЧЕТ] Два комплекта стоят 5 980 000 руб., превышение базового лимита — 1 980 000 руб. При прочих равных CAPEX — 8 980 000 руб., финансирование — 11 480 000 руб., NPV — 1 966 443 руб. Это изолированный тест удорожания закупки, не новая полноценная база. Обучение и сопровождение в комплекте нужно исключить из повторного счета после получения КП.</a:t>
+              <a:t>[РАСЧЕТ] Два комплекта стоят 5 980 000 руб., превышение базового лимита — 1 980 000 руб. Это изолированный тест удорожания закупки, не новая полноценная база; его финансовые результаты требуют полного пересчета модели. Обучение и сопровождение в комплекте нужно исключить из повторного счета после получения КП.</a:t>
             </a:r>
           </a:p>
           <a:p/>
@@ -2881,17 +2874,17 @@
           </a:p>
           <a:p>
             <a:r>
-              <a:t>| 1 | 285 200 | 0 |</a:t>
-            </a:r>
-          </a:p>
-          <a:p>
-            <a:r>
-              <a:t>| 2 | -724 800 | 724 800 |</a:t>
-            </a:r>
-          </a:p>
-          <a:p>
-            <a:r>
-              <a:t>| 3 | -1 602 800 | 1 602 800 |</a:t>
+              <a:t>| 1 | -417 800 | 417 800 |</a:t>
+            </a:r>
+          </a:p>
+          <a:p>
+            <a:r>
+              <a:t>| 2 | -1 568 400 | 1 568 400 |</a:t>
+            </a:r>
+          </a:p>
+          <a:p>
+            <a:r>
+              <a:t>| 3 | -2 587 000 | 2 587 000 |</a:t>
             </a:r>
           </a:p>
           <a:p/>
@@ -2984,7 +2977,7 @@
           <a:p/>
           <a:p>
             <a:r>
-              <a:t>[РАСЧЕТ] NPV=−9500000+Σ(FCFₜ/1,24ᵗ)=3 946 443,10 руб. Простая окупаемость 2,676 года; дисконтированная 3,885 года. Доля года — условная интерполяция, а не точная дата при сезонном потоке.</a:t>
+              <a:t>[РАСЧЕТ] NPV=−9500000+Σ(FCFₜ/1,24ᵗ)=-1 067 653,16 руб. Простая окупаемость 3,681 года; дисконтированная окупаемость: Не достигнута года. Если показатель не достигнут за горизонт, он отображается как «Не достигнута».</a:t>
             </a:r>
           </a:p>
           <a:p/>
@@ -3005,33 +2998,33 @@
           </a:p>
           <a:p>
             <a:r>
-              <a:t>| 1 | 1 432 000,00 | 0,806452 | 1 154 838,71 | -8 345 161,29 |</a:t>
-            </a:r>
-          </a:p>
-          <a:p>
-            <a:r>
-              <a:t>| 2 | 4 036 320,00 | 0,650364 | 2 625 078,04 | -5 720 083,25 |</a:t>
-            </a:r>
-          </a:p>
-          <a:p>
-            <a:r>
-              <a:t>| 3 | 5 961 575,20 | 0,524487 | 3 126 770,25 | -2 593 313,00 |</a:t>
-            </a:r>
-          </a:p>
-          <a:p>
-            <a:r>
-              <a:t>| 4 | 6 930 350,56 | 0,422974 | 2 931 355,31 | 338 042,31 |</a:t>
-            </a:r>
-          </a:p>
-          <a:p>
-            <a:r>
-              <a:t>| 5 | 10 578 478,20 | 0,341108 | 3 608 400,79 | 3 946 443,10 |</a:t>
+              <a:t>| 1 | -255 200,00 | 0,806452 | -205 806,45 | -9 705 806,45 |</a:t>
+            </a:r>
+          </a:p>
+          <a:p>
+            <a:r>
+              <a:t>| 2 | 2 264 760,00 | 0,650364 | 1 472 918,83 | -8 232 887,62 |</a:t>
+            </a:r>
+          </a:p>
+          <a:p>
+            <a:r>
+              <a:t>| 3 | 4 101 437,20 | 0,524487 | 2 151 151,56 | -6 081 736,05 |</a:t>
+            </a:r>
+          </a:p>
+          <a:p>
+            <a:r>
+              <a:t>| 4 | 4 977 205,66 | 0,422974 | 2 105 226,58 | -3 976 509,47 |</a:t>
+            </a:r>
+          </a:p>
+          <a:p>
+            <a:r>
+              <a:t>| 5 | 8 527 676,06 | 0,341108 | 2 908 856,31 | -1 067 653,16 |</a:t>
             </a:r>
           </a:p>
           <a:p/>
           <a:p>
             <a:r>
-              <a:t>[РАСЧЕТ] Если бизнес продолжает работу и резерв не высвобождается, NPV без возврата 2 млн составляет 3 264 227,62 руб. Это отдельная проверка терминального допущения, не прибавка стоимости бизнеса.</a:t>
+              <a:t>[РАСЧЕТ] Если бизнес продолжает работу и резерв не высвобождается, NPV без возврата 2 млн составляет -1 749 868,64 руб. Это отдельная проверка терминального допущения, не прибавка стоимости бизнеса.</a:t>
             </a:r>
           </a:p>
           <a:p/>
@@ -3053,32 +3046,32 @@
           </a:p>
           <a:p>
             <a:r>
-              <a:t>| База | 3 946 443,10 | 2,676 | 3,885 |</a:t>
-            </a:r>
-          </a:p>
-          <a:p>
-            <a:r>
-              <a:t>| Оба тарифа−10% | 44 872,94 | 3,366 | 5,000 |</a:t>
-            </a:r>
-          </a:p>
-          <a:p>
-            <a:r>
-              <a:t>| Оба объема−25% | -2 638 836,29 | 4,141 | Не достигнута |</a:t>
-            </a:r>
-          </a:p>
-          <a:p>
-            <a:r>
-              <a:t>| Переменные+20% | 1 411 526,29 | 3,089 | 4,702 |</a:t>
-            </a:r>
-          </a:p>
-          <a:p>
-            <a:r>
-              <a:t>| Задержка 1 год | -1 433 041,24 | 3,793 | Не достигнута |</a:t>
-            </a:r>
-          </a:p>
-          <a:p>
-            <a:r>
-              <a:t>| Внесение 900 руб. в 2027; мониторинг без изменения | -6 605 370,13 | Не достигнута | Не достигнута |</a:t>
+              <a:t>| База | -1 067 653,16 | 3,681 | Не достигнута |</a:t>
+            </a:r>
+          </a:p>
+          <a:p>
+            <a:r>
+              <a:t>| Оба тарифа−10% | -4 969 223,33 | 4,927 | Не достигнута |</a:t>
+            </a:r>
+          </a:p>
+          <a:p>
+            <a:r>
+              <a:t>| Оба объема−25% | -7 652 932,56 | Не достигнута | Не достигнута |</a:t>
+            </a:r>
+          </a:p>
+          <a:p>
+            <a:r>
+              <a:t>| Переменные+20% | -3 602 569,98 | 4,407 | Не достигнута |</a:t>
+            </a:r>
+          </a:p>
+          <a:p>
+            <a:r>
+              <a:t>| Задержка 1 год | -5 086 492,35 | 4,849 | Не достигнута |</a:t>
+            </a:r>
+          </a:p>
+          <a:p>
+            <a:r>
+              <a:t>| Внесение 900 руб. в 2027; мониторинг без изменения | -11 619 466,40 | Не достигнута | Не достигнута |</a:t>
             </a:r>
           </a:p>
           <a:p/>
@@ -3090,7 +3083,7 @@
           <a:p/>
           <a:p>
             <a:r>
-              <a:t>[РАСЧЕТ] Снижение тарифа на 10% почти обнуляет NPV; дисконтированная окупаемость этого стресса наступает только в конце Y5 с возвратом резерва. При недозагрузке 25% либо годовой задержке дисконтированная окупаемость за 5 лет не достигается. Основное условие вложения капитала — проверка готовности клиентов оплачивать именно плановый тариф.</a:t>
+              <a:t>[РАСЧЕТ] Окупаемость трактуется как не достигнутая, если накопленный поток не пересек ноль в пятилетнем горизонте; возврат резерва показывается отдельно и не интерполируется как операционная окупаемость. Основное условие вложения капитала — проверка готовности клиентов оплачивать именно плановый тариф.</a:t>
             </a:r>
           </a:p>
           <a:p/>
@@ -3124,17 +3117,17 @@
           </a:p>
           <a:p>
             <a:r>
-              <a:t>| Мониторинг = внесение / 3 во все пять лет; не базовая выручка | 9 500 000 | 8 300 000 | 2 080 329,92 |</a:t>
-            </a:r>
-          </a:p>
-          <a:p>
-            <a:r>
-              <a:t>| Два публичных ценника по 2,99 млн вместо лимита 4 млн; прочее неизменно; не полное КП | 11 480 000 | 8 800 000 | 1 966 443,10 |</a:t>
-            </a:r>
-          </a:p>
-          <a:p>
-            <a:r>
-              <a:t>| Оба тарифа −10%; оба объема −25%; CAPEX +1,98 млн; исходный горизонт | 11 480 000 | 5 940 000 | -7 545 013,92 |</a:t>
+              <a:t>| Мониторинг = внесение / 3 во все пять лет; не базовая выручка | 9 500 000 | 8 300 000 | -2 933 766,34 |</a:t>
+            </a:r>
+          </a:p>
+          <a:p>
+            <a:r>
+              <a:t>| Два публичных ценника по 2,99 млн вместо лимита 4 млн; прочее неизменно; не полное КП | 11 480 000 | 8 800 000 | -3 047 653,16 |</a:t>
+            </a:r>
+          </a:p>
+          <a:p>
+            <a:r>
+              <a:t>| Оба тарифа −10%; оба объема −25%; CAPEX +1,98 млн; исходный горизонт | 11 480 000 | 5 940 000 | -12 559 110,18 |</a:t>
             </a:r>
           </a:p>
           <a:p/>
@@ -3147,7 +3140,7 @@
           <a:p/>
           <a:p>
             <a:r>
-              <a:t>[РАСЧЕТ] NPV ресурсного стресса — 2 309 588,02 руб.; простая / дисконтированная окупаемость — 2,758 / 4,259 года. Базовая модель не заменена. Помесячные объемы и годовые потоки: data/capacity_scenario_monthly.csv и data/capacity_scenario_annual.csv; формулы — scripts/build_capacity_scenario.py.</a:t>
+              <a:t>[РАСЧЕТ] NPV ресурсного стресса — -2 704 508,25 руб.; простая / дисконтированная окупаемость — 4,089 / Не достигнута года. Базовая модель не заменена. Помесячные объемы и годовые потоки: data/capacity_scenario_monthly.csv и data/capacity_scenario_annual.csv; формулы — scripts/build_capacity_scenario.py.</a:t>
             </a:r>
           </a:p>
           <a:p/>
@@ -3646,17 +3639,17 @@
           </a:p>
           <a:p>
             <a:r>
-              <a:t>| EBITDA,руб. | 1 960 000 | 10 540 194 |</a:t>
-            </a:r>
-          </a:p>
-          <a:p>
-            <a:r>
-              <a:t>| Рентабельность EBITDA | 22,3% | 46,4% |</a:t>
-            </a:r>
-          </a:p>
-          <a:p>
-            <a:r>
-              <a:t>| FCF,руб. | 1 432 000 | 10 578 478 |</a:t>
+              <a:t>| EBITDA,руб. | 272 800 | 8 489 391 |</a:t>
+            </a:r>
+          </a:p>
+          <a:p>
+            <a:r>
+              <a:t>| Рентабельность EBITDA | 3,1% | 37,4% |</a:t>
+            </a:r>
+          </a:p>
+          <a:p>
+            <a:r>
+              <a:t>| FCF,руб. | -255 200 | 8 527 676 |</a:t>
             </a:r>
           </a:p>
           <a:p>
@@ -3673,7 +3666,7 @@
           <a:p/>
           <a:p>
             <a:r>
-              <a:t>[РАСЧЕТ] Обе услуги требуют 54,15 эффективного дня в 2027 и 120 в 2031; это не гарантированные доступные смены. FCF 2031 до высвобождения резерва: 8 578 478,20 руб.; возврат резерва отдельно 2 млн руб. [ДОПУЩЕНИЕ] Поздняя база ресурсно не подтверждена.</a:t>
+              <a:t>[РАСЧЕТ] Обе услуги требуют 54,15 эффективного дня в 2027 и 120 в 2031; это не гарантированные доступные смены. FCF 2031 до высвобождения резерва: 6 527 676,06 руб.; возврат резерва отдельно 2 млн руб. [ДОПУЩЕНИЕ] Поздняя база ресурсно не подтверждена.</a:t>
             </a:r>
           </a:p>
           <a:p/>
@@ -3962,6 +3955,31 @@
               <a:t>[32] http://publication.pravo.gov.ru/Document/View/1600202211300002 — Указ Республики Татарстан от 25.11.2022 № УП-813</a:t>
             </a:r>
           </a:p>
+          <a:p>
+            <a:r>
+              <a:t>[33] https://agroexpert.press/numbers/posevnaya-ploshhad-v-2025-godu-snizilas-na-111-do-79298-mln-ga-rosstat — Агроэксперт: общероссийская посевная площадь 2025 по данным Росстата</a:t>
+            </a:r>
+          </a:p>
+          <a:p>
+            <a:r>
+              <a:t>[34] https://zur-kazan.ru/news/article/srednemesyachnaya-zarplata-v-tatarstane-vozrosla-do-98-479-rubley-131310 — Журнал Казань: средняя зарплата Татарстана, январь–июнь 2026</a:t>
+            </a:r>
+          </a:p>
+          <a:p>
+            <a:r>
+              <a:t>[35] https://www.nalog.gov.ru/rn77/news/activities_fts/16577139 — ФНС: единый тариф взносов и предельная база 2026</a:t>
+            </a:r>
+          </a:p>
+          <a:p>
+            <a:r>
+              <a:t>[36] https://agrdron.ru/about — Агродроны ЮФО: цена услуги от 900 руб./га</a:t>
+            </a:r>
+          </a:p>
+          <a:p>
+            <a:r>
+              <a:t>[37] https://secrets.tbank.ru/blogi-kompanij/pro-tekhnologii-v-polyah — Леонид Гоминюк, ООО Купец: авторский диапазон стоимости, 07.05.2025</a:t>
+            </a:r>
+          </a:p>
           <a:p/>
           <a:p>
             <a:r>
@@ -4139,13 +4157,13 @@
           <a:lstStyle/>
           <a:p>
             <a:r>
-              <a:t>[ДОПУЩЕНИЕ] Business Model Canvas фиксирует проверяемые гипотезы раннего проекта. До подтверждения договоров указанные сегменты и партнерства не считаются сформированным рынком сбыта.</a:t>
+              <a:t>[ДОПУЩЕНИЕ] Lean Canvas по референсу «Практика 08.10.26», слайд 33 и фото 1. Девять блоков описывают проверяемые гипотезы, не действующий бизнес.</a:t>
             </a:r>
           </a:p>
           <a:p/>
           <a:p>
             <a:r>
-              <a:t>| Блок | Содержание модели | Проверка гипотезы |</a:t>
+              <a:t>| Блок Lean Canvas | Гипотеза AgroVector | Проверка / ограничение |</a:t>
             </a:r>
           </a:p>
           <a:p>
@@ -4155,59 +4173,47 @@
           </a:p>
           <a:p>
             <a:r>
-              <a:t>| 1. Потребительские сегменты | КФХ и малые/средние хозяйства Татарстана — основной сегмент; агрохолдинги — вторичный; руководитель покупает, агроном принимает результат | Интервью по конкретным полям, культурам и календарям |</a:t>
-            </a:r>
-          </a:p>
-          <a:p>
-            <a:r>
-              <a:t>| 2. Ценностное предложение | Мониторинг, карта задания, подходящее точечное внесение и отчет в одном договорном контуре | Платный пилот, согласованные критерии приемки |</a:t>
-            </a:r>
-          </a:p>
-          <a:p>
-            <a:r>
-              <a:t>| 3. Каналы | Прямые продажи директора, рекомендации агрономов, демонстрации на согласованных площадках | Стоимость привлечения и переход заявки в договор |</a:t>
-            </a:r>
-          </a:p>
-          <a:p>
-            <a:r>
-              <a:t>| 4. Отношения с клиентами | Персональное планирование сезона, единый контакт, уведомления о переносах, разбор отклонений | Продление договора и реестр претензий |</a:t>
-            </a:r>
-          </a:p>
-          <a:p>
-            <a:r>
-              <a:t>| 5. Потоки доходов | Оплата внесения за га-проход; отдельная оплата согласованного мониторинга за га-обследование | Акты, отсутствие повторного выставления одного объема |</a:t>
-            </a:r>
-          </a:p>
-          <a:p>
-            <a:r>
-              <a:t>| 6. Ключевые ресурсы | Одна бригада, основной и резервный аппараты внесения, мониторинговый аппарат, транспорт, документы и оборотный резерв | Приемка, ресурсный календарь и кассовый план |</a:t>
-            </a:r>
-          </a:p>
-          <a:p>
-            <a:r>
-              <a:t>| 7. Ключевые действия | Продажи, правовая проверка, планирование, подготовка задания, безопасное исполнение, обслуживание и отчетность | Регламенты, журналы и контроль качества |</a:t>
-            </a:r>
-          </a:p>
-          <a:p>
-            <a:r>
-              <a:t>| 8. Ключевые партнеры | Внешний агроном, учебный партнер, сервис техники, юрист, бухгалтер; поставщики препаратов взаимодействуют с клиентом | Договоры, квалификация, сроки реакции |</a:t>
-            </a:r>
-          </a:p>
-          <a:p>
-            <a:r>
-              <a:t>| 9. Структура затрат | OPEX: труд, логистика, обслуживание, специалисты, страхование, маркетинг, IT и учет; CAPEX и запуск отдельно; резерв ликвидности не является расходом | Сметы, предложения поставщиков, ежемесячный план-факт |</a:t>
-            </a:r>
-          </a:p>
-          <a:p/>
-          <a:p>
-            <a:r>
-              <a:t>[ДОПУЩЕНИЕ] Выпуск энтомофагов относится к согласованной операции внесения, а не формирует третью строку выручки. Повторный проход учитывается только при отдельном задании и фактическом выполнении. Площадь мониторинга может совпадать с обработанными полями; это разные услуги, но не дополнительные уникальные гектары территории.</a:t>
-            </a:r>
-          </a:p>
-          <a:p/>
-          <a:p>
-            <a:r>
-              <a:t>[ДОПУЩЕНИЕ] Все партнеры — кандидаты до подписания договоров; ресурсы — план закупки до внесения капитала. Два потока доходов и три FTE соответствуют финансовому плану. Резерв 2 млн руб. — ресурс покрытия кассового разрыва, а не себестоимость услуги.</a:t>
+              <a:t>| 2. Проблемы | Неуспевание в агроокно; неоднородность посевов; недостаток карт и отчетности. Проверяются интервью, не объявляются доказанным спросом. | Альтернативы: наземная техника, собственный БВС, другой подрядчик, отказ от операции. |</a:t>
+            </a:r>
+          </a:p>
+          <a:p>
+            <a:r>
+              <a:t>| 4. Решение | Обследование и карта; согласованное точечное внесение; акт и отчет по заданию. | Пилот с контрольным участком и согласованной приемкой. |</a:t>
+            </a:r>
+          </a:p>
+          <a:p>
+            <a:r>
+              <a:t>| 3. Уникальное ценностное предложение | Одно согласованное задание: от карты проблемных зон до выполненной операции и проверяемого отчета. | Не обещаем универсальной экономии СЗР или прироста урожая. |</a:t>
+            </a:r>
+          </a:p>
+          <a:p>
+            <a:r>
+              <a:t>| 9. Труднокопируемое преимущество | Пока не подтверждено. Локальные повторные договоры и накопленные карты могут стать преимуществом после сезона. | Ни дрон, ни идея комплексной услуги сами по себе не уникальны. |</a:t>
+            </a:r>
+          </a:p>
+          <a:p>
+            <a:r>
+              <a:t>| 1. Сегменты клиентов | КФХ и малые/средние хозяйства Татарстана до 150 км при допуске поля. Платит руководитель, принимает агроном. | Ранние последователи: хозяйства с конкретной неудовлетворенной задачей и готовностью оплатить пилот. |</a:t>
+            </a:r>
+          </a:p>
+          <a:p>
+            <a:r>
+              <a:t>| 8. Ключевые метрики | Доступный подтвержденный портфель; оплаченные га-проходы и га-обследования; вклад после УСН; повторы; время отчета. | Цели: 10 клиентов, 6000/4000 операций, отчет до 48 часов; это не фактические результаты. |</a:t>
+            </a:r>
+          </a:p>
+          <a:p>
+            <a:r>
+              <a:t>| 5. Каналы | Прямые продажи, рекомендации агрономов, фермерские объединения, демонстрационный платный пилот. | Воронка 100 контактов → 40 разговоров → 20 предложений → 10 клиентов — гипотеза. |</a:t>
+            </a:r>
+          </a:p>
+          <a:p>
+            <a:r>
+              <a:t>| 7. Структура затрат | Штат и взносы по payroll2027.csv; логистика, ремонт, специалисты и прочий OPEX; CAPEX и запуск отдельно. | Резерв ликвидности не расход; препараты предоставляет клиент. |</a:t>
+            </a:r>
+          </a:p>
+          <a:p>
+            <a:r>
+              <a:t>| 6. Потоки доходов | Внесение: 6000 × 1300 = 7,8 млн руб.; мониторинг: 4000 × 250 = 1,0 млн руб.; всего 8,8 млн руб. без НДС. | Оплачиваются разные операции; обследование не включается бесплатно во внесение. |</a:t>
             </a:r>
           </a:p>
           <a:p/>
@@ -4288,223 +4294,79 @@
           <a:lstStyle/>
           <a:p>
             <a:r>
-              <a:t>[ДОПУЩЕНИЕ] Приоритет — КФХ и малые/средние сельхозпредприятия с фрагментированными полями, культурами высокой ценности, переувлажненными участками и недостаточной собственной техникой. Покупатель — руководитель хозяйства; технический заказчик и приемщик — агроном. Агрохолдинги — вторичный сегмент для пиков нагрузки и сложных участков, а не якорь первого сезона.</a:t>
+              <a:t>[ДОПУЩЕНИЕ] TAM охватывает всю Россию и все категории хозяйств, включая вторичный сегмент агрохолдингов. Это потенциальный выручечный рынок двух услуг — внесения и отдельного мониторинга, не рынок продажи БВС и не наблюдаемая выручка подрядчиков. География SAM — доступный кластер Татарстана до 150 км; SOM — первый сезон одной бригады. SAM вложен в национальный TAM; доступность каждого поля подтверждается отдельно.</a:t>
             </a:r>
           </a:p>
           <a:p/>
           <a:p>
             <a:r>
-              <a:t>### TAM SAM SOM и проверка расчета</a:t>
+              <a:t>[ФАКТ] Агроэксперт со ссылкой на весенний учет Росстата сообщает 79 298 млн га посевов в хозяйствах всех категорий РФ за 2025 год.[33] Использован весь общероссийский опубликованный итог, не сумма регионов и не произвольные 2000 хозяйств. Первичная таблица Росстата построчно не извлечена; статистическое основание подтверждено вторичной публикацией.</a:t>
             </a:r>
           </a:p>
           <a:p/>
           <a:p>
             <a:r>
-              <a:t>Рынок проекта — платные услуги агродронов по внесению и мониторингу для КФХ и малых/средних хозяйств. Оценка — годовая, в ценах 2027 года, без НДС, препаратов клиента и продажи дронов. TAM — потенциальный спрос выбранного сегмента РФ; SAM — его доступная часть в кластере Татарстана до 150 км; SOM — объем, который одна бригада планирует продать и выполнить в первом сезоне. SAM вложен в TAM. Доступность требует проверки конкретного поля.</a:t>
+              <a:t>[ДОПУЩЕНИЕ] Потенциальная пригодность 15%, 1,5 платных прохода внесения и 0,5 оплачиваемого обследования в сезон; тарифы 1300 и 250 руб. в ценах 2027 без НДС. Пригодность включает техническую, агрономическую и правовую возможность как сценарный фильтр, но не означает выданного допуска на 15% России. Это не подтвержденный коэффициент принятия услуги клиентами.</a:t>
             </a:r>
           </a:p>
           <a:p/>
           <a:p>
             <a:r>
-              <a:t>[ДОПУЩЕНИЕ] База 2000 хозяйств РФ и 200 хозяйств кластера, средняя площадь 2000 га, пригодность 15%, 1,5 прохода внесения и 0,5 обследования на пригодный гектар — параметры сценария. Список хозяйств и пригодность не подтверждены. Поэтому эти результаты называются сценарной емкостью выбранного сегмента, а не установленной емкостью всей России. До адресного реестра точность 1,245 млрд руб. арифметическая, а не статистическая.</a:t>
+              <a:t>[РАСЧЕТ] TAM = 79 298 000 × 0,15 × (1,5 × 1300 + 0,5 × 250) = 24 681 502 500 руб./год. Операции: 17 842 050 га-проходов и 5 947 350 га-обследований; не складывать как уникальные гектары.</a:t>
             </a:r>
           </a:p>
           <a:p/>
           <a:p>
             <a:r>
-              <a:t>[РАСЧЕТ] Пригодная площадь = число хозяйств × средняя площадь × доля пригодности. Внесение = пригодная площадь × 1,5; мониторинг = пригодная площадь × 0,5. Емкость = внесение × 1300 + мониторинг × 250.</a:t>
+              <a:t>[РАСЧЕТ] SAM = 200 × 2000 × 0,15 × (1,5 × 1300 + 0,5 × 250) = 124 500 000 руб./год. 200 хозяйств и 2000 га на хозяйство — прежние неподтвержденные параметры кластера, не статистика Татарстана. Адресный список внутри 150 км пока отсутствует.</a:t>
             </a:r>
           </a:p>
           <a:p/>
           <a:p>
             <a:r>
-              <a:t>| Уровень | Хозяйства | Пригодная площадь, га | Внесение, га-проходы | Мониторинг, га-обследования | Емкость, руб./год |</a:t>
-            </a:r>
-          </a:p>
-          <a:p>
-            <a:r>
-              <a:t>|---|---:|---:|---:|---:|---:|</a:t>
-            </a:r>
-          </a:p>
-          <a:p>
-            <a:r>
-              <a:t>| TAM выбранного сегмента, сценарий | 2000 | 600000 | 900000 | 300000 | 1245000000 |</a:t>
-            </a:r>
-          </a:p>
-          <a:p>
-            <a:r>
-              <a:t>| SAM кластера, сценарий | 200 | 60000 | 90000 | 30000 | 124500000 |</a:t>
-            </a:r>
-          </a:p>
-          <a:p>
-            <a:r>
-              <a:t>| SOM сезона 2027, цель | 10 | Не суммируется по услугам | 6000 | 4000 | 8800000 |</a:t>
+              <a:t>[РАСЧЕТ] SOM = 6000 × 1300 + 4000 × 250 = 8 800 000 руб./год; цель 10 клиентов. По внесению SOM/SAM = 6000/90000 = 6,67%; по обследованиям 4000/30000 = 13,33%; по выручке 7,07%. Разный микс объясняет разные проценты. Это сценарные доли цели, не фактическая доля AgroVector. Альтернативный микс SAM: мониторинг 2000, выручка 8,3 млн; не подмена базы 8,8 млн.</a:t>
             </a:r>
           </a:p>
           <a:p/>
           <a:p>
             <a:r>
-              <a:t>[РАСЧЕТ] TAM = 2000 × 2000 × 0,15 × (1,5 × 1300 + 0,5 × 250). SAM использует ту же формулу для 200 хозяйств. SOM = 6000 × 1300 + 4000 × 250 = 7,8 млн + 1,0 млн = 8,8 млн руб. Средние 600 га-проходов на каждого из 10 клиентов относятся к внесению; 400 га-обследований на клиента — отдельная целевая услуга, если все 10 заказывают мониторинг.</a:t>
+              <a:t>[РАСЧЕТ] Чувствительность TAM при пригодности 10/15/20%: 16 454 335 000 / 24 681 502 500 / 32 908 670 000 руб. Коэффициенты не доверительные интервалы. Нужны адресные поля, культура, операция, кратность, допуск и готовность платить. Не все посевы станут рынком услуг.</a:t>
             </a:r>
           </a:p>
           <a:p/>
           <a:p>
             <a:r>
-              <a:t>| Доля SOM в SAM | Расчет | Результат |</a:t>
-            </a:r>
-          </a:p>
-          <a:p>
-            <a:r>
-              <a:t>|---|---|---:|</a:t>
-            </a:r>
-          </a:p>
-          <a:p>
-            <a:r>
-              <a:t>| По внесению | 6000 / 90000 × 100% | 6,67% |</a:t>
-            </a:r>
-          </a:p>
-          <a:p>
-            <a:r>
-              <a:t>| По мониторингу | 4000 / 30000 × 100% | 13,33% |</a:t>
-            </a:r>
-          </a:p>
-          <a:p>
-            <a:r>
-              <a:t>| По выручке двух услуг | 8800000 / 124500000 × 100% | 7,07% |</a:t>
+              <a:t>[ДОПУЩЕНИЕ] Выход на рынок: 100 адресных контактов → 40 квалифицированных разговоров → 20 предложений → 10 сезонных клиентов. 20 интервью SMART — исследование, а не автоматические предложения или продажи. Маркетинг 240000 руб. в постоянномOPEX, денежныйCAC24000 руб. при 10 клиентах без распределения зарплаты директора. Заказ внесения от 100 га-проходов,30%аванс, остаток после акта; кассовая модель на аванс не опирается. Препараты клиента; приемка по паспорту поля, качество и сроки пилота без обещания роста урожая.</a:t>
             </a:r>
           </a:p>
           <a:p/>
           <a:p>
             <a:r>
-              <a:t>Основной SOM: 6 000 га-проходов и 4 000 га-обследований. Отношение обследований к проходам 0,667 против 0,333 в SAM. Дополнительный спрос на мониторинг подтверждается отдельно; поэтому денежная доля 7,07% не равна доле по внесению 6,67%.</a:t>
+              <a:t>[ДОПУЩЕНИЕ] Национальный потенциал не увеличивает мощность нашей бригады и не компенсирует отрицательный NPV новой зарплатной базы. Подтвержденных заказов нет. Файлы расчета: data/market_revision.json и scripts/register_reference_sources.py.</a:t>
             </a:r>
           </a:p>
           <a:p/>
           <a:p>
             <a:r>
-              <a:t>### Альтернативный микс — не базовая выручка</a:t>
+              <a:t>### Наблюдаемая отрасль и динамика (снимок проверки 20.10.2026)</a:t>
             </a:r>
           </a:p>
           <a:p/>
           <a:p>
             <a:r>
-              <a:t>При среднем миксе SAM мониторинг составил бы 2 000 обследований, выручка — 8,3 млн руб., денежная доля — 6,67%. Это отдельный тест гипотезы, не замена 8,8 млн в финансовой базе. Снижение мониторинга на 2 000 обследований уменьшает денежный вклад 2027 после УСН на 350 000 руб. при неизменных фиксированных расходах.</a:t>
+              <a:t>[ФАКТ] Министр сельского хозяйства сообщила об около 600 тыс.га полей, обработанных агродронами в 2025 году.[8] РСХБ в публикации 16.07.2026 приводит 781 тыс.га за 2025 год и прогноз 1058 тыс.га на 2026 год.[9]</a:t>
             </a:r>
           </a:p>
           <a:p/>
           <a:p>
             <a:r>
-              <a:t>[РАСЧЕТ] Ограничение мощности: 6000 / 130 + 4000 / 500 = 54,15 полевых дня при плановых производительностях проекта. Это ниже потолка 120 дней, однако пики агрономических окон, погода, транспорт и отдых могут ограничить загрузку. SOM проверяется одновременно по договорам, кадрам и календарю. Резервный борт не создает вторую бригаду.</a:t>
+              <a:t>[ДОПУЩЕНИЕ] Источники расходятся по 2025 году; охват и правила учета проходов недостаточно раскрыты. Их нельзя объединять в один ряд или выдавать прогноз 2026 за выполненные работы. Сопоставимый первичный национальный итог 2024 не подтвержден. Площади включают не только внешние платные услуги, поэтому умножение отраслевой площади на наш тариф не является доказанным объемом сервисного рынка. Приведенный выше TAM — сценарная будущая корзина, а не текущая платная выручка отрасли.</a:t>
             </a:r>
           </a:p>
           <a:p/>
           <a:p>
             <a:r>
-              <a:t>### Чувствительность сценарной емкости</a:t>
-            </a:r>
-          </a:p>
-          <a:p/>
-          <a:p>
-            <a:r>
-              <a:t>При прежних числе хозяйств, площади, частоте и тарифах меняется только пригодность. Диапазон не является доверительным интервалом.</a:t>
-            </a:r>
-          </a:p>
-          <a:p/>
-          <a:p>
-            <a:r>
-              <a:t>| Пригодность | TAM, руб./год | SAM, руб./год | Цель SOM / SAM |</a:t>
-            </a:r>
-          </a:p>
-          <a:p>
-            <a:r>
-              <a:t>|---|---:|---:|---:|</a:t>
-            </a:r>
-          </a:p>
-          <a:p>
-            <a:r>
-              <a:t>| 10% | 830000000 | 83000000 | 10,60% |</a:t>
-            </a:r>
-          </a:p>
-          <a:p>
-            <a:r>
-              <a:t>| 15%, база | 1245000000 | 124500000 | 7,07% |</a:t>
-            </a:r>
-          </a:p>
-          <a:p>
-            <a:r>
-              <a:t>| 20% | 1660000000 | 166000000 | 5,30% |</a:t>
-            </a:r>
-          </a:p>
-          <a:p/>
-          <a:p>
-            <a:r>
-              <a:t>Для подтверждения оценки нужны адресный список хозяйств, площадь и культуры по каждому клиенту, агрономически подходящие операции, доступность участков, частота заказов и готовность оплатить тариф. Национальная площадь обработок не подменяет выручку подрядчиков и не служит знаменателем региональных долей.</a:t>
-            </a:r>
-          </a:p>
-          <a:p/>
-          <a:p>
-            <a:r>
-              <a:t>### Выход на рынок</a:t>
-            </a:r>
-          </a:p>
-          <a:p/>
-          <a:p>
-            <a:r>
-              <a:t>[ДОПУЩЕНИЕ] Каналы: прямые продажи через агрономов, партнеры по биопрепаратам и удобрениям, фермерские объединения, демонстрации на поле и рекомендации. Плановая воронка: 100 адресных контактов → 40 квалифицированных разговоров → 20 квалифицированных предложений → 10 сезонных клиентов. Ни одно соглашение пока не подписано. Предварительное интервью не считается продажей.</a:t>
-            </a:r>
-          </a:p>
-          <a:p/>
-          <a:p>
-            <a:r>
-              <a:t>[ДОПУЩЕНИЕ] Годовой маркетинговый бюджет 240000 руб. входит в постоянный OPEX. Денежный CAC при 10 новых клиентах — 24000 руб. без распределения зарплаты директора; это не fully-loaded CAC. Средняя выручка на клиента в первом сезоне — 880000 руб. при условном распределении всех услуг между десятью клиентами. Агрономические консультации, дорога в согласованном радиусе и отчет включены; дальний выезд и малый участок требуют отдельной сметы и не заложены как дополнительная выручка.</a:t>
-            </a:r>
-          </a:p>
-          <a:p/>
-          <a:p>
-            <a:r>
-              <a:t>[ДОПУЩЕНИЕ] Коммерческие условия: минимальный планируемый маршрут 100 га-проходов, 30% аванс, остаток после акта; модель ликвидности консервативно не опирается на аванс. Ценность проверяется на сопоставимых контрольных участках: сроки, площадь, качество покрытия, повреждение колеи, расход состава. Процент экономии СЗР и прирост урожая до испытаний не обещаются.</a:t>
-            </a:r>
-          </a:p>
-          <a:p/>
-          <a:p>
-            <a:r>
-              <a:t>[ДОПУЩЕНИЕ] Контроль спроса: если к решению о закупке нет подтвержденного доступного портфеля на 6000 га-проходов, капиталоемкий запуск переносится; допускается отдельный малый пилот через законного оператора. Его экономика не подменяет базовую модель собственной бригады.</a:t>
-            </a:r>
-          </a:p>
-          <a:p/>
-          <a:p>
-            <a:r>
-              <a:t>### Наблюдаемая отрасль и динамика</a:t>
-            </a:r>
-          </a:p>
-          <a:p/>
-          <a:p>
-            <a:r>
-              <a:t>[ФАКТ] Министр сельского хозяйства сообщила об около 600 тыс.га полей, обработанных агродронами в 2025 году.[8] РСХБ в публикации 16.07.2026 приводит 781 тыс.га за 2025 год и прогноз 1058 тыс.га на 2026 год.[9]</a:t>
-            </a:r>
-          </a:p>
-          <a:p/>
-          <a:p>
-            <a:r>
-              <a:t>[ДОПУЩЕНИЕ] Источники расходятся по 2025 году; охват и правила учета проходов недостаточно раскрыты. Их нельзя объединять в один ряд или выдавать прогноз 2026 за выполненные работы. Сопоставимый первичный национальный итог 2024 не подтвержден. Площади включают не только внешние платные услуги, поэтому умножение отраслевой площади на наш тариф не является доказанным объемом сервисного рынка. Приведенный выше TAM — сценарная будущая корзина, а не текущая платная выручка отрасли.</a:t>
-            </a:r>
-          </a:p>
-          <a:p/>
-          <a:p>
-            <a:r>
               <a:t>[РАСЧЕТ] Внутри оценки РСХБ прогнозный рост 2026 к 2025 составляет 35,47% (1058/781−1), но этот темп не переносится на финансовую модель АгроВектора: ее выручку определяют собственные гектары, тариф и мощность. Плановый средний CAC24000 руб. и выручка 880000 руб. на клиента рассчитаны как 240000/10 и 8800000/10 соответственно.</a:t>
-            </a:r>
-          </a:p>
-          <a:p/>
-          <a:p>
-            <a:r>
-              <a:t>[ДОПУЩЕНИЕ] Основная база — 6 000 га-проходов и 4 000 га-обследований, 8,8 млн руб. Альтернативные 8,3 млн — только тест среднего микса SAM, а не исправленная выручка базы. Требуются отдельные заявки на мониторинг; его спрос нельзя выводить из числа проходов внесения.</a:t>
-            </a:r>
-          </a:p>
-          <a:p/>
-          <a:p>
-            <a:r>
-              <a:t>[ДОПУЩЕНИЕ] Двадцать интервью SMART — исследование спроса; двадцать предложений воронки — отдельная стадия, не автоматическое следствие интервью. Заявки должны раскрывать клиентов, культуры, контуры полей, обе услуги, кратность, цену и агрономическое окно. Предварительная заявка не равна обязательному договору. Подтвержденных заказов нет.</a:t>
             </a:r>
           </a:p>
           <a:p/>
@@ -4667,6 +4529,18 @@
           <a:p/>
           <a:p>
             <a:r>
+              <a:t>### Примерные цены аналогичных компаний</a:t>
+            </a:r>
+          </a:p>
+          <a:p/>
+          <a:p>
+            <a:r>
+              <a:t>[ФАКТ] Агродроны ЮФО публикуют цену обработки от 900 руб./га.[36] НДС и полный состав цены не раскрыты. ООО«Купец» в авторской публикации 07.05.2025 приводит диапазон 1200–1500 руб./га сНДС.[37] Это не текущая оферта, не прайсТатарстана и не независимая медиана. У Агропрофи/XAG, Аграс и BeeUAV числовые тарифы услуг в проверенном наборе не раскрыты; цена аппарата не используется вместо цены обработки. ПланAgroVector1300/250 не объявляется доказанным рыночным средним; по мониторингу нужен отдельный запросКП.</a:t>
+            </a:r>
+          </a:p>
+          <a:p/>
+          <a:p>
+            <a:r>
               <a:t>Комментарий к слайду:</a:t>
             </a:r>
           </a:p>
@@ -4777,85 +4651,33 @@
           <a:lstStyle/>
           <a:p>
             <a:r>
-              <a:t>[ДОПУЩЕНИЕ] SWOT отражает внутреннюю конструкцию проекта и сценарии внешней среды, а не доказанные преимущества действующей компании.</a:t>
+              <a:t>[ДОПУЩЕНИЕ] Полный перекрестный SWOT/TOWS по референсу, слайды 35–38 и фото 2. Сильные стороны — особенности проектной конструкции, не подтвержденные преимущества работающей компании. Возможности — гипотезы спроса, не статистика рынка.</a:t>
             </a:r>
           </a:p>
           <a:p/>
           <a:p>
             <a:r>
-              <a:t>| Группа | Фактор | Коммерческое последствие | Управленческое действие |</a:t>
-            </a:r>
-          </a:p>
-          <a:p>
-            <a:r>
-              <a:t>|---|---|---|---|</a:t>
-            </a:r>
-          </a:p>
-          <a:p>
-            <a:r>
-              <a:t>| S | Связка мониторинга, задания и отчета | Возможность продавать понятный результат | Единый паспорт заказа и критерии приемки |</a:t>
-            </a:r>
-          </a:p>
-          <a:p>
-            <a:r>
-              <a:t>| S | Резервный аппарат внесения | Снижение зависимости от единичного отказа | Проверять готовность резерва перед выездом |</a:t>
-            </a:r>
-          </a:p>
-          <a:p>
-            <a:r>
-              <a:t>| S | Компактная команда | Короткая цепочка согласования | Закрепить полномочия остановки работ |</a:t>
-            </a:r>
-          </a:p>
-          <a:p>
-            <a:r>
-              <a:t>| W | Отсутствие подтвержденного портфеля | Риск недозагрузки после закупки | Условное инвестиционное решение после проверки заявок |</a:t>
-            </a:r>
-          </a:p>
-          <a:p>
-            <a:r>
-              <a:t>| W | Одна бригада и совмещение ролей | Конфликты сроков и зависимость от людей | Единый календарь, ограничение принимаемых обязательств |</a:t>
-            </a:r>
-          </a:p>
-          <a:p>
-            <a:r>
-              <a:t>| W | Экономный фонд труда | Риск вакансий, текучести и перегрузки | Проверить предложения кандидатам до закупок |</a:t>
-            </a:r>
-          </a:p>
-          <a:p>
-            <a:r>
-              <a:t>| O | Неудовлетворенные локальные задачи клиентов | Возможность повторных заказов | Проверять проблему на конкретном поле |</a:t>
-            </a:r>
-          </a:p>
-          <a:p>
-            <a:r>
-              <a:t>| O | Гражданская переподготовка кандидатов с опытом БПЛА | Потенциальный кадровый канал | Добровольный отбор и обучение на равных условиях |</a:t>
-            </a:r>
-          </a:p>
-          <a:p>
-            <a:r>
-              <a:t>| T | Ограничения полетов и технологий | Невозможность исполнения части договоров | Юридический стоп-фактор и прозрачные условия переноса |</a:t>
-            </a:r>
-          </a:p>
-          <a:p>
-            <a:r>
-              <a:t>| T | Несовпадение погоды и агрономических окон | Потеря объемов без технической поломки | Приоритеты заданий, запас времени, отказ от перегруза |</a:t>
-            </a:r>
-          </a:p>
-          <a:p>
-            <a:r>
-              <a:t>| T | Ценовое давление или задержка оплаты | Снижение маржи и кассовый разрыв | Авансирование, проверка дебиторской задолженности |</a:t>
-            </a:r>
-          </a:p>
-          <a:p/>
-          <a:p>
-            <a:r>
-              <a:t>[ДОПУЩЕНИЕ] SO-стратегия — тестировать комплексное предложение на локальных задачах; WO — закрывать дефицит компетенций наставником и внешним агрономом. ST — использовать отчетность и технический резерв для управляемого исполнения. WT — не расширять парк и географию до подтверждения юридической доступности, кадров и фактической экономики сезона.</a:t>
-            </a:r>
-          </a:p>
-          <a:p/>
-          <a:p>
-            <a:r>
-              <a:t>[ДОПУЩЕНИЕ] Владельцы стратегий: директор проверяет спрос и тариф до D; операционный руководитель проверяет общий риск основного/резервного борта до G; агроном согласует применимость до каждого выезда. Совместимость АКБ, зарядок и сервиса может создавать общий отказ обоих бортов.</a:t>
+              <a:t>| Внутренняя / внешняя среда | Возможности O | Угрозы T |</a:t>
+            </a:r>
+          </a:p>
+          <a:p>
+            <a:r>
+              <a:t>|---|---|---|</a:t>
+            </a:r>
+          </a:p>
+          <a:p>
+            <a:r>
+              <a:t>| Факторы | O1: локальные задачи, для которых наземная обработка неудобна; O2: партнерство с агрономами и хозяйствами для платного пилота; O3: добровольная подготовка кандидатов с опытом БПЛА | T1: ограничения полетов и применимости препаратов; T2: погода, узкие окна и общие отказы оборудования; T3: ценовое давление и задержка платежей |</a:t>
+            </a:r>
+          </a:p>
+          <a:p>
+            <a:r>
+              <a:t>| Сильные стороны S: S1: спроектирован единый контур задания, карты и отчета; S2: предусмотрен резервный аппарат внесения; S3: короткая цепочка решений одной бригады | SO: S1+O1/O2: директор и агроном до закупки согласуют платный пилот и критерии приемки; метрика — подписанный паспорт задания и оплаченный пилот, без обещания урожайности. | ST: S2/S3+T1/T2: операционный руководитель перед каждым выездом проверяет допуски и резерв; no-go при нарушении. Метрика — 100% чек-листов и отсутствие неразрешенных заданий. |</a:t>
+            </a:r>
+          </a:p>
+          <a:p>
+            <a:r>
+              <a:t>| Слабые стороны W: W1: нет подтвержденных заказов и проведенного сезона; W2: одна бригада, совместные агроокна двух услуг; W3: парк и условия труда еще не подтверждены КП/кандидатами | WO: W1/W3+O2/O3: директор до финансирования получает КП, предложения кандидатам и договорный портфель; наставник оценивает обоих операторов. Метрика — документы и протоколы оценки, не число интервью. | WT: W2+T2/T3: директор ограничивает загрузку месячным календарем, согласует аванс и перенос; при неподтвержденной мощности отклоняет заказ. Метрика — отсутствие двойного бронирования и контроль кассового минимума. |</a:t>
             </a:r>
           </a:p>
           <a:p/>
@@ -4936,55 +4758,43 @@
           <a:lstStyle/>
           <a:p>
             <a:r>
-              <a:t>[ДОПУЩЕНИЕ] Пять сил Портера оцениваются сценарно; уровни не являются результатом измерения регионального рынка.</a:t>
+              <a:t>[ДОПУЩЕНИЕ] Сводная таблица пяти сил Портера в формате фото 3 и слайда 46 референса. Уровни качественные и подлежат проверке; не статистические измерения.</a:t>
             </a:r>
           </a:p>
           <a:p/>
           <a:p>
             <a:r>
-              <a:t>| Сила | Уровень гипотезы | Механизм воздействия | Ответ проекта | Что проверить |</a:t>
-            </a:r>
-          </a:p>
-          <a:p>
-            <a:r>
-              <a:t>|---|---|---|---|---|</a:t>
-            </a:r>
-          </a:p>
-          <a:p>
-            <a:r>
-              <a:t>| Конкуренция действующих исполнителей | Высокий | Сравнение тарифов и свободных окон | Продавать определенное задание, сроки и приемку | Сопоставимые предложения по одинаковому полю |</a:t>
-            </a:r>
-          </a:p>
-          <a:p>
-            <a:r>
-              <a:t>| Угроза новых участников | Средний | Появление дополнительной услуги у действующих подрядчиков | Развивать повторные договоры и дисциплину качества | Реальные сроки запуска и стоимость готовности |</a:t>
-            </a:r>
-          </a:p>
-          <a:p>
-            <a:r>
-              <a:t>| Угроза заменителей | Высокий | Наземная обработка, собственная техника, отказ от операции | Отбирать задачи, где клиент видит ценность сервиса | Полная стоимость и применимость альтернатив |</a:t>
-            </a:r>
-          </a:p>
-          <a:p>
-            <a:r>
-              <a:t>| Власть покупателей | Высокий | Сезонный торг и концентрация заказов | Разделять объемы по клиентам, фиксировать условия заранее | Концентрацию портфеля и причины отказов |</a:t>
-            </a:r>
-          </a:p>
-          <a:p>
-            <a:r>
-              <a:t>| Власть поставщиков | Средний–высокий | Зависимость от техники, аккумуляторов и ремонта | Резервный аппарат, запас критичных деталей, сервисный договор | Совместимость, гарантийные условия, сроки ремонта |</a:t>
-            </a:r>
-          </a:p>
-          <a:p/>
-          <a:p>
-            <a:r>
-              <a:t>[ДОПУЩЕНИЕ] Гипотеза зависит от повторного спроса и исполнения в сезонном окне. Устойчивое преимущество до полевой проверки не подтверждено.</a:t>
-            </a:r>
-          </a:p>
-          <a:p/>
-          <a:p>
-            <a:r>
-              <a:t>[ДОПУЩЕНИЕ] Барьеры входа включают капитал, подготовку людей, ремонт и разрешительную процедуру. Эти же барьеры ограничивают AgroVector, поэтому не считаются уже полученной защитой от новых игроков.</a:t>
+              <a:t>| Параметр | Значение | Описание | Направление работ |</a:t>
+            </a:r>
+          </a:p>
+          <a:p>
+            <a:r>
+              <a:t>|---|---|---|---|</a:t>
+            </a:r>
+          </a:p>
+          <a:p>
+            <a:r>
+              <a:t>| Заменители | Высокий | Наземная техника, свой БВС, отказ от операции | Сравнить полную стоимость и применимость на конкретном поле; не обещать превосходство повсеместно |</a:t>
+            </a:r>
+          </a:p>
+          <a:p>
+            <a:r>
+              <a:t>| Действующие конкуренты | Высокий | Клиент сравнивает тариф, состав работ и доступное окно | Собирать сопоставимые КП; фиксировать приемку и отчетность |</a:t>
+            </a:r>
+          </a:p>
+          <a:p>
+            <a:r>
+              <a:t>| Новые участники | Средний | Технику можно купить, но капитал, персонал и допуски ограничивают вход | Удерживать клиентов качеством и повторными договорами; мониторить новых исполнителей |</a:t>
+            </a:r>
+          </a:p>
+          <a:p>
+            <a:r>
+              <a:t>| Покупатели | Высокий | Сезонный торг, концентрация портфеля, отсрочки | Лимиты концентрации и дебиторки; согласованный аванс и календарь |</a:t>
+            </a:r>
+          </a:p>
+          <a:p>
+            <a:r>
+              <a:t>| Поставщики | Средний–высокий | АКБ, комплектующие, сервис и совместимость зависят от поставщика | Два КП, запас критичных деталей, сервисный SLA; резерв не устраняет общий отказ |</a:t>
             </a:r>
           </a:p>
           <a:p/>
@@ -8868,7 +8678,7 @@
               </a:defRPr>
             </a:pPr>
             <a:r>
-              <a:t>3,95</a:t>
+              <a:t>-1,07</a:t>
             </a:r>
           </a:p>
         </p:txBody>
@@ -11601,7 +11411,7 @@
               </a:defRPr>
             </a:pPr>
             <a:r>
-              <a:t>3,0 млн ₽ / год — бюджет штатного труда; требует проверки рынка и начислений</a:t>
+              <a:t>4.69 млн ₽ / год — полная стоимость работодателя; gross 3.60 млн ₽</a:t>
             </a:r>
           </a:p>
         </p:txBody>
@@ -19599,7 +19409,7 @@
                         </a:defRPr>
                       </a:pPr>
                       <a:r>
-                        <a:t>Оператор</a:t>
+                        <a:t>Второй оператор</a:t>
                       </a:r>
                     </a:p>
                   </a:txBody>
@@ -20010,7 +19820,7 @@
                         </a:defRPr>
                       </a:pPr>
                       <a:r>
-                        <a:t>Оператор</a:t>
+                        <a:t>Второй оператор</a:t>
                       </a:r>
                     </a:p>
                   </a:txBody>
@@ -20791,7 +20601,7 @@
                         </a:defRPr>
                       </a:pPr>
                       <a:r>
-                        <a:t>1,96</a:t>
+                        <a:t>0,27</a:t>
                       </a:r>
                     </a:p>
                   </a:txBody>
@@ -20818,7 +20628,7 @@
                         </a:defRPr>
                       </a:pPr>
                       <a:r>
-                        <a:t>1,43</a:t>
+                        <a:t>-0,26</a:t>
                       </a:r>
                     </a:p>
                   </a:txBody>
@@ -20901,7 +20711,7 @@
                         </a:defRPr>
                       </a:pPr>
                       <a:r>
-                        <a:t>5,16</a:t>
+                        <a:t>3,39</a:t>
                       </a:r>
                     </a:p>
                   </a:txBody>
@@ -20928,7 +20738,7 @@
                         </a:defRPr>
                       </a:pPr>
                       <a:r>
-                        <a:t>4,04</a:t>
+                        <a:t>2,26</a:t>
                       </a:r>
                     </a:p>
                   </a:txBody>
@@ -21011,7 +20821,7 @@
                         </a:defRPr>
                       </a:pPr>
                       <a:r>
-                        <a:t>7,62</a:t>
+                        <a:t>5,76</a:t>
                       </a:r>
                     </a:p>
                   </a:txBody>
@@ -21038,7 +20848,7 @@
                         </a:defRPr>
                       </a:pPr>
                       <a:r>
-                        <a:t>5,96</a:t>
+                        <a:t>4,10</a:t>
                       </a:r>
                     </a:p>
                   </a:txBody>
@@ -21121,7 +20931,7 @@
                         </a:defRPr>
                       </a:pPr>
                       <a:r>
-                        <a:t>9,04</a:t>
+                        <a:t>7,08</a:t>
                       </a:r>
                     </a:p>
                   </a:txBody>
@@ -21148,7 +20958,7 @@
                         </a:defRPr>
                       </a:pPr>
                       <a:r>
-                        <a:t>6,93</a:t>
+                        <a:t>4,98</a:t>
                       </a:r>
                     </a:p>
                   </a:txBody>
@@ -21231,7 +21041,7 @@
                         </a:defRPr>
                       </a:pPr>
                       <a:r>
-                        <a:t>10,54</a:t>
+                        <a:t>8,49</a:t>
                       </a:r>
                     </a:p>
                   </a:txBody>
@@ -21258,7 +21068,7 @@
                         </a:defRPr>
                       </a:pPr>
                       <a:r>
-                        <a:t>10,58</a:t>
+                        <a:t>8,53</a:t>
                       </a:r>
                     </a:p>
                   </a:txBody>
@@ -21863,7 +21673,7 @@
                         </a:defRPr>
                       </a:pPr>
                       <a:r>
-                        <a:t>3,946</a:t>
+                        <a:t>-1,068</a:t>
                       </a:r>
                     </a:p>
                   </a:txBody>
@@ -21919,7 +21729,7 @@
                         </a:defRPr>
                       </a:pPr>
                       <a:r>
-                        <a:t>0,045</a:t>
+                        <a:t>-4,969</a:t>
                       </a:r>
                     </a:p>
                   </a:txBody>
@@ -21975,7 +21785,7 @@
                         </a:defRPr>
                       </a:pPr>
                       <a:r>
-                        <a:t>-2,639</a:t>
+                        <a:t>-7,653</a:t>
                       </a:r>
                     </a:p>
                   </a:txBody>
@@ -22031,7 +21841,7 @@
                         </a:defRPr>
                       </a:pPr>
                       <a:r>
-                        <a:t>1,412</a:t>
+                        <a:t>-3,603</a:t>
                       </a:r>
                     </a:p>
                   </a:txBody>
@@ -22087,7 +21897,7 @@
                         </a:defRPr>
                       </a:pPr>
                       <a:r>
-                        <a:t>-1,433</a:t>
+                        <a:t>-5,086</a:t>
                       </a:r>
                     </a:p>
                   </a:txBody>
@@ -22143,7 +21953,7 @@
                         </a:defRPr>
                       </a:pPr>
                       <a:r>
-                        <a:t>-6,605</a:t>
+                        <a:t>-11,619</a:t>
                       </a:r>
                     </a:p>
                   </a:txBody>
@@ -22195,7 +22005,7 @@
               </a:defRPr>
             </a:pPr>
             <a:r>
-              <a:t>Окупаемость базы: 2,68 года</a:t>
+              <a:t>Окупаемость базы: 3,68 года</a:t>
             </a:r>
           </a:p>
           <a:p>
@@ -22214,7 +22024,7 @@
               </a:defRPr>
             </a:pPr>
             <a:r>
-              <a:t>Дисконтированная: 3,88 года</a:t>
+              <a:t>Дисконтированная: не достигнута за 5 лет</a:t>
             </a:r>
           </a:p>
         </p:txBody>
@@ -22301,7 +22111,7 @@
               </a:defRPr>
             </a:pPr>
             <a:r>
-              <a:t>Комбинированный стресс: NPV -7,55 млн ₽; цена −10%, объем −25%, CAPEX +1,98 млн</a:t>
+              <a:t>Комбинированный стресс: NPV -12,56 млн ₽; цена −10%, объем −25%, CAPEX +1,98 млн</a:t>
             </a:r>
           </a:p>
         </p:txBody>
@@ -25640,7 +25450,7 @@
               </a:defRPr>
             </a:pPr>
             <a:r>
-              <a:t>8,8 млн ₽</a:t>
+              <a:t>8.80 млн ₽</a:t>
             </a:r>
           </a:p>
         </p:txBody>
@@ -25724,7 +25534,7 @@
               </a:defRPr>
             </a:pPr>
             <a:r>
-              <a:t>6000 га-проходов + 4000 обследований</a:t>
+              <a:t>6 000 га-проходов + 4 000 обследований</a:t>
             </a:r>
           </a:p>
         </p:txBody>
@@ -25811,7 +25621,7 @@
               </a:defRPr>
             </a:pPr>
             <a:r>
-              <a:t>22,3%</a:t>
+              <a:t>3,1%</a:t>
             </a:r>
           </a:p>
         </p:txBody>
@@ -25982,7 +25792,7 @@
               </a:defRPr>
             </a:pPr>
             <a:r>
-              <a:t>1,432 млн ₽</a:t>
+              <a:t>-0.255 млн ₽</a:t>
             </a:r>
           </a:p>
         </p:txBody>
@@ -26153,7 +25963,7 @@
               </a:defRPr>
             </a:pPr>
             <a:r>
-              <a:t>13 000</a:t>
+              <a:t>6 000</a:t>
             </a:r>
           </a:p>
         </p:txBody>
@@ -26195,7 +26005,7 @@
               </a:defRPr>
             </a:pPr>
             <a:r>
-              <a:t>Потолок га-проходов</a:t>
+              <a:t>План га-проходов</a:t>
             </a:r>
           </a:p>
         </p:txBody>
@@ -26237,7 +26047,7 @@
               </a:defRPr>
             </a:pPr>
             <a:r>
-              <a:t>100 дней × 130 га; подтвердить пилотом</a:t>
+              <a:t>Объем из финансового сценария</a:t>
             </a:r>
           </a:p>
         </p:txBody>
@@ -28548,7 +28358,7 @@
               </a:defRPr>
             </a:pPr>
             <a:r>
-              <a:t>Business Model Canvas</a:t>
+              <a:t>Lean Canvas</a:t>
             </a:r>
           </a:p>
         </p:txBody>

</xml_diff>